<commit_message>
First sprint 6 planning meeting
</commit_message>
<xml_diff>
--- a/SE202526/Management/Scrum Board.pptx
+++ b/SE202526/Management/Scrum Board.pptx
@@ -5,7 +5,7 @@
     <p:sldMasterId id="2147483659" r:id="rId1"/>
   </p:sldMasterIdLst>
   <p:notesMasterIdLst>
-    <p:notesMasterId r:id="rId22"/>
+    <p:notesMasterId r:id="rId24"/>
   </p:notesMasterIdLst>
   <p:sldIdLst>
     <p:sldId id="256" r:id="rId2"/>
@@ -28,6 +28,8 @@
     <p:sldId id="275" r:id="rId19"/>
     <p:sldId id="276" r:id="rId20"/>
     <p:sldId id="277" r:id="rId21"/>
+    <p:sldId id="279" r:id="rId22"/>
+    <p:sldId id="280" r:id="rId23"/>
   </p:sldIdLst>
   <p:sldSz cx="21599525" cy="10799763"/>
   <p:notesSz cx="6858000" cy="9144000"/>
@@ -2316,6 +2318,260 @@
     <p:extLst>
       <p:ext uri="{BB962C8B-B14F-4D97-AF65-F5344CB8AC3E}">
         <p14:creationId xmlns:p14="http://schemas.microsoft.com/office/powerpoint/2010/main" val="604953558"/>
+      </p:ext>
+    </p:extLst>
+  </p:cSld>
+  <p:clrMapOvr>
+    <a:masterClrMapping/>
+  </p:clrMapOvr>
+</p:notes>
+</file>
+
+<file path=ppt/notesSlides/notesSlide21.xml><?xml version="1.0" encoding="utf-8"?>
+<p:notes xmlns:a="http://schemas.openxmlformats.org/drawingml/2006/main" xmlns:r="http://schemas.openxmlformats.org/officeDocument/2006/relationships" xmlns:p="http://schemas.openxmlformats.org/presentationml/2006/main" showMasterSp="0" showMasterPhAnim="0">
+  <p:cSld>
+    <p:spTree>
+      <p:nvGrpSpPr>
+        <p:cNvPr id="1" name="Shape 217">
+          <a:extLst>
+            <a:ext uri="{FF2B5EF4-FFF2-40B4-BE49-F238E27FC236}">
+              <a16:creationId xmlns:a16="http://schemas.microsoft.com/office/drawing/2014/main" id="{99B1618B-27A0-70CC-95C7-0E6DB7D4254C}"/>
+            </a:ext>
+          </a:extLst>
+        </p:cNvPr>
+        <p:cNvGrpSpPr/>
+        <p:nvPr/>
+      </p:nvGrpSpPr>
+      <p:grpSpPr>
+        <a:xfrm>
+          <a:off x="0" y="0"/>
+          <a:ext cx="0" cy="0"/>
+          <a:chOff x="0" y="0"/>
+          <a:chExt cx="0" cy="0"/>
+        </a:xfrm>
+      </p:grpSpPr>
+      <p:sp>
+        <p:nvSpPr>
+          <p:cNvPr id="218" name="Google Shape;218;g3850b307b58_0_258:notes">
+            <a:extLst>
+              <a:ext uri="{FF2B5EF4-FFF2-40B4-BE49-F238E27FC236}">
+                <a16:creationId xmlns:a16="http://schemas.microsoft.com/office/drawing/2014/main" id="{E6BF7EC5-11DB-C986-C818-2CC28240D3CF}"/>
+              </a:ext>
+            </a:extLst>
+          </p:cNvPr>
+          <p:cNvSpPr>
+            <a:spLocks noGrp="1" noRot="1" noChangeAspect="1"/>
+          </p:cNvSpPr>
+          <p:nvPr>
+            <p:ph type="sldImg" idx="2"/>
+          </p:nvPr>
+        </p:nvSpPr>
+        <p:spPr>
+          <a:xfrm>
+            <a:off x="0" y="685800"/>
+            <a:ext cx="6858000" cy="3429000"/>
+          </a:xfrm>
+          <a:custGeom>
+            <a:avLst/>
+            <a:gdLst/>
+            <a:ahLst/>
+            <a:cxnLst/>
+            <a:rect l="l" t="t" r="r" b="b"/>
+            <a:pathLst>
+              <a:path w="120000" h="120000" extrusionOk="0">
+                <a:moveTo>
+                  <a:pt x="0" y="0"/>
+                </a:moveTo>
+                <a:lnTo>
+                  <a:pt x="120000" y="0"/>
+                </a:lnTo>
+                <a:lnTo>
+                  <a:pt x="120000" y="120000"/>
+                </a:lnTo>
+                <a:lnTo>
+                  <a:pt x="0" y="120000"/>
+                </a:lnTo>
+                <a:close/>
+              </a:path>
+            </a:pathLst>
+          </a:custGeom>
+        </p:spPr>
+      </p:sp>
+      <p:sp>
+        <p:nvSpPr>
+          <p:cNvPr id="219" name="Google Shape;219;g3850b307b58_0_258:notes">
+            <a:extLst>
+              <a:ext uri="{FF2B5EF4-FFF2-40B4-BE49-F238E27FC236}">
+                <a16:creationId xmlns:a16="http://schemas.microsoft.com/office/drawing/2014/main" id="{6854550A-FCCF-5D83-8AC0-2422D0BDBBDA}"/>
+              </a:ext>
+            </a:extLst>
+          </p:cNvPr>
+          <p:cNvSpPr txBox="1">
+            <a:spLocks noGrp="1"/>
+          </p:cNvSpPr>
+          <p:nvPr>
+            <p:ph type="body" idx="1"/>
+          </p:nvPr>
+        </p:nvSpPr>
+        <p:spPr>
+          <a:xfrm>
+            <a:off x="685800" y="4343400"/>
+            <a:ext cx="5486400" cy="4114800"/>
+          </a:xfrm>
+          <a:prstGeom prst="rect">
+            <a:avLst/>
+          </a:prstGeom>
+        </p:spPr>
+        <p:txBody>
+          <a:bodyPr spcFirstLastPara="1" wrap="square" lIns="91425" tIns="91425" rIns="91425" bIns="91425" anchor="t" anchorCtr="0">
+            <a:noAutofit/>
+          </a:bodyPr>
+          <a:lstStyle/>
+          <a:p>
+            <a:pPr marL="0" lvl="0" indent="0" algn="l" rtl="0">
+              <a:spcBef>
+                <a:spcPts val="0"/>
+              </a:spcBef>
+              <a:spcAft>
+                <a:spcPts val="0"/>
+              </a:spcAft>
+              <a:buNone/>
+            </a:pPr>
+            <a:endParaRPr/>
+          </a:p>
+        </p:txBody>
+      </p:sp>
+    </p:spTree>
+    <p:extLst>
+      <p:ext uri="{BB962C8B-B14F-4D97-AF65-F5344CB8AC3E}">
+        <p14:creationId xmlns:p14="http://schemas.microsoft.com/office/powerpoint/2010/main" val="3628573967"/>
+      </p:ext>
+    </p:extLst>
+  </p:cSld>
+  <p:clrMapOvr>
+    <a:masterClrMapping/>
+  </p:clrMapOvr>
+</p:notes>
+</file>
+
+<file path=ppt/notesSlides/notesSlide22.xml><?xml version="1.0" encoding="utf-8"?>
+<p:notes xmlns:a="http://schemas.openxmlformats.org/drawingml/2006/main" xmlns:r="http://schemas.openxmlformats.org/officeDocument/2006/relationships" xmlns:p="http://schemas.openxmlformats.org/presentationml/2006/main" showMasterSp="0" showMasterPhAnim="0">
+  <p:cSld>
+    <p:spTree>
+      <p:nvGrpSpPr>
+        <p:cNvPr id="1" name="Shape 186">
+          <a:extLst>
+            <a:ext uri="{FF2B5EF4-FFF2-40B4-BE49-F238E27FC236}">
+              <a16:creationId xmlns:a16="http://schemas.microsoft.com/office/drawing/2014/main" id="{E3B6E81E-3FBB-A8B8-B886-C0DE1288F7B6}"/>
+            </a:ext>
+          </a:extLst>
+        </p:cNvPr>
+        <p:cNvGrpSpPr/>
+        <p:nvPr/>
+      </p:nvGrpSpPr>
+      <p:grpSpPr>
+        <a:xfrm>
+          <a:off x="0" y="0"/>
+          <a:ext cx="0" cy="0"/>
+          <a:chOff x="0" y="0"/>
+          <a:chExt cx="0" cy="0"/>
+        </a:xfrm>
+      </p:grpSpPr>
+      <p:sp>
+        <p:nvSpPr>
+          <p:cNvPr id="187" name="Google Shape;187;g3850b307b58_0_218:notes">
+            <a:extLst>
+              <a:ext uri="{FF2B5EF4-FFF2-40B4-BE49-F238E27FC236}">
+                <a16:creationId xmlns:a16="http://schemas.microsoft.com/office/drawing/2014/main" id="{47E5CEE2-BC08-07F4-11B2-A005DBA96694}"/>
+              </a:ext>
+            </a:extLst>
+          </p:cNvPr>
+          <p:cNvSpPr>
+            <a:spLocks noGrp="1" noRot="1" noChangeAspect="1"/>
+          </p:cNvSpPr>
+          <p:nvPr>
+            <p:ph type="sldImg" idx="2"/>
+          </p:nvPr>
+        </p:nvSpPr>
+        <p:spPr>
+          <a:xfrm>
+            <a:off x="0" y="685800"/>
+            <a:ext cx="6858000" cy="3429000"/>
+          </a:xfrm>
+          <a:custGeom>
+            <a:avLst/>
+            <a:gdLst/>
+            <a:ahLst/>
+            <a:cxnLst/>
+            <a:rect l="l" t="t" r="r" b="b"/>
+            <a:pathLst>
+              <a:path w="120000" h="120000" extrusionOk="0">
+                <a:moveTo>
+                  <a:pt x="0" y="0"/>
+                </a:moveTo>
+                <a:lnTo>
+                  <a:pt x="120000" y="0"/>
+                </a:lnTo>
+                <a:lnTo>
+                  <a:pt x="120000" y="120000"/>
+                </a:lnTo>
+                <a:lnTo>
+                  <a:pt x="0" y="120000"/>
+                </a:lnTo>
+                <a:close/>
+              </a:path>
+            </a:pathLst>
+          </a:custGeom>
+        </p:spPr>
+      </p:sp>
+      <p:sp>
+        <p:nvSpPr>
+          <p:cNvPr id="188" name="Google Shape;188;g3850b307b58_0_218:notes">
+            <a:extLst>
+              <a:ext uri="{FF2B5EF4-FFF2-40B4-BE49-F238E27FC236}">
+                <a16:creationId xmlns:a16="http://schemas.microsoft.com/office/drawing/2014/main" id="{400FB9EA-44A4-A59D-B720-8FE2508A4D49}"/>
+              </a:ext>
+            </a:extLst>
+          </p:cNvPr>
+          <p:cNvSpPr txBox="1">
+            <a:spLocks noGrp="1"/>
+          </p:cNvSpPr>
+          <p:nvPr>
+            <p:ph type="body" idx="1"/>
+          </p:nvPr>
+        </p:nvSpPr>
+        <p:spPr>
+          <a:xfrm>
+            <a:off x="685800" y="4343400"/>
+            <a:ext cx="5486400" cy="4114800"/>
+          </a:xfrm>
+          <a:prstGeom prst="rect">
+            <a:avLst/>
+          </a:prstGeom>
+        </p:spPr>
+        <p:txBody>
+          <a:bodyPr spcFirstLastPara="1" wrap="square" lIns="91425" tIns="91425" rIns="91425" bIns="91425" anchor="t" anchorCtr="0">
+            <a:noAutofit/>
+          </a:bodyPr>
+          <a:lstStyle/>
+          <a:p>
+            <a:pPr marL="0" lvl="0" indent="0" algn="l" rtl="0">
+              <a:spcBef>
+                <a:spcPts val="0"/>
+              </a:spcBef>
+              <a:spcAft>
+                <a:spcPts val="0"/>
+              </a:spcAft>
+              <a:buNone/>
+            </a:pPr>
+            <a:endParaRPr/>
+          </a:p>
+        </p:txBody>
+      </p:sp>
+    </p:spTree>
+    <p:extLst>
+      <p:ext uri="{BB962C8B-B14F-4D97-AF65-F5344CB8AC3E}">
+        <p14:creationId xmlns:p14="http://schemas.microsoft.com/office/powerpoint/2010/main" val="2467119470"/>
       </p:ext>
     </p:extLst>
   </p:cSld>
@@ -28946,6 +29202,2919 @@
 </p:sld>
 </file>
 
+<file path=ppt/slides/slide21.xml><?xml version="1.0" encoding="utf-8"?>
+<p:sld xmlns:a="http://schemas.openxmlformats.org/drawingml/2006/main" xmlns:r="http://schemas.openxmlformats.org/officeDocument/2006/relationships" xmlns:p="http://schemas.openxmlformats.org/presentationml/2006/main">
+  <p:cSld>
+    <p:spTree>
+      <p:nvGrpSpPr>
+        <p:cNvPr id="1" name="Shape 220">
+          <a:extLst>
+            <a:ext uri="{FF2B5EF4-FFF2-40B4-BE49-F238E27FC236}">
+              <a16:creationId xmlns:a16="http://schemas.microsoft.com/office/drawing/2014/main" id="{98A453F8-ECD9-7141-CDD6-109E3B8BEED1}"/>
+            </a:ext>
+          </a:extLst>
+        </p:cNvPr>
+        <p:cNvGrpSpPr/>
+        <p:nvPr/>
+      </p:nvGrpSpPr>
+      <p:grpSpPr>
+        <a:xfrm>
+          <a:off x="0" y="0"/>
+          <a:ext cx="0" cy="0"/>
+          <a:chOff x="0" y="0"/>
+          <a:chExt cx="0" cy="0"/>
+        </a:xfrm>
+      </p:grpSpPr>
+      <p:pic>
+        <p:nvPicPr>
+          <p:cNvPr id="221" name="Google Shape;221;p20" title="Vmw_I2.png">
+            <a:extLst>
+              <a:ext uri="{FF2B5EF4-FFF2-40B4-BE49-F238E27FC236}">
+                <a16:creationId xmlns:a16="http://schemas.microsoft.com/office/drawing/2014/main" id="{85D624E0-D4E0-CC9A-3DD9-A4597601F9FE}"/>
+              </a:ext>
+            </a:extLst>
+          </p:cNvPr>
+          <p:cNvPicPr preferRelativeResize="0"/>
+          <p:nvPr/>
+        </p:nvPicPr>
+        <p:blipFill>
+          <a:blip r:embed="rId3">
+            <a:alphaModFix amt="51000"/>
+          </a:blip>
+          <a:stretch>
+            <a:fillRect/>
+          </a:stretch>
+        </p:blipFill>
+        <p:spPr>
+          <a:xfrm>
+            <a:off x="0" y="0"/>
+            <a:ext cx="21600000" cy="10800000"/>
+          </a:xfrm>
+          <a:prstGeom prst="rect">
+            <a:avLst/>
+          </a:prstGeom>
+          <a:noFill/>
+          <a:ln>
+            <a:noFill/>
+          </a:ln>
+        </p:spPr>
+      </p:pic>
+      <p:sp>
+        <p:nvSpPr>
+          <p:cNvPr id="222" name="Google Shape;222;p20">
+            <a:extLst>
+              <a:ext uri="{FF2B5EF4-FFF2-40B4-BE49-F238E27FC236}">
+                <a16:creationId xmlns:a16="http://schemas.microsoft.com/office/drawing/2014/main" id="{9C56FCB9-BF84-7C9F-90D9-4FBBF200DCBC}"/>
+              </a:ext>
+            </a:extLst>
+          </p:cNvPr>
+          <p:cNvSpPr/>
+          <p:nvPr/>
+        </p:nvSpPr>
+        <p:spPr>
+          <a:xfrm>
+            <a:off x="814250" y="3300663"/>
+            <a:ext cx="19957567" cy="4198675"/>
+          </a:xfrm>
+          <a:prstGeom prst="rect">
+            <a:avLst/>
+          </a:prstGeom>
+        </p:spPr>
+        <p:txBody>
+          <a:bodyPr>
+            <a:prstTxWarp prst="textPlain">
+              <a:avLst/>
+            </a:prstTxWarp>
+          </a:bodyPr>
+          <a:lstStyle/>
+          <a:p>
+            <a:pPr lvl="0" algn="ctr"/>
+            <a:r>
+              <a:rPr b="1" i="0" dirty="0">
+                <a:ln w="114300" cap="flat" cmpd="sng">
+                  <a:solidFill>
+                    <a:srgbClr val="434343"/>
+                  </a:solidFill>
+                  <a:prstDash val="solid"/>
+                  <a:round/>
+                  <a:headEnd type="none" w="sm" len="sm"/>
+                  <a:tailEnd type="none" w="sm" len="sm"/>
+                </a:ln>
+                <a:solidFill>
+                  <a:schemeClr val="lt1"/>
+                </a:solidFill>
+                <a:latin typeface="Consolas"/>
+              </a:rPr>
+              <a:t>Sprint </a:t>
+            </a:r>
+            <a:r>
+              <a:rPr lang="pt-PT" b="1" dirty="0">
+                <a:ln w="114300" cap="flat" cmpd="sng">
+                  <a:solidFill>
+                    <a:srgbClr val="434343"/>
+                  </a:solidFill>
+                  <a:prstDash val="solid"/>
+                  <a:round/>
+                  <a:headEnd type="none" w="sm" len="sm"/>
+                  <a:tailEnd type="none" w="sm" len="sm"/>
+                </a:ln>
+                <a:solidFill>
+                  <a:schemeClr val="lt1"/>
+                </a:solidFill>
+                <a:latin typeface="Consolas"/>
+              </a:rPr>
+              <a:t>6</a:t>
+            </a:r>
+            <a:endParaRPr b="1" i="0" dirty="0">
+              <a:ln w="114300" cap="flat" cmpd="sng">
+                <a:solidFill>
+                  <a:srgbClr val="434343"/>
+                </a:solidFill>
+                <a:prstDash val="solid"/>
+                <a:round/>
+                <a:headEnd type="none" w="sm" len="sm"/>
+                <a:tailEnd type="none" w="sm" len="sm"/>
+              </a:ln>
+              <a:solidFill>
+                <a:schemeClr val="lt1"/>
+              </a:solidFill>
+              <a:latin typeface="Consolas"/>
+            </a:endParaRPr>
+          </a:p>
+        </p:txBody>
+      </p:sp>
+    </p:spTree>
+    <p:extLst>
+      <p:ext uri="{BB962C8B-B14F-4D97-AF65-F5344CB8AC3E}">
+        <p14:creationId xmlns:p14="http://schemas.microsoft.com/office/powerpoint/2010/main" val="2449578432"/>
+      </p:ext>
+    </p:extLst>
+  </p:cSld>
+  <p:clrMapOvr>
+    <a:masterClrMapping/>
+  </p:clrMapOvr>
+</p:sld>
+</file>
+
+<file path=ppt/slides/slide22.xml><?xml version="1.0" encoding="utf-8"?>
+<p:sld xmlns:a="http://schemas.openxmlformats.org/drawingml/2006/main" xmlns:r="http://schemas.openxmlformats.org/officeDocument/2006/relationships" xmlns:p="http://schemas.openxmlformats.org/presentationml/2006/main">
+  <p:cSld>
+    <p:spTree>
+      <p:nvGrpSpPr>
+        <p:cNvPr id="1" name="Shape 189">
+          <a:extLst>
+            <a:ext uri="{FF2B5EF4-FFF2-40B4-BE49-F238E27FC236}">
+              <a16:creationId xmlns:a16="http://schemas.microsoft.com/office/drawing/2014/main" id="{988A0C36-91A8-424E-47D0-C9FFA7AA8526}"/>
+            </a:ext>
+          </a:extLst>
+        </p:cNvPr>
+        <p:cNvGrpSpPr/>
+        <p:nvPr/>
+      </p:nvGrpSpPr>
+      <p:grpSpPr>
+        <a:xfrm>
+          <a:off x="0" y="0"/>
+          <a:ext cx="0" cy="0"/>
+          <a:chOff x="0" y="0"/>
+          <a:chExt cx="0" cy="0"/>
+        </a:xfrm>
+      </p:grpSpPr>
+      <p:cxnSp>
+        <p:nvCxnSpPr>
+          <p:cNvPr id="190" name="Google Shape;190;p19">
+            <a:extLst>
+              <a:ext uri="{FF2B5EF4-FFF2-40B4-BE49-F238E27FC236}">
+                <a16:creationId xmlns:a16="http://schemas.microsoft.com/office/drawing/2014/main" id="{A77EDF78-783E-1055-3E26-0C71D312180F}"/>
+              </a:ext>
+            </a:extLst>
+          </p:cNvPr>
+          <p:cNvCxnSpPr/>
+          <p:nvPr/>
+        </p:nvCxnSpPr>
+        <p:spPr>
+          <a:xfrm>
+            <a:off x="5944724" y="-31500"/>
+            <a:ext cx="0" cy="10857000"/>
+          </a:xfrm>
+          <a:prstGeom prst="straightConnector1">
+            <a:avLst/>
+          </a:prstGeom>
+          <a:noFill/>
+          <a:ln w="38100" cap="flat" cmpd="sng">
+            <a:solidFill>
+              <a:srgbClr val="5B0F00"/>
+            </a:solidFill>
+            <a:prstDash val="solid"/>
+            <a:round/>
+            <a:headEnd type="none" w="med" len="med"/>
+            <a:tailEnd type="none" w="med" len="med"/>
+          </a:ln>
+        </p:spPr>
+      </p:cxnSp>
+      <p:sp>
+        <p:nvSpPr>
+          <p:cNvPr id="191" name="Google Shape;191;p19">
+            <a:extLst>
+              <a:ext uri="{FF2B5EF4-FFF2-40B4-BE49-F238E27FC236}">
+                <a16:creationId xmlns:a16="http://schemas.microsoft.com/office/drawing/2014/main" id="{B98D767B-8ACB-D271-F132-A0E445653DAA}"/>
+              </a:ext>
+            </a:extLst>
+          </p:cNvPr>
+          <p:cNvSpPr/>
+          <p:nvPr/>
+        </p:nvSpPr>
+        <p:spPr>
+          <a:xfrm>
+            <a:off x="3197186" y="84312"/>
+            <a:ext cx="2410800" cy="480900"/>
+          </a:xfrm>
+          <a:prstGeom prst="roundRect">
+            <a:avLst>
+              <a:gd name="adj" fmla="val 16667"/>
+            </a:avLst>
+          </a:prstGeom>
+          <a:solidFill>
+            <a:srgbClr val="F9CB9C"/>
+          </a:solidFill>
+          <a:ln w="28575" cap="flat" cmpd="sng">
+            <a:solidFill>
+              <a:srgbClr val="B45F06"/>
+            </a:solidFill>
+            <a:prstDash val="solid"/>
+            <a:round/>
+            <a:headEnd type="none" w="sm" len="sm"/>
+            <a:tailEnd type="none" w="sm" len="sm"/>
+          </a:ln>
+        </p:spPr>
+        <p:txBody>
+          <a:bodyPr spcFirstLastPara="1" wrap="square" lIns="91425" tIns="91425" rIns="91425" bIns="91425" anchor="ctr" anchorCtr="0">
+            <a:noAutofit/>
+          </a:bodyPr>
+          <a:lstStyle/>
+          <a:p>
+            <a:pPr marL="0" lvl="0" indent="0" algn="ctr" rtl="0">
+              <a:spcBef>
+                <a:spcPts val="0"/>
+              </a:spcBef>
+              <a:spcAft>
+                <a:spcPts val="0"/>
+              </a:spcAft>
+              <a:buNone/>
+            </a:pPr>
+            <a:r>
+              <a:rPr lang="en-GB" sz="1800" b="1">
+                <a:latin typeface="Consolas"/>
+                <a:ea typeface="Consolas"/>
+                <a:cs typeface="Consolas"/>
+                <a:sym typeface="Consolas"/>
+              </a:rPr>
+              <a:t>Student ID</a:t>
+            </a:r>
+            <a:endParaRPr sz="1800" b="1">
+              <a:latin typeface="Consolas"/>
+              <a:ea typeface="Consolas"/>
+              <a:cs typeface="Consolas"/>
+              <a:sym typeface="Consolas"/>
+            </a:endParaRPr>
+          </a:p>
+        </p:txBody>
+      </p:sp>
+      <p:sp>
+        <p:nvSpPr>
+          <p:cNvPr id="192" name="Google Shape;192;p19">
+            <a:extLst>
+              <a:ext uri="{FF2B5EF4-FFF2-40B4-BE49-F238E27FC236}">
+                <a16:creationId xmlns:a16="http://schemas.microsoft.com/office/drawing/2014/main" id="{2FCA0D5B-8F24-0836-052A-2EDA5068EB78}"/>
+              </a:ext>
+            </a:extLst>
+          </p:cNvPr>
+          <p:cNvSpPr/>
+          <p:nvPr/>
+        </p:nvSpPr>
+        <p:spPr>
+          <a:xfrm>
+            <a:off x="6281636" y="84312"/>
+            <a:ext cx="2410800" cy="480900"/>
+          </a:xfrm>
+          <a:prstGeom prst="roundRect">
+            <a:avLst>
+              <a:gd name="adj" fmla="val 16667"/>
+            </a:avLst>
+          </a:prstGeom>
+          <a:solidFill>
+            <a:srgbClr val="F9CB9C"/>
+          </a:solidFill>
+          <a:ln w="28575" cap="flat" cmpd="sng">
+            <a:solidFill>
+              <a:srgbClr val="B45F06"/>
+            </a:solidFill>
+            <a:prstDash val="solid"/>
+            <a:round/>
+            <a:headEnd type="none" w="sm" len="sm"/>
+            <a:tailEnd type="none" w="sm" len="sm"/>
+          </a:ln>
+        </p:spPr>
+        <p:txBody>
+          <a:bodyPr spcFirstLastPara="1" wrap="square" lIns="91425" tIns="91425" rIns="91425" bIns="91425" anchor="ctr" anchorCtr="0">
+            <a:noAutofit/>
+          </a:bodyPr>
+          <a:lstStyle/>
+          <a:p>
+            <a:pPr marL="0" lvl="0" indent="0" algn="ctr" rtl="0">
+              <a:spcBef>
+                <a:spcPts val="0"/>
+              </a:spcBef>
+              <a:spcAft>
+                <a:spcPts val="0"/>
+              </a:spcAft>
+              <a:buNone/>
+            </a:pPr>
+            <a:r>
+              <a:rPr lang="en-GB" sz="1800" b="1">
+                <a:latin typeface="Consolas"/>
+                <a:ea typeface="Consolas"/>
+                <a:cs typeface="Consolas"/>
+                <a:sym typeface="Consolas"/>
+              </a:rPr>
+              <a:t>Story</a:t>
+            </a:r>
+            <a:endParaRPr sz="1800" b="1">
+              <a:latin typeface="Consolas"/>
+              <a:ea typeface="Consolas"/>
+              <a:cs typeface="Consolas"/>
+              <a:sym typeface="Consolas"/>
+            </a:endParaRPr>
+          </a:p>
+        </p:txBody>
+      </p:sp>
+      <p:sp>
+        <p:nvSpPr>
+          <p:cNvPr id="193" name="Google Shape;193;p19">
+            <a:extLst>
+              <a:ext uri="{FF2B5EF4-FFF2-40B4-BE49-F238E27FC236}">
+                <a16:creationId xmlns:a16="http://schemas.microsoft.com/office/drawing/2014/main" id="{B6639257-54CA-F8F2-4D34-C5970A254913}"/>
+              </a:ext>
+            </a:extLst>
+          </p:cNvPr>
+          <p:cNvSpPr/>
+          <p:nvPr/>
+        </p:nvSpPr>
+        <p:spPr>
+          <a:xfrm>
+            <a:off x="9366071" y="84312"/>
+            <a:ext cx="2410800" cy="480900"/>
+          </a:xfrm>
+          <a:prstGeom prst="roundRect">
+            <a:avLst>
+              <a:gd name="adj" fmla="val 16667"/>
+            </a:avLst>
+          </a:prstGeom>
+          <a:solidFill>
+            <a:srgbClr val="F9CB9C"/>
+          </a:solidFill>
+          <a:ln w="28575" cap="flat" cmpd="sng">
+            <a:solidFill>
+              <a:srgbClr val="B45F06"/>
+            </a:solidFill>
+            <a:prstDash val="solid"/>
+            <a:round/>
+            <a:headEnd type="none" w="sm" len="sm"/>
+            <a:tailEnd type="none" w="sm" len="sm"/>
+          </a:ln>
+        </p:spPr>
+        <p:txBody>
+          <a:bodyPr spcFirstLastPara="1" wrap="square" lIns="91425" tIns="91425" rIns="91425" bIns="91425" anchor="ctr" anchorCtr="0">
+            <a:noAutofit/>
+          </a:bodyPr>
+          <a:lstStyle/>
+          <a:p>
+            <a:pPr marL="0" lvl="0" indent="0" algn="ctr" rtl="0">
+              <a:spcBef>
+                <a:spcPts val="0"/>
+              </a:spcBef>
+              <a:spcAft>
+                <a:spcPts val="0"/>
+              </a:spcAft>
+              <a:buNone/>
+            </a:pPr>
+            <a:r>
+              <a:rPr lang="en-GB" sz="1800" b="1">
+                <a:latin typeface="Consolas"/>
+                <a:ea typeface="Consolas"/>
+                <a:cs typeface="Consolas"/>
+                <a:sym typeface="Consolas"/>
+              </a:rPr>
+              <a:t>To Do</a:t>
+            </a:r>
+            <a:endParaRPr sz="1800" b="1">
+              <a:latin typeface="Consolas"/>
+              <a:ea typeface="Consolas"/>
+              <a:cs typeface="Consolas"/>
+              <a:sym typeface="Consolas"/>
+            </a:endParaRPr>
+          </a:p>
+        </p:txBody>
+      </p:sp>
+      <p:sp>
+        <p:nvSpPr>
+          <p:cNvPr id="194" name="Google Shape;194;p19">
+            <a:extLst>
+              <a:ext uri="{FF2B5EF4-FFF2-40B4-BE49-F238E27FC236}">
+                <a16:creationId xmlns:a16="http://schemas.microsoft.com/office/drawing/2014/main" id="{F924E555-3E0F-E013-8627-B264192983AB}"/>
+              </a:ext>
+            </a:extLst>
+          </p:cNvPr>
+          <p:cNvSpPr/>
+          <p:nvPr/>
+        </p:nvSpPr>
+        <p:spPr>
+          <a:xfrm>
+            <a:off x="12395940" y="84312"/>
+            <a:ext cx="2410800" cy="480900"/>
+          </a:xfrm>
+          <a:prstGeom prst="roundRect">
+            <a:avLst>
+              <a:gd name="adj" fmla="val 16667"/>
+            </a:avLst>
+          </a:prstGeom>
+          <a:solidFill>
+            <a:srgbClr val="F9CB9C"/>
+          </a:solidFill>
+          <a:ln w="28575" cap="flat" cmpd="sng">
+            <a:solidFill>
+              <a:srgbClr val="B45F06"/>
+            </a:solidFill>
+            <a:prstDash val="solid"/>
+            <a:round/>
+            <a:headEnd type="none" w="sm" len="sm"/>
+            <a:tailEnd type="none" w="sm" len="sm"/>
+          </a:ln>
+        </p:spPr>
+        <p:txBody>
+          <a:bodyPr spcFirstLastPara="1" wrap="square" lIns="91425" tIns="91425" rIns="91425" bIns="91425" anchor="ctr" anchorCtr="0">
+            <a:noAutofit/>
+          </a:bodyPr>
+          <a:lstStyle/>
+          <a:p>
+            <a:pPr marL="0" lvl="0" indent="0" algn="ctr" rtl="0">
+              <a:spcBef>
+                <a:spcPts val="0"/>
+              </a:spcBef>
+              <a:spcAft>
+                <a:spcPts val="0"/>
+              </a:spcAft>
+              <a:buNone/>
+            </a:pPr>
+            <a:r>
+              <a:rPr lang="en-GB" sz="1800" b="1">
+                <a:latin typeface="Consolas"/>
+                <a:ea typeface="Consolas"/>
+                <a:cs typeface="Consolas"/>
+                <a:sym typeface="Consolas"/>
+              </a:rPr>
+              <a:t>Doing</a:t>
+            </a:r>
+            <a:endParaRPr sz="1800" b="1">
+              <a:latin typeface="Consolas"/>
+              <a:ea typeface="Consolas"/>
+              <a:cs typeface="Consolas"/>
+              <a:sym typeface="Consolas"/>
+            </a:endParaRPr>
+          </a:p>
+        </p:txBody>
+      </p:sp>
+      <p:sp>
+        <p:nvSpPr>
+          <p:cNvPr id="195" name="Google Shape;195;p19">
+            <a:extLst>
+              <a:ext uri="{FF2B5EF4-FFF2-40B4-BE49-F238E27FC236}">
+                <a16:creationId xmlns:a16="http://schemas.microsoft.com/office/drawing/2014/main" id="{7E16B341-9D7F-CADA-B9AE-E1125E77F572}"/>
+              </a:ext>
+            </a:extLst>
+          </p:cNvPr>
+          <p:cNvSpPr/>
+          <p:nvPr/>
+        </p:nvSpPr>
+        <p:spPr>
+          <a:xfrm>
+            <a:off x="15532407" y="84312"/>
+            <a:ext cx="2410800" cy="480900"/>
+          </a:xfrm>
+          <a:prstGeom prst="roundRect">
+            <a:avLst>
+              <a:gd name="adj" fmla="val 16667"/>
+            </a:avLst>
+          </a:prstGeom>
+          <a:solidFill>
+            <a:srgbClr val="F9CB9C"/>
+          </a:solidFill>
+          <a:ln w="28575" cap="flat" cmpd="sng">
+            <a:solidFill>
+              <a:srgbClr val="B45F06"/>
+            </a:solidFill>
+            <a:prstDash val="solid"/>
+            <a:round/>
+            <a:headEnd type="none" w="sm" len="sm"/>
+            <a:tailEnd type="none" w="sm" len="sm"/>
+          </a:ln>
+        </p:spPr>
+        <p:txBody>
+          <a:bodyPr spcFirstLastPara="1" wrap="square" lIns="91425" tIns="91425" rIns="91425" bIns="91425" anchor="ctr" anchorCtr="0">
+            <a:noAutofit/>
+          </a:bodyPr>
+          <a:lstStyle/>
+          <a:p>
+            <a:pPr marL="0" lvl="0" indent="0" algn="ctr" rtl="0">
+              <a:spcBef>
+                <a:spcPts val="0"/>
+              </a:spcBef>
+              <a:spcAft>
+                <a:spcPts val="0"/>
+              </a:spcAft>
+              <a:buNone/>
+            </a:pPr>
+            <a:r>
+              <a:rPr lang="en-GB" sz="1800" b="1">
+                <a:latin typeface="Consolas"/>
+                <a:ea typeface="Consolas"/>
+                <a:cs typeface="Consolas"/>
+                <a:sym typeface="Consolas"/>
+              </a:rPr>
+              <a:t>Review</a:t>
+            </a:r>
+            <a:endParaRPr sz="1800" b="1">
+              <a:latin typeface="Consolas"/>
+              <a:ea typeface="Consolas"/>
+              <a:cs typeface="Consolas"/>
+              <a:sym typeface="Consolas"/>
+            </a:endParaRPr>
+          </a:p>
+        </p:txBody>
+      </p:sp>
+      <p:sp>
+        <p:nvSpPr>
+          <p:cNvPr id="196" name="Google Shape;196;p19">
+            <a:extLst>
+              <a:ext uri="{FF2B5EF4-FFF2-40B4-BE49-F238E27FC236}">
+                <a16:creationId xmlns:a16="http://schemas.microsoft.com/office/drawing/2014/main" id="{BAA6B421-B4E1-CC48-6694-DFA17776975B}"/>
+              </a:ext>
+            </a:extLst>
+          </p:cNvPr>
+          <p:cNvSpPr/>
+          <p:nvPr/>
+        </p:nvSpPr>
+        <p:spPr>
+          <a:xfrm>
+            <a:off x="18668888" y="84312"/>
+            <a:ext cx="2410800" cy="480900"/>
+          </a:xfrm>
+          <a:prstGeom prst="roundRect">
+            <a:avLst>
+              <a:gd name="adj" fmla="val 16667"/>
+            </a:avLst>
+          </a:prstGeom>
+          <a:solidFill>
+            <a:srgbClr val="F9CB9C"/>
+          </a:solidFill>
+          <a:ln w="28575" cap="flat" cmpd="sng">
+            <a:solidFill>
+              <a:srgbClr val="B45F06"/>
+            </a:solidFill>
+            <a:prstDash val="solid"/>
+            <a:round/>
+            <a:headEnd type="none" w="sm" len="sm"/>
+            <a:tailEnd type="none" w="sm" len="sm"/>
+          </a:ln>
+        </p:spPr>
+        <p:txBody>
+          <a:bodyPr spcFirstLastPara="1" wrap="square" lIns="91425" tIns="91425" rIns="91425" bIns="91425" anchor="ctr" anchorCtr="0">
+            <a:noAutofit/>
+          </a:bodyPr>
+          <a:lstStyle/>
+          <a:p>
+            <a:pPr marL="0" lvl="0" indent="0" algn="ctr" rtl="0">
+              <a:spcBef>
+                <a:spcPts val="0"/>
+              </a:spcBef>
+              <a:spcAft>
+                <a:spcPts val="0"/>
+              </a:spcAft>
+              <a:buNone/>
+            </a:pPr>
+            <a:r>
+              <a:rPr lang="en-GB" sz="1800" b="1">
+                <a:latin typeface="Consolas"/>
+                <a:ea typeface="Consolas"/>
+                <a:cs typeface="Consolas"/>
+                <a:sym typeface="Consolas"/>
+              </a:rPr>
+              <a:t>Done</a:t>
+            </a:r>
+            <a:endParaRPr sz="1800" b="1">
+              <a:latin typeface="Consolas"/>
+              <a:ea typeface="Consolas"/>
+              <a:cs typeface="Consolas"/>
+              <a:sym typeface="Consolas"/>
+            </a:endParaRPr>
+          </a:p>
+        </p:txBody>
+      </p:sp>
+      <p:sp>
+        <p:nvSpPr>
+          <p:cNvPr id="197" name="Google Shape;197;p19">
+            <a:extLst>
+              <a:ext uri="{FF2B5EF4-FFF2-40B4-BE49-F238E27FC236}">
+                <a16:creationId xmlns:a16="http://schemas.microsoft.com/office/drawing/2014/main" id="{516D7FC1-2721-9ABA-87C7-7ED7F357E81D}"/>
+              </a:ext>
+            </a:extLst>
+          </p:cNvPr>
+          <p:cNvSpPr/>
+          <p:nvPr/>
+        </p:nvSpPr>
+        <p:spPr>
+          <a:xfrm>
+            <a:off x="167288" y="84312"/>
+            <a:ext cx="2410800" cy="480900"/>
+          </a:xfrm>
+          <a:prstGeom prst="roundRect">
+            <a:avLst>
+              <a:gd name="adj" fmla="val 16667"/>
+            </a:avLst>
+          </a:prstGeom>
+          <a:solidFill>
+            <a:srgbClr val="F9CB9C"/>
+          </a:solidFill>
+          <a:ln w="28575" cap="flat" cmpd="sng">
+            <a:solidFill>
+              <a:srgbClr val="B45F06"/>
+            </a:solidFill>
+            <a:prstDash val="solid"/>
+            <a:round/>
+            <a:headEnd type="none" w="sm" len="sm"/>
+            <a:tailEnd type="none" w="sm" len="sm"/>
+          </a:ln>
+        </p:spPr>
+        <p:txBody>
+          <a:bodyPr spcFirstLastPara="1" wrap="square" lIns="91425" tIns="91425" rIns="91425" bIns="91425" anchor="ctr" anchorCtr="0">
+            <a:noAutofit/>
+          </a:bodyPr>
+          <a:lstStyle/>
+          <a:p>
+            <a:pPr marL="0" lvl="0" indent="0" algn="ctr" rtl="0">
+              <a:spcBef>
+                <a:spcPts val="0"/>
+              </a:spcBef>
+              <a:spcAft>
+                <a:spcPts val="0"/>
+              </a:spcAft>
+              <a:buNone/>
+            </a:pPr>
+            <a:r>
+              <a:rPr lang="en-GB" sz="1800" b="1">
+                <a:latin typeface="Consolas"/>
+                <a:ea typeface="Consolas"/>
+                <a:cs typeface="Consolas"/>
+                <a:sym typeface="Consolas"/>
+              </a:rPr>
+              <a:t>Backlog</a:t>
+            </a:r>
+            <a:endParaRPr sz="1800" b="1">
+              <a:latin typeface="Consolas"/>
+              <a:ea typeface="Consolas"/>
+              <a:cs typeface="Consolas"/>
+              <a:sym typeface="Consolas"/>
+            </a:endParaRPr>
+          </a:p>
+        </p:txBody>
+      </p:sp>
+      <p:cxnSp>
+        <p:nvCxnSpPr>
+          <p:cNvPr id="204" name="Google Shape;204;p19">
+            <a:extLst>
+              <a:ext uri="{FF2B5EF4-FFF2-40B4-BE49-F238E27FC236}">
+                <a16:creationId xmlns:a16="http://schemas.microsoft.com/office/drawing/2014/main" id="{0D220198-1226-64AA-ED17-6F832D349B6E}"/>
+              </a:ext>
+            </a:extLst>
+          </p:cNvPr>
+          <p:cNvCxnSpPr/>
+          <p:nvPr/>
+        </p:nvCxnSpPr>
+        <p:spPr>
+          <a:xfrm>
+            <a:off x="5607986" y="1626038"/>
+            <a:ext cx="16042200" cy="0"/>
+          </a:xfrm>
+          <a:prstGeom prst="straightConnector1">
+            <a:avLst/>
+          </a:prstGeom>
+          <a:noFill/>
+          <a:ln w="28575" cap="flat" cmpd="sng">
+            <a:solidFill>
+              <a:srgbClr val="999999"/>
+            </a:solidFill>
+            <a:prstDash val="dash"/>
+            <a:round/>
+            <a:headEnd type="none" w="med" len="med"/>
+            <a:tailEnd type="none" w="med" len="med"/>
+          </a:ln>
+        </p:spPr>
+      </p:cxnSp>
+      <p:cxnSp>
+        <p:nvCxnSpPr>
+          <p:cNvPr id="205" name="Google Shape;205;p19">
+            <a:extLst>
+              <a:ext uri="{FF2B5EF4-FFF2-40B4-BE49-F238E27FC236}">
+                <a16:creationId xmlns:a16="http://schemas.microsoft.com/office/drawing/2014/main" id="{B0061229-9FB6-1392-3177-6FEED81A8725}"/>
+              </a:ext>
+            </a:extLst>
+          </p:cNvPr>
+          <p:cNvCxnSpPr/>
+          <p:nvPr/>
+        </p:nvCxnSpPr>
+        <p:spPr>
+          <a:xfrm>
+            <a:off x="5607986" y="3203476"/>
+            <a:ext cx="16042200" cy="0"/>
+          </a:xfrm>
+          <a:prstGeom prst="straightConnector1">
+            <a:avLst/>
+          </a:prstGeom>
+          <a:noFill/>
+          <a:ln w="28575" cap="flat" cmpd="sng">
+            <a:solidFill>
+              <a:srgbClr val="999999"/>
+            </a:solidFill>
+            <a:prstDash val="dash"/>
+            <a:round/>
+            <a:headEnd type="none" w="med" len="med"/>
+            <a:tailEnd type="none" w="med" len="med"/>
+          </a:ln>
+        </p:spPr>
+      </p:cxnSp>
+      <p:cxnSp>
+        <p:nvCxnSpPr>
+          <p:cNvPr id="206" name="Google Shape;206;p19">
+            <a:extLst>
+              <a:ext uri="{FF2B5EF4-FFF2-40B4-BE49-F238E27FC236}">
+                <a16:creationId xmlns:a16="http://schemas.microsoft.com/office/drawing/2014/main" id="{0FE2DB45-6CA0-0905-DB19-91DA1397CDA9}"/>
+              </a:ext>
+            </a:extLst>
+          </p:cNvPr>
+          <p:cNvCxnSpPr/>
+          <p:nvPr/>
+        </p:nvCxnSpPr>
+        <p:spPr>
+          <a:xfrm>
+            <a:off x="5607986" y="4777838"/>
+            <a:ext cx="16042200" cy="0"/>
+          </a:xfrm>
+          <a:prstGeom prst="straightConnector1">
+            <a:avLst/>
+          </a:prstGeom>
+          <a:noFill/>
+          <a:ln w="28575" cap="flat" cmpd="sng">
+            <a:solidFill>
+              <a:srgbClr val="999999"/>
+            </a:solidFill>
+            <a:prstDash val="dash"/>
+            <a:round/>
+            <a:headEnd type="none" w="med" len="med"/>
+            <a:tailEnd type="none" w="med" len="med"/>
+          </a:ln>
+        </p:spPr>
+      </p:cxnSp>
+      <p:cxnSp>
+        <p:nvCxnSpPr>
+          <p:cNvPr id="207" name="Google Shape;207;p19">
+            <a:extLst>
+              <a:ext uri="{FF2B5EF4-FFF2-40B4-BE49-F238E27FC236}">
+                <a16:creationId xmlns:a16="http://schemas.microsoft.com/office/drawing/2014/main" id="{8497C966-1D35-ED7F-F938-169BBE04EE1A}"/>
+              </a:ext>
+            </a:extLst>
+          </p:cNvPr>
+          <p:cNvCxnSpPr/>
+          <p:nvPr/>
+        </p:nvCxnSpPr>
+        <p:spPr>
+          <a:xfrm>
+            <a:off x="5607986" y="6353738"/>
+            <a:ext cx="16042200" cy="0"/>
+          </a:xfrm>
+          <a:prstGeom prst="straightConnector1">
+            <a:avLst/>
+          </a:prstGeom>
+          <a:noFill/>
+          <a:ln w="28575" cap="flat" cmpd="sng">
+            <a:solidFill>
+              <a:srgbClr val="999999"/>
+            </a:solidFill>
+            <a:prstDash val="dash"/>
+            <a:round/>
+            <a:headEnd type="none" w="med" len="med"/>
+            <a:tailEnd type="none" w="med" len="med"/>
+          </a:ln>
+        </p:spPr>
+      </p:cxnSp>
+      <p:cxnSp>
+        <p:nvCxnSpPr>
+          <p:cNvPr id="208" name="Google Shape;208;p19">
+            <a:extLst>
+              <a:ext uri="{FF2B5EF4-FFF2-40B4-BE49-F238E27FC236}">
+                <a16:creationId xmlns:a16="http://schemas.microsoft.com/office/drawing/2014/main" id="{835B2663-0890-96B6-07DC-4DA497028CE4}"/>
+              </a:ext>
+            </a:extLst>
+          </p:cNvPr>
+          <p:cNvCxnSpPr/>
+          <p:nvPr/>
+        </p:nvCxnSpPr>
+        <p:spPr>
+          <a:xfrm>
+            <a:off x="5607986" y="7929638"/>
+            <a:ext cx="16042200" cy="0"/>
+          </a:xfrm>
+          <a:prstGeom prst="straightConnector1">
+            <a:avLst/>
+          </a:prstGeom>
+          <a:noFill/>
+          <a:ln w="28575" cap="flat" cmpd="sng">
+            <a:solidFill>
+              <a:srgbClr val="999999"/>
+            </a:solidFill>
+            <a:prstDash val="dash"/>
+            <a:round/>
+            <a:headEnd type="none" w="med" len="med"/>
+            <a:tailEnd type="none" w="med" len="med"/>
+          </a:ln>
+        </p:spPr>
+      </p:cxnSp>
+      <p:cxnSp>
+        <p:nvCxnSpPr>
+          <p:cNvPr id="209" name="Google Shape;209;p19">
+            <a:extLst>
+              <a:ext uri="{FF2B5EF4-FFF2-40B4-BE49-F238E27FC236}">
+                <a16:creationId xmlns:a16="http://schemas.microsoft.com/office/drawing/2014/main" id="{89850700-3A1C-F3DA-D4C1-BA2F915CC867}"/>
+              </a:ext>
+            </a:extLst>
+          </p:cNvPr>
+          <p:cNvCxnSpPr/>
+          <p:nvPr/>
+        </p:nvCxnSpPr>
+        <p:spPr>
+          <a:xfrm>
+            <a:off x="5607986" y="9505538"/>
+            <a:ext cx="16042200" cy="0"/>
+          </a:xfrm>
+          <a:prstGeom prst="straightConnector1">
+            <a:avLst/>
+          </a:prstGeom>
+          <a:noFill/>
+          <a:ln w="28575" cap="flat" cmpd="sng">
+            <a:solidFill>
+              <a:srgbClr val="999999"/>
+            </a:solidFill>
+            <a:prstDash val="dash"/>
+            <a:round/>
+            <a:headEnd type="none" w="med" len="med"/>
+            <a:tailEnd type="none" w="med" len="med"/>
+          </a:ln>
+        </p:spPr>
+      </p:cxnSp>
+      <p:cxnSp>
+        <p:nvCxnSpPr>
+          <p:cNvPr id="215" name="Google Shape;215;p19">
+            <a:extLst>
+              <a:ext uri="{FF2B5EF4-FFF2-40B4-BE49-F238E27FC236}">
+                <a16:creationId xmlns:a16="http://schemas.microsoft.com/office/drawing/2014/main" id="{425B3A0D-8E09-8D6D-87F4-6527CB687C31}"/>
+              </a:ext>
+            </a:extLst>
+          </p:cNvPr>
+          <p:cNvCxnSpPr/>
+          <p:nvPr/>
+        </p:nvCxnSpPr>
+        <p:spPr>
+          <a:xfrm>
+            <a:off x="2874374" y="-28500"/>
+            <a:ext cx="0" cy="10857000"/>
+          </a:xfrm>
+          <a:prstGeom prst="straightConnector1">
+            <a:avLst/>
+          </a:prstGeom>
+          <a:noFill/>
+          <a:ln w="38100" cap="flat" cmpd="sng">
+            <a:solidFill>
+              <a:srgbClr val="5B0F00"/>
+            </a:solidFill>
+            <a:prstDash val="solid"/>
+            <a:round/>
+            <a:headEnd type="none" w="med" len="med"/>
+            <a:tailEnd type="none" w="med" len="med"/>
+          </a:ln>
+        </p:spPr>
+      </p:cxnSp>
+      <p:sp>
+        <p:nvSpPr>
+          <p:cNvPr id="2" name="Google Shape;74;p15">
+            <a:extLst>
+              <a:ext uri="{FF2B5EF4-FFF2-40B4-BE49-F238E27FC236}">
+                <a16:creationId xmlns:a16="http://schemas.microsoft.com/office/drawing/2014/main" id="{D4F7ADC3-A67C-C392-602B-A6691E12973F}"/>
+              </a:ext>
+            </a:extLst>
+          </p:cNvPr>
+          <p:cNvSpPr/>
+          <p:nvPr/>
+        </p:nvSpPr>
+        <p:spPr>
+          <a:xfrm>
+            <a:off x="3197186" y="1385588"/>
+            <a:ext cx="2410800" cy="480900"/>
+          </a:xfrm>
+          <a:prstGeom prst="roundRect">
+            <a:avLst>
+              <a:gd name="adj" fmla="val 16667"/>
+            </a:avLst>
+          </a:prstGeom>
+          <a:solidFill>
+            <a:srgbClr val="E6B8AF"/>
+          </a:solidFill>
+          <a:ln w="28575" cap="flat" cmpd="sng">
+            <a:solidFill>
+              <a:srgbClr val="5B0F00"/>
+            </a:solidFill>
+            <a:prstDash val="solid"/>
+            <a:round/>
+            <a:headEnd type="none" w="sm" len="sm"/>
+            <a:tailEnd type="none" w="sm" len="sm"/>
+          </a:ln>
+        </p:spPr>
+        <p:txBody>
+          <a:bodyPr spcFirstLastPara="1" wrap="square" lIns="91425" tIns="91425" rIns="91425" bIns="91425" anchor="ctr" anchorCtr="0">
+            <a:noAutofit/>
+          </a:bodyPr>
+          <a:lstStyle/>
+          <a:p>
+            <a:pPr marL="0" lvl="0" indent="0" algn="ctr" rtl="0">
+              <a:spcBef>
+                <a:spcPts val="0"/>
+              </a:spcBef>
+              <a:spcAft>
+                <a:spcPts val="0"/>
+              </a:spcAft>
+              <a:buNone/>
+            </a:pPr>
+            <a:r>
+              <a:rPr lang="en-GB" sz="1800" b="1" dirty="0">
+                <a:latin typeface="Consolas"/>
+                <a:ea typeface="Consolas"/>
+                <a:cs typeface="Consolas"/>
+                <a:sym typeface="Consolas"/>
+              </a:rPr>
+              <a:t>68338</a:t>
+            </a:r>
+            <a:endParaRPr sz="1800" b="1" dirty="0">
+              <a:latin typeface="Consolas"/>
+              <a:ea typeface="Consolas"/>
+              <a:cs typeface="Consolas"/>
+              <a:sym typeface="Consolas"/>
+            </a:endParaRPr>
+          </a:p>
+        </p:txBody>
+      </p:sp>
+      <p:sp>
+        <p:nvSpPr>
+          <p:cNvPr id="3" name="Google Shape;75;p15">
+            <a:extLst>
+              <a:ext uri="{FF2B5EF4-FFF2-40B4-BE49-F238E27FC236}">
+                <a16:creationId xmlns:a16="http://schemas.microsoft.com/office/drawing/2014/main" id="{68EADD84-B48E-2466-1EBD-CBF5C7DC0600}"/>
+              </a:ext>
+            </a:extLst>
+          </p:cNvPr>
+          <p:cNvSpPr/>
+          <p:nvPr/>
+        </p:nvSpPr>
+        <p:spPr>
+          <a:xfrm>
+            <a:off x="3197186" y="2961501"/>
+            <a:ext cx="2410800" cy="480900"/>
+          </a:xfrm>
+          <a:prstGeom prst="roundRect">
+            <a:avLst>
+              <a:gd name="adj" fmla="val 16667"/>
+            </a:avLst>
+          </a:prstGeom>
+          <a:solidFill>
+            <a:srgbClr val="E6B8AF"/>
+          </a:solidFill>
+          <a:ln w="28575" cap="flat" cmpd="sng">
+            <a:solidFill>
+              <a:srgbClr val="5B0F00"/>
+            </a:solidFill>
+            <a:prstDash val="solid"/>
+            <a:round/>
+            <a:headEnd type="none" w="sm" len="sm"/>
+            <a:tailEnd type="none" w="sm" len="sm"/>
+          </a:ln>
+        </p:spPr>
+        <p:txBody>
+          <a:bodyPr spcFirstLastPara="1" wrap="square" lIns="91425" tIns="91425" rIns="91425" bIns="91425" anchor="ctr" anchorCtr="0">
+            <a:noAutofit/>
+          </a:bodyPr>
+          <a:lstStyle/>
+          <a:p>
+            <a:pPr marL="0" lvl="0" indent="0" algn="ctr" rtl="0">
+              <a:spcBef>
+                <a:spcPts val="0"/>
+              </a:spcBef>
+              <a:spcAft>
+                <a:spcPts val="0"/>
+              </a:spcAft>
+              <a:buNone/>
+            </a:pPr>
+            <a:r>
+              <a:rPr lang="en-GB" sz="1800" b="1" dirty="0">
+                <a:latin typeface="Consolas"/>
+                <a:ea typeface="Consolas"/>
+                <a:cs typeface="Consolas"/>
+                <a:sym typeface="Consolas"/>
+              </a:rPr>
+              <a:t>68245</a:t>
+            </a:r>
+            <a:endParaRPr sz="1800" b="1" dirty="0">
+              <a:latin typeface="Consolas"/>
+              <a:ea typeface="Consolas"/>
+              <a:cs typeface="Consolas"/>
+              <a:sym typeface="Consolas"/>
+            </a:endParaRPr>
+          </a:p>
+        </p:txBody>
+      </p:sp>
+      <p:sp>
+        <p:nvSpPr>
+          <p:cNvPr id="4" name="Google Shape;76;p15">
+            <a:extLst>
+              <a:ext uri="{FF2B5EF4-FFF2-40B4-BE49-F238E27FC236}">
+                <a16:creationId xmlns:a16="http://schemas.microsoft.com/office/drawing/2014/main" id="{3EEB9402-294C-D6EE-0ECD-BDCFE13115EB}"/>
+              </a:ext>
+            </a:extLst>
+          </p:cNvPr>
+          <p:cNvSpPr/>
+          <p:nvPr/>
+        </p:nvSpPr>
+        <p:spPr>
+          <a:xfrm>
+            <a:off x="3197186" y="4537410"/>
+            <a:ext cx="2410800" cy="480900"/>
+          </a:xfrm>
+          <a:prstGeom prst="roundRect">
+            <a:avLst>
+              <a:gd name="adj" fmla="val 16667"/>
+            </a:avLst>
+          </a:prstGeom>
+          <a:solidFill>
+            <a:srgbClr val="E6B8AF"/>
+          </a:solidFill>
+          <a:ln w="28575" cap="flat" cmpd="sng">
+            <a:solidFill>
+              <a:srgbClr val="5B0F00"/>
+            </a:solidFill>
+            <a:prstDash val="solid"/>
+            <a:round/>
+            <a:headEnd type="none" w="sm" len="sm"/>
+            <a:tailEnd type="none" w="sm" len="sm"/>
+          </a:ln>
+        </p:spPr>
+        <p:txBody>
+          <a:bodyPr spcFirstLastPara="1" wrap="square" lIns="91425" tIns="91425" rIns="91425" bIns="91425" anchor="ctr" anchorCtr="0">
+            <a:noAutofit/>
+          </a:bodyPr>
+          <a:lstStyle/>
+          <a:p>
+            <a:pPr marL="0" lvl="0" indent="0" algn="ctr" rtl="0">
+              <a:spcBef>
+                <a:spcPts val="0"/>
+              </a:spcBef>
+              <a:spcAft>
+                <a:spcPts val="0"/>
+              </a:spcAft>
+              <a:buNone/>
+            </a:pPr>
+            <a:r>
+              <a:rPr lang="en-GB" sz="1800" b="1" dirty="0">
+                <a:latin typeface="Consolas"/>
+                <a:ea typeface="Consolas"/>
+                <a:cs typeface="Consolas"/>
+                <a:sym typeface="Consolas"/>
+              </a:rPr>
+              <a:t>68725</a:t>
+            </a:r>
+            <a:endParaRPr sz="1800" b="1" dirty="0">
+              <a:latin typeface="Consolas"/>
+              <a:ea typeface="Consolas"/>
+              <a:cs typeface="Consolas"/>
+              <a:sym typeface="Consolas"/>
+            </a:endParaRPr>
+          </a:p>
+        </p:txBody>
+      </p:sp>
+      <p:sp>
+        <p:nvSpPr>
+          <p:cNvPr id="5" name="Google Shape;77;p15">
+            <a:extLst>
+              <a:ext uri="{FF2B5EF4-FFF2-40B4-BE49-F238E27FC236}">
+                <a16:creationId xmlns:a16="http://schemas.microsoft.com/office/drawing/2014/main" id="{38933AE8-4E26-2CF1-7F39-C385B676EB96}"/>
+              </a:ext>
+            </a:extLst>
+          </p:cNvPr>
+          <p:cNvSpPr/>
+          <p:nvPr/>
+        </p:nvSpPr>
+        <p:spPr>
+          <a:xfrm>
+            <a:off x="3197186" y="6113307"/>
+            <a:ext cx="2410800" cy="480900"/>
+          </a:xfrm>
+          <a:prstGeom prst="roundRect">
+            <a:avLst>
+              <a:gd name="adj" fmla="val 16667"/>
+            </a:avLst>
+          </a:prstGeom>
+          <a:solidFill>
+            <a:srgbClr val="E6B8AF"/>
+          </a:solidFill>
+          <a:ln w="28575" cap="flat" cmpd="sng">
+            <a:solidFill>
+              <a:srgbClr val="5B0F00"/>
+            </a:solidFill>
+            <a:prstDash val="solid"/>
+            <a:round/>
+            <a:headEnd type="none" w="sm" len="sm"/>
+            <a:tailEnd type="none" w="sm" len="sm"/>
+          </a:ln>
+        </p:spPr>
+        <p:txBody>
+          <a:bodyPr spcFirstLastPara="1" wrap="square" lIns="91425" tIns="91425" rIns="91425" bIns="91425" anchor="ctr" anchorCtr="0">
+            <a:noAutofit/>
+          </a:bodyPr>
+          <a:lstStyle/>
+          <a:p>
+            <a:pPr marL="0" lvl="0" indent="0" algn="ctr" rtl="0">
+              <a:spcBef>
+                <a:spcPts val="0"/>
+              </a:spcBef>
+              <a:spcAft>
+                <a:spcPts val="0"/>
+              </a:spcAft>
+              <a:buNone/>
+            </a:pPr>
+            <a:r>
+              <a:rPr lang="en-GB" sz="1800" b="1" dirty="0">
+                <a:latin typeface="Consolas"/>
+                <a:ea typeface="Consolas"/>
+                <a:cs typeface="Consolas"/>
+                <a:sym typeface="Consolas"/>
+              </a:rPr>
+              <a:t>68180</a:t>
+            </a:r>
+            <a:endParaRPr sz="1800" b="1" dirty="0">
+              <a:latin typeface="Consolas"/>
+              <a:ea typeface="Consolas"/>
+              <a:cs typeface="Consolas"/>
+              <a:sym typeface="Consolas"/>
+            </a:endParaRPr>
+          </a:p>
+        </p:txBody>
+      </p:sp>
+      <p:sp>
+        <p:nvSpPr>
+          <p:cNvPr id="6" name="Google Shape;78;p15">
+            <a:extLst>
+              <a:ext uri="{FF2B5EF4-FFF2-40B4-BE49-F238E27FC236}">
+                <a16:creationId xmlns:a16="http://schemas.microsoft.com/office/drawing/2014/main" id="{AA10CF88-7570-5F3D-B88A-F08F621A4BBA}"/>
+              </a:ext>
+            </a:extLst>
+          </p:cNvPr>
+          <p:cNvSpPr/>
+          <p:nvPr/>
+        </p:nvSpPr>
+        <p:spPr>
+          <a:xfrm>
+            <a:off x="3197186" y="7689198"/>
+            <a:ext cx="2410800" cy="480900"/>
+          </a:xfrm>
+          <a:prstGeom prst="roundRect">
+            <a:avLst>
+              <a:gd name="adj" fmla="val 16667"/>
+            </a:avLst>
+          </a:prstGeom>
+          <a:solidFill>
+            <a:srgbClr val="E6B8AF"/>
+          </a:solidFill>
+          <a:ln w="28575" cap="flat" cmpd="sng">
+            <a:solidFill>
+              <a:srgbClr val="5B0F00"/>
+            </a:solidFill>
+            <a:prstDash val="solid"/>
+            <a:round/>
+            <a:headEnd type="none" w="sm" len="sm"/>
+            <a:tailEnd type="none" w="sm" len="sm"/>
+          </a:ln>
+        </p:spPr>
+        <p:txBody>
+          <a:bodyPr spcFirstLastPara="1" wrap="square" lIns="91425" tIns="91425" rIns="91425" bIns="91425" anchor="ctr" anchorCtr="0">
+            <a:noAutofit/>
+          </a:bodyPr>
+          <a:lstStyle/>
+          <a:p>
+            <a:pPr marL="0" lvl="0" indent="0" algn="ctr" rtl="0">
+              <a:spcBef>
+                <a:spcPts val="0"/>
+              </a:spcBef>
+              <a:spcAft>
+                <a:spcPts val="0"/>
+              </a:spcAft>
+              <a:buNone/>
+            </a:pPr>
+            <a:r>
+              <a:rPr lang="en-GB" sz="1800" b="1" dirty="0">
+                <a:latin typeface="Consolas"/>
+                <a:ea typeface="Consolas"/>
+                <a:cs typeface="Consolas"/>
+                <a:sym typeface="Consolas"/>
+              </a:rPr>
+              <a:t>67912</a:t>
+            </a:r>
+            <a:endParaRPr sz="1800" b="1" dirty="0">
+              <a:latin typeface="Consolas"/>
+              <a:ea typeface="Consolas"/>
+              <a:cs typeface="Consolas"/>
+              <a:sym typeface="Consolas"/>
+            </a:endParaRPr>
+          </a:p>
+        </p:txBody>
+      </p:sp>
+      <p:sp>
+        <p:nvSpPr>
+          <p:cNvPr id="7" name="Google Shape;79;p15">
+            <a:extLst>
+              <a:ext uri="{FF2B5EF4-FFF2-40B4-BE49-F238E27FC236}">
+                <a16:creationId xmlns:a16="http://schemas.microsoft.com/office/drawing/2014/main" id="{291A0CC3-4110-4639-1C79-D3DD3C4BE937}"/>
+              </a:ext>
+            </a:extLst>
+          </p:cNvPr>
+          <p:cNvSpPr/>
+          <p:nvPr/>
+        </p:nvSpPr>
+        <p:spPr>
+          <a:xfrm>
+            <a:off x="3197186" y="9265103"/>
+            <a:ext cx="2410800" cy="480900"/>
+          </a:xfrm>
+          <a:prstGeom prst="roundRect">
+            <a:avLst>
+              <a:gd name="adj" fmla="val 16667"/>
+            </a:avLst>
+          </a:prstGeom>
+          <a:solidFill>
+            <a:srgbClr val="E6B8AF"/>
+          </a:solidFill>
+          <a:ln w="28575" cap="flat" cmpd="sng">
+            <a:solidFill>
+              <a:srgbClr val="5B0F00"/>
+            </a:solidFill>
+            <a:prstDash val="solid"/>
+            <a:round/>
+            <a:headEnd type="none" w="sm" len="sm"/>
+            <a:tailEnd type="none" w="sm" len="sm"/>
+          </a:ln>
+        </p:spPr>
+        <p:txBody>
+          <a:bodyPr spcFirstLastPara="1" wrap="square" lIns="91425" tIns="91425" rIns="91425" bIns="91425" anchor="ctr" anchorCtr="0">
+            <a:noAutofit/>
+          </a:bodyPr>
+          <a:lstStyle/>
+          <a:p>
+            <a:pPr marL="0" lvl="0" indent="0" algn="ctr" rtl="0">
+              <a:spcBef>
+                <a:spcPts val="0"/>
+              </a:spcBef>
+              <a:spcAft>
+                <a:spcPts val="0"/>
+              </a:spcAft>
+              <a:buNone/>
+            </a:pPr>
+            <a:r>
+              <a:rPr lang="en-GB" sz="1800" b="1" dirty="0">
+                <a:latin typeface="Consolas"/>
+                <a:ea typeface="Consolas"/>
+                <a:cs typeface="Consolas"/>
+                <a:sym typeface="Consolas"/>
+              </a:rPr>
+              <a:t>67870</a:t>
+            </a:r>
+            <a:endParaRPr sz="1800" b="1" dirty="0">
+              <a:latin typeface="Consolas"/>
+              <a:ea typeface="Consolas"/>
+              <a:cs typeface="Consolas"/>
+              <a:sym typeface="Consolas"/>
+            </a:endParaRPr>
+          </a:p>
+        </p:txBody>
+      </p:sp>
+      <p:sp>
+        <p:nvSpPr>
+          <p:cNvPr id="15" name="Google Shape;92;p15">
+            <a:extLst>
+              <a:ext uri="{FF2B5EF4-FFF2-40B4-BE49-F238E27FC236}">
+                <a16:creationId xmlns:a16="http://schemas.microsoft.com/office/drawing/2014/main" id="{3D597083-EB0F-4290-8143-BF179502298F}"/>
+              </a:ext>
+            </a:extLst>
+          </p:cNvPr>
+          <p:cNvSpPr/>
+          <p:nvPr/>
+        </p:nvSpPr>
+        <p:spPr>
+          <a:xfrm>
+            <a:off x="270828" y="872940"/>
+            <a:ext cx="2185575" cy="1792037"/>
+          </a:xfrm>
+          <a:prstGeom prst="roundRect">
+            <a:avLst>
+              <a:gd name="adj" fmla="val 16667"/>
+            </a:avLst>
+          </a:prstGeom>
+          <a:solidFill>
+            <a:srgbClr val="D9EAD3"/>
+          </a:solidFill>
+          <a:ln w="28575" cap="flat" cmpd="sng">
+            <a:solidFill>
+              <a:srgbClr val="274E13"/>
+            </a:solidFill>
+            <a:prstDash val="solid"/>
+            <a:round/>
+            <a:headEnd type="none" w="sm" len="sm"/>
+            <a:tailEnd type="none" w="sm" len="sm"/>
+          </a:ln>
+        </p:spPr>
+        <p:txBody>
+          <a:bodyPr spcFirstLastPara="1" wrap="square" lIns="91425" tIns="91425" rIns="91425" bIns="91425" anchor="t" anchorCtr="0">
+            <a:noAutofit/>
+          </a:bodyPr>
+          <a:lstStyle/>
+          <a:p>
+            <a:pPr lvl="0"/>
+            <a:r>
+              <a:rPr lang="pt-PT" dirty="0">
+                <a:latin typeface="Consolas"/>
+                <a:ea typeface="Consolas"/>
+                <a:cs typeface="Consolas"/>
+                <a:sym typeface="Consolas"/>
+              </a:rPr>
+              <a:t>T1: Acabar de implementar o gerador de mapa semanal.</a:t>
+            </a:r>
+            <a:endParaRPr dirty="0">
+              <a:latin typeface="Consolas"/>
+              <a:ea typeface="Consolas"/>
+              <a:cs typeface="Consolas"/>
+              <a:sym typeface="Consolas"/>
+            </a:endParaRPr>
+          </a:p>
+        </p:txBody>
+      </p:sp>
+      <p:sp>
+        <p:nvSpPr>
+          <p:cNvPr id="16" name="Google Shape;92;p15">
+            <a:extLst>
+              <a:ext uri="{FF2B5EF4-FFF2-40B4-BE49-F238E27FC236}">
+                <a16:creationId xmlns:a16="http://schemas.microsoft.com/office/drawing/2014/main" id="{07784F17-3532-FD63-B1B6-5CC770A9A748}"/>
+              </a:ext>
+            </a:extLst>
+          </p:cNvPr>
+          <p:cNvSpPr/>
+          <p:nvPr/>
+        </p:nvSpPr>
+        <p:spPr>
+          <a:xfrm>
+            <a:off x="277880" y="2783177"/>
+            <a:ext cx="2185575" cy="1792037"/>
+          </a:xfrm>
+          <a:prstGeom prst="roundRect">
+            <a:avLst>
+              <a:gd name="adj" fmla="val 16667"/>
+            </a:avLst>
+          </a:prstGeom>
+          <a:solidFill>
+            <a:srgbClr val="D9EAD3"/>
+          </a:solidFill>
+          <a:ln w="28575" cap="flat" cmpd="sng">
+            <a:solidFill>
+              <a:srgbClr val="274E13"/>
+            </a:solidFill>
+            <a:prstDash val="solid"/>
+            <a:round/>
+            <a:headEnd type="none" w="sm" len="sm"/>
+            <a:tailEnd type="none" w="sm" len="sm"/>
+          </a:ln>
+        </p:spPr>
+        <p:txBody>
+          <a:bodyPr spcFirstLastPara="1" wrap="square" lIns="91425" tIns="91425" rIns="91425" bIns="91425" anchor="t" anchorCtr="0">
+            <a:noAutofit/>
+          </a:bodyPr>
+          <a:lstStyle/>
+          <a:p>
+            <a:pPr lvl="0"/>
+            <a:r>
+              <a:rPr lang="pt-PT" dirty="0">
+                <a:latin typeface="Consolas"/>
+                <a:ea typeface="Consolas"/>
+                <a:cs typeface="Consolas"/>
+                <a:sym typeface="Consolas"/>
+              </a:rPr>
+              <a:t>T2: Acabar de implementar a </a:t>
+            </a:r>
+            <a:r>
+              <a:rPr lang="pt-PT" dirty="0" err="1">
+                <a:latin typeface="Consolas"/>
+                <a:ea typeface="Consolas"/>
+                <a:cs typeface="Consolas"/>
+                <a:sym typeface="Consolas"/>
+              </a:rPr>
+              <a:t>Health</a:t>
+            </a:r>
+            <a:r>
+              <a:rPr lang="pt-PT" dirty="0">
+                <a:latin typeface="Consolas"/>
+                <a:ea typeface="Consolas"/>
+                <a:cs typeface="Consolas"/>
+                <a:sym typeface="Consolas"/>
+              </a:rPr>
+              <a:t> Bar de cada </a:t>
+            </a:r>
+            <a:r>
+              <a:rPr lang="pt-PT" dirty="0" err="1">
+                <a:latin typeface="Consolas"/>
+                <a:ea typeface="Consolas"/>
+                <a:cs typeface="Consolas"/>
+                <a:sym typeface="Consolas"/>
+              </a:rPr>
+              <a:t>wave</a:t>
+            </a:r>
+            <a:r>
+              <a:rPr lang="pt-PT" dirty="0">
+                <a:latin typeface="Consolas"/>
+                <a:ea typeface="Consolas"/>
+                <a:cs typeface="Consolas"/>
+                <a:sym typeface="Consolas"/>
+              </a:rPr>
+              <a:t> de inimigos e fazer o </a:t>
+            </a:r>
+            <a:r>
+              <a:rPr lang="pt-PT" dirty="0" err="1">
+                <a:latin typeface="Consolas"/>
+                <a:ea typeface="Consolas"/>
+                <a:cs typeface="Consolas"/>
+                <a:sym typeface="Consolas"/>
+              </a:rPr>
+              <a:t>review</a:t>
+            </a:r>
+            <a:r>
+              <a:rPr lang="pt-PT" dirty="0">
+                <a:latin typeface="Consolas"/>
+                <a:ea typeface="Consolas"/>
+                <a:cs typeface="Consolas"/>
+                <a:sym typeface="Consolas"/>
+              </a:rPr>
+              <a:t>.</a:t>
+            </a:r>
+            <a:endParaRPr dirty="0">
+              <a:latin typeface="Consolas"/>
+              <a:ea typeface="Consolas"/>
+              <a:cs typeface="Consolas"/>
+              <a:sym typeface="Consolas"/>
+            </a:endParaRPr>
+          </a:p>
+        </p:txBody>
+      </p:sp>
+      <p:sp>
+        <p:nvSpPr>
+          <p:cNvPr id="17" name="Google Shape;92;p15">
+            <a:extLst>
+              <a:ext uri="{FF2B5EF4-FFF2-40B4-BE49-F238E27FC236}">
+                <a16:creationId xmlns:a16="http://schemas.microsoft.com/office/drawing/2014/main" id="{0FF2637C-A33B-57B4-748E-01BCA8231306}"/>
+              </a:ext>
+            </a:extLst>
+          </p:cNvPr>
+          <p:cNvSpPr/>
+          <p:nvPr/>
+        </p:nvSpPr>
+        <p:spPr>
+          <a:xfrm>
+            <a:off x="277880" y="4699227"/>
+            <a:ext cx="2185575" cy="1792037"/>
+          </a:xfrm>
+          <a:prstGeom prst="roundRect">
+            <a:avLst>
+              <a:gd name="adj" fmla="val 16667"/>
+            </a:avLst>
+          </a:prstGeom>
+          <a:solidFill>
+            <a:srgbClr val="D9EAD3"/>
+          </a:solidFill>
+          <a:ln w="28575" cap="flat" cmpd="sng">
+            <a:solidFill>
+              <a:srgbClr val="274E13"/>
+            </a:solidFill>
+            <a:prstDash val="solid"/>
+            <a:round/>
+            <a:headEnd type="none" w="sm" len="sm"/>
+            <a:tailEnd type="none" w="sm" len="sm"/>
+          </a:ln>
+        </p:spPr>
+        <p:txBody>
+          <a:bodyPr spcFirstLastPara="1" wrap="square" lIns="91425" tIns="91425" rIns="91425" bIns="91425" anchor="t" anchorCtr="0">
+            <a:noAutofit/>
+          </a:bodyPr>
+          <a:lstStyle/>
+          <a:p>
+            <a:pPr lvl="0"/>
+            <a:r>
+              <a:rPr lang="pt-PT" dirty="0">
+                <a:latin typeface="Consolas"/>
+                <a:ea typeface="Consolas"/>
+                <a:cs typeface="Consolas"/>
+                <a:sym typeface="Consolas"/>
+              </a:rPr>
+              <a:t>T3: Acabar de implementar as diferentes condições climatéricas e fazer o </a:t>
+            </a:r>
+            <a:r>
+              <a:rPr lang="pt-PT" dirty="0" err="1">
+                <a:latin typeface="Consolas"/>
+                <a:ea typeface="Consolas"/>
+                <a:cs typeface="Consolas"/>
+                <a:sym typeface="Consolas"/>
+              </a:rPr>
+              <a:t>review</a:t>
+            </a:r>
+            <a:r>
+              <a:rPr lang="pt-PT" dirty="0">
+                <a:latin typeface="Consolas"/>
+                <a:ea typeface="Consolas"/>
+                <a:cs typeface="Consolas"/>
+                <a:sym typeface="Consolas"/>
+              </a:rPr>
+              <a:t>.</a:t>
+            </a:r>
+            <a:endParaRPr dirty="0">
+              <a:latin typeface="Consolas"/>
+              <a:ea typeface="Consolas"/>
+              <a:cs typeface="Consolas"/>
+              <a:sym typeface="Consolas"/>
+            </a:endParaRPr>
+          </a:p>
+        </p:txBody>
+      </p:sp>
+      <p:sp>
+        <p:nvSpPr>
+          <p:cNvPr id="19" name="Google Shape;86;p15">
+            <a:extLst>
+              <a:ext uri="{FF2B5EF4-FFF2-40B4-BE49-F238E27FC236}">
+                <a16:creationId xmlns:a16="http://schemas.microsoft.com/office/drawing/2014/main" id="{5A9D5649-F694-D8B5-7DC3-7475446F2EB4}"/>
+              </a:ext>
+            </a:extLst>
+          </p:cNvPr>
+          <p:cNvSpPr/>
+          <p:nvPr/>
+        </p:nvSpPr>
+        <p:spPr>
+          <a:xfrm>
+            <a:off x="6113258" y="1294224"/>
+            <a:ext cx="2609591" cy="8864188"/>
+          </a:xfrm>
+          <a:prstGeom prst="roundRect">
+            <a:avLst>
+              <a:gd name="adj" fmla="val 16667"/>
+            </a:avLst>
+          </a:prstGeom>
+          <a:solidFill>
+            <a:srgbClr val="D9EAD3"/>
+          </a:solidFill>
+          <a:ln w="28575" cap="flat" cmpd="sng">
+            <a:solidFill>
+              <a:srgbClr val="274E13"/>
+            </a:solidFill>
+            <a:prstDash val="solid"/>
+            <a:round/>
+            <a:headEnd type="none" w="sm" len="sm"/>
+            <a:tailEnd type="none" w="sm" len="sm"/>
+          </a:ln>
+        </p:spPr>
+        <p:txBody>
+          <a:bodyPr spcFirstLastPara="1" wrap="square" lIns="91425" tIns="91425" rIns="91425" bIns="91425" anchor="t" anchorCtr="0">
+            <a:noAutofit/>
+          </a:bodyPr>
+          <a:lstStyle/>
+          <a:p>
+            <a:pPr marL="0" lvl="0" indent="0" rtl="0">
+              <a:spcBef>
+                <a:spcPts val="0"/>
+              </a:spcBef>
+              <a:spcAft>
+                <a:spcPts val="0"/>
+              </a:spcAft>
+              <a:buNone/>
+            </a:pPr>
+            <a:r>
+              <a:rPr lang="en-GB" dirty="0">
+                <a:latin typeface="Consolas"/>
+                <a:ea typeface="Consolas"/>
+                <a:cs typeface="Consolas"/>
+                <a:sym typeface="Consolas"/>
+              </a:rPr>
+              <a:t>US1: Como </a:t>
+            </a:r>
+            <a:r>
+              <a:rPr lang="en-GB" dirty="0" err="1">
+                <a:latin typeface="Consolas"/>
+                <a:ea typeface="Consolas"/>
+                <a:cs typeface="Consolas"/>
+                <a:sym typeface="Consolas"/>
+              </a:rPr>
+              <a:t>membro</a:t>
+            </a:r>
+            <a:r>
+              <a:rPr lang="en-GB" dirty="0">
+                <a:latin typeface="Consolas"/>
+                <a:ea typeface="Consolas"/>
+                <a:cs typeface="Consolas"/>
+                <a:sym typeface="Consolas"/>
+              </a:rPr>
+              <a:t> da </a:t>
+            </a:r>
+            <a:r>
+              <a:rPr lang="en-GB" dirty="0" err="1">
+                <a:latin typeface="Consolas"/>
+                <a:ea typeface="Consolas"/>
+                <a:cs typeface="Consolas"/>
+                <a:sym typeface="Consolas"/>
+              </a:rPr>
+              <a:t>equipa</a:t>
+            </a:r>
+            <a:r>
+              <a:rPr lang="en-GB" dirty="0">
+                <a:latin typeface="Consolas"/>
+                <a:ea typeface="Consolas"/>
+                <a:cs typeface="Consolas"/>
+                <a:sym typeface="Consolas"/>
+              </a:rPr>
+              <a:t>, </a:t>
+            </a:r>
+            <a:r>
+              <a:rPr lang="en-GB" dirty="0" err="1">
+                <a:latin typeface="Consolas"/>
+                <a:ea typeface="Consolas"/>
+                <a:cs typeface="Consolas"/>
+                <a:sym typeface="Consolas"/>
+              </a:rPr>
+              <a:t>quero</a:t>
+            </a:r>
+            <a:r>
+              <a:rPr lang="en-GB" dirty="0">
+                <a:latin typeface="Consolas"/>
+                <a:ea typeface="Consolas"/>
+                <a:cs typeface="Consolas"/>
+                <a:sym typeface="Consolas"/>
+              </a:rPr>
+              <a:t> </a:t>
+            </a:r>
+            <a:r>
+              <a:rPr lang="en-GB" dirty="0" err="1">
+                <a:latin typeface="Consolas"/>
+                <a:ea typeface="Consolas"/>
+                <a:cs typeface="Consolas"/>
+                <a:sym typeface="Consolas"/>
+              </a:rPr>
+              <a:t>implementar</a:t>
+            </a:r>
+            <a:r>
+              <a:rPr lang="en-GB" dirty="0">
+                <a:latin typeface="Consolas"/>
+                <a:ea typeface="Consolas"/>
+                <a:cs typeface="Consolas"/>
+                <a:sym typeface="Consolas"/>
+              </a:rPr>
+              <a:t> um modo de </a:t>
+            </a:r>
+            <a:r>
+              <a:rPr lang="en-GB" dirty="0" err="1">
+                <a:latin typeface="Consolas"/>
+                <a:ea typeface="Consolas"/>
+                <a:cs typeface="Consolas"/>
+                <a:sym typeface="Consolas"/>
+              </a:rPr>
+              <a:t>jogo</a:t>
+            </a:r>
+            <a:r>
+              <a:rPr lang="en-GB" dirty="0">
+                <a:latin typeface="Consolas"/>
+                <a:ea typeface="Consolas"/>
+                <a:cs typeface="Consolas"/>
+                <a:sym typeface="Consolas"/>
+              </a:rPr>
+              <a:t> </a:t>
+            </a:r>
+            <a:r>
+              <a:rPr lang="en-GB" dirty="0" err="1">
+                <a:latin typeface="Consolas"/>
+                <a:ea typeface="Consolas"/>
+                <a:cs typeface="Consolas"/>
+                <a:sym typeface="Consolas"/>
+              </a:rPr>
+              <a:t>onde</a:t>
+            </a:r>
+            <a:r>
+              <a:rPr lang="en-GB" dirty="0">
+                <a:latin typeface="Consolas"/>
+                <a:ea typeface="Consolas"/>
+                <a:cs typeface="Consolas"/>
+                <a:sym typeface="Consolas"/>
+              </a:rPr>
+              <a:t> o </a:t>
+            </a:r>
+            <a:r>
+              <a:rPr lang="en-GB" dirty="0" err="1">
+                <a:latin typeface="Consolas"/>
+                <a:ea typeface="Consolas"/>
+                <a:cs typeface="Consolas"/>
+                <a:sym typeface="Consolas"/>
+              </a:rPr>
+              <a:t>mapa</a:t>
+            </a:r>
+            <a:r>
+              <a:rPr lang="en-GB" dirty="0">
+                <a:latin typeface="Consolas"/>
+                <a:ea typeface="Consolas"/>
+                <a:cs typeface="Consolas"/>
+                <a:sym typeface="Consolas"/>
+              </a:rPr>
+              <a:t> </a:t>
+            </a:r>
+            <a:r>
+              <a:rPr lang="en-GB" dirty="0" err="1">
+                <a:latin typeface="Consolas"/>
+                <a:ea typeface="Consolas"/>
+                <a:cs typeface="Consolas"/>
+                <a:sym typeface="Consolas"/>
+              </a:rPr>
+              <a:t>muda</a:t>
+            </a:r>
+            <a:r>
+              <a:rPr lang="en-GB" dirty="0">
+                <a:latin typeface="Consolas"/>
+                <a:ea typeface="Consolas"/>
+                <a:cs typeface="Consolas"/>
+                <a:sym typeface="Consolas"/>
+              </a:rPr>
+              <a:t> </a:t>
+            </a:r>
+            <a:r>
+              <a:rPr lang="en-GB" dirty="0" err="1">
+                <a:latin typeface="Consolas"/>
+                <a:ea typeface="Consolas"/>
+                <a:cs typeface="Consolas"/>
+                <a:sym typeface="Consolas"/>
+              </a:rPr>
+              <a:t>semanalmente</a:t>
+            </a:r>
+            <a:r>
+              <a:rPr lang="en-GB" dirty="0">
+                <a:latin typeface="Consolas"/>
+                <a:ea typeface="Consolas"/>
+                <a:cs typeface="Consolas"/>
+                <a:sym typeface="Consolas"/>
+              </a:rPr>
+              <a:t> e </a:t>
+            </a:r>
+            <a:r>
+              <a:rPr lang="en-GB" dirty="0" err="1">
+                <a:latin typeface="Consolas"/>
+                <a:ea typeface="Consolas"/>
+                <a:cs typeface="Consolas"/>
+                <a:sym typeface="Consolas"/>
+              </a:rPr>
+              <a:t>possui</a:t>
+            </a:r>
+            <a:r>
+              <a:rPr lang="en-GB" dirty="0">
+                <a:latin typeface="Consolas"/>
+                <a:ea typeface="Consolas"/>
+                <a:cs typeface="Consolas"/>
+                <a:sym typeface="Consolas"/>
+              </a:rPr>
+              <a:t> um ranking </a:t>
+            </a:r>
+            <a:r>
+              <a:rPr lang="en-GB" dirty="0" err="1">
+                <a:latin typeface="Consolas"/>
+                <a:ea typeface="Consolas"/>
+                <a:cs typeface="Consolas"/>
+                <a:sym typeface="Consolas"/>
+              </a:rPr>
+              <a:t>baseado</a:t>
+            </a:r>
+            <a:r>
+              <a:rPr lang="en-GB" dirty="0">
+                <a:latin typeface="Consolas"/>
+                <a:ea typeface="Consolas"/>
+                <a:cs typeface="Consolas"/>
+                <a:sym typeface="Consolas"/>
+              </a:rPr>
+              <a:t> </a:t>
+            </a:r>
+            <a:r>
+              <a:rPr lang="en-GB" dirty="0" err="1">
+                <a:latin typeface="Consolas"/>
+                <a:ea typeface="Consolas"/>
+                <a:cs typeface="Consolas"/>
+                <a:sym typeface="Consolas"/>
+              </a:rPr>
+              <a:t>na</a:t>
+            </a:r>
+            <a:r>
+              <a:rPr lang="en-GB" dirty="0">
+                <a:latin typeface="Consolas"/>
+                <a:ea typeface="Consolas"/>
+                <a:cs typeface="Consolas"/>
+                <a:sym typeface="Consolas"/>
+              </a:rPr>
+              <a:t> performance.</a:t>
+            </a:r>
+            <a:endParaRPr dirty="0">
+              <a:latin typeface="Consolas"/>
+              <a:ea typeface="Consolas"/>
+              <a:cs typeface="Consolas"/>
+              <a:sym typeface="Consolas"/>
+            </a:endParaRPr>
+          </a:p>
+        </p:txBody>
+      </p:sp>
+      <p:sp>
+        <p:nvSpPr>
+          <p:cNvPr id="20" name="Google Shape;92;p15">
+            <a:extLst>
+              <a:ext uri="{FF2B5EF4-FFF2-40B4-BE49-F238E27FC236}">
+                <a16:creationId xmlns:a16="http://schemas.microsoft.com/office/drawing/2014/main" id="{4AA76463-0120-A363-0737-1D738CF2A3BD}"/>
+              </a:ext>
+            </a:extLst>
+          </p:cNvPr>
+          <p:cNvSpPr/>
+          <p:nvPr/>
+        </p:nvSpPr>
+        <p:spPr>
+          <a:xfrm>
+            <a:off x="6113258" y="3203475"/>
+            <a:ext cx="2609587" cy="7609683"/>
+          </a:xfrm>
+          <a:prstGeom prst="roundRect">
+            <a:avLst>
+              <a:gd name="adj" fmla="val 16667"/>
+            </a:avLst>
+          </a:prstGeom>
+          <a:solidFill>
+            <a:srgbClr val="D9EAD3"/>
+          </a:solidFill>
+          <a:ln w="28575" cap="flat" cmpd="sng">
+            <a:solidFill>
+              <a:srgbClr val="274E13"/>
+            </a:solidFill>
+            <a:prstDash val="solid"/>
+            <a:round/>
+            <a:headEnd type="none" w="sm" len="sm"/>
+            <a:tailEnd type="none" w="sm" len="sm"/>
+          </a:ln>
+        </p:spPr>
+        <p:txBody>
+          <a:bodyPr spcFirstLastPara="1" wrap="square" lIns="91425" tIns="91425" rIns="91425" bIns="91425" anchor="t" anchorCtr="0">
+            <a:noAutofit/>
+          </a:bodyPr>
+          <a:lstStyle/>
+          <a:p>
+            <a:pPr lvl="0"/>
+            <a:r>
+              <a:rPr lang="en-GB" dirty="0">
+                <a:latin typeface="Consolas"/>
+                <a:ea typeface="Consolas"/>
+                <a:cs typeface="Consolas"/>
+                <a:sym typeface="Consolas"/>
+              </a:rPr>
+              <a:t>US2: Como </a:t>
+            </a:r>
+            <a:r>
+              <a:rPr lang="en-GB" dirty="0" err="1">
+                <a:latin typeface="Consolas"/>
+                <a:ea typeface="Consolas"/>
+                <a:cs typeface="Consolas"/>
+                <a:sym typeface="Consolas"/>
+              </a:rPr>
+              <a:t>membro</a:t>
+            </a:r>
+            <a:r>
+              <a:rPr lang="en-GB" dirty="0">
+                <a:latin typeface="Consolas"/>
+                <a:ea typeface="Consolas"/>
+                <a:cs typeface="Consolas"/>
+                <a:sym typeface="Consolas"/>
+              </a:rPr>
+              <a:t> da </a:t>
+            </a:r>
+            <a:r>
+              <a:rPr lang="en-GB" dirty="0" err="1">
+                <a:latin typeface="Consolas"/>
+                <a:ea typeface="Consolas"/>
+                <a:cs typeface="Consolas"/>
+                <a:sym typeface="Consolas"/>
+              </a:rPr>
+              <a:t>equipa</a:t>
+            </a:r>
+            <a:r>
+              <a:rPr lang="en-GB" dirty="0">
+                <a:latin typeface="Consolas"/>
+                <a:ea typeface="Consolas"/>
+                <a:cs typeface="Consolas"/>
+                <a:sym typeface="Consolas"/>
+              </a:rPr>
+              <a:t> </a:t>
+            </a:r>
+            <a:r>
+              <a:rPr lang="en-GB" dirty="0" err="1">
+                <a:latin typeface="Consolas"/>
+                <a:ea typeface="Consolas"/>
+                <a:cs typeface="Consolas"/>
+                <a:sym typeface="Consolas"/>
+              </a:rPr>
+              <a:t>quero</a:t>
+            </a:r>
+            <a:r>
+              <a:rPr lang="pt-PT" dirty="0">
+                <a:latin typeface="Consolas"/>
+                <a:ea typeface="Consolas"/>
+                <a:cs typeface="Consolas"/>
+                <a:sym typeface="Consolas"/>
+              </a:rPr>
+              <a:t> implementar a </a:t>
+            </a:r>
+            <a:r>
+              <a:rPr lang="pt-PT" dirty="0" err="1">
+                <a:latin typeface="Consolas"/>
+                <a:ea typeface="Consolas"/>
+                <a:cs typeface="Consolas"/>
+                <a:sym typeface="Consolas"/>
+              </a:rPr>
+              <a:t>Health</a:t>
+            </a:r>
+            <a:r>
+              <a:rPr lang="pt-PT" dirty="0">
+                <a:latin typeface="Consolas"/>
+                <a:ea typeface="Consolas"/>
+                <a:cs typeface="Consolas"/>
+                <a:sym typeface="Consolas"/>
+              </a:rPr>
+              <a:t> Bar de cada </a:t>
+            </a:r>
+            <a:r>
+              <a:rPr lang="pt-PT" dirty="0" err="1">
+                <a:latin typeface="Consolas"/>
+                <a:ea typeface="Consolas"/>
+                <a:cs typeface="Consolas"/>
+                <a:sym typeface="Consolas"/>
+              </a:rPr>
+              <a:t>wave</a:t>
+            </a:r>
+            <a:r>
+              <a:rPr lang="pt-PT" dirty="0">
+                <a:latin typeface="Consolas"/>
+                <a:ea typeface="Consolas"/>
+                <a:cs typeface="Consolas"/>
+                <a:sym typeface="Consolas"/>
+              </a:rPr>
+              <a:t> de inimigos.</a:t>
+            </a:r>
+            <a:endParaRPr dirty="0">
+              <a:latin typeface="Consolas"/>
+              <a:ea typeface="Consolas"/>
+              <a:cs typeface="Consolas"/>
+              <a:sym typeface="Consolas"/>
+            </a:endParaRPr>
+          </a:p>
+        </p:txBody>
+      </p:sp>
+      <p:sp>
+        <p:nvSpPr>
+          <p:cNvPr id="21" name="Google Shape;92;p15">
+            <a:extLst>
+              <a:ext uri="{FF2B5EF4-FFF2-40B4-BE49-F238E27FC236}">
+                <a16:creationId xmlns:a16="http://schemas.microsoft.com/office/drawing/2014/main" id="{232B6B6E-700E-8286-71A1-6EE06569DF3A}"/>
+              </a:ext>
+            </a:extLst>
+          </p:cNvPr>
+          <p:cNvSpPr/>
+          <p:nvPr/>
+        </p:nvSpPr>
+        <p:spPr>
+          <a:xfrm>
+            <a:off x="6136546" y="4644094"/>
+            <a:ext cx="2609586" cy="6208084"/>
+          </a:xfrm>
+          <a:prstGeom prst="roundRect">
+            <a:avLst>
+              <a:gd name="adj" fmla="val 16667"/>
+            </a:avLst>
+          </a:prstGeom>
+          <a:solidFill>
+            <a:srgbClr val="D9EAD3"/>
+          </a:solidFill>
+          <a:ln w="28575" cap="flat" cmpd="sng">
+            <a:solidFill>
+              <a:srgbClr val="274E13"/>
+            </a:solidFill>
+            <a:prstDash val="solid"/>
+            <a:round/>
+            <a:headEnd type="none" w="sm" len="sm"/>
+            <a:tailEnd type="none" w="sm" len="sm"/>
+          </a:ln>
+        </p:spPr>
+        <p:txBody>
+          <a:bodyPr spcFirstLastPara="1" wrap="square" lIns="91425" tIns="91425" rIns="91425" bIns="91425" anchor="t" anchorCtr="0">
+            <a:noAutofit/>
+          </a:bodyPr>
+          <a:lstStyle/>
+          <a:p>
+            <a:pPr lvl="0"/>
+            <a:r>
+              <a:rPr lang="en-GB" dirty="0">
+                <a:latin typeface="Consolas"/>
+                <a:ea typeface="Consolas"/>
+                <a:cs typeface="Consolas"/>
+                <a:sym typeface="Consolas"/>
+              </a:rPr>
+              <a:t>US3: Como </a:t>
+            </a:r>
+            <a:r>
+              <a:rPr lang="en-GB" dirty="0" err="1">
+                <a:latin typeface="Consolas"/>
+                <a:ea typeface="Consolas"/>
+                <a:cs typeface="Consolas"/>
+                <a:sym typeface="Consolas"/>
+              </a:rPr>
+              <a:t>membro</a:t>
+            </a:r>
+            <a:r>
+              <a:rPr lang="en-GB" dirty="0">
+                <a:latin typeface="Consolas"/>
+                <a:ea typeface="Consolas"/>
+                <a:cs typeface="Consolas"/>
+                <a:sym typeface="Consolas"/>
+              </a:rPr>
+              <a:t> da </a:t>
+            </a:r>
+            <a:r>
+              <a:rPr lang="en-GB" dirty="0" err="1">
+                <a:latin typeface="Consolas"/>
+                <a:ea typeface="Consolas"/>
+                <a:cs typeface="Consolas"/>
+                <a:sym typeface="Consolas"/>
+              </a:rPr>
+              <a:t>equipa</a:t>
+            </a:r>
+            <a:r>
+              <a:rPr lang="en-GB" dirty="0">
+                <a:latin typeface="Consolas"/>
+                <a:ea typeface="Consolas"/>
+                <a:cs typeface="Consolas"/>
+                <a:sym typeface="Consolas"/>
+              </a:rPr>
+              <a:t> </a:t>
+            </a:r>
+            <a:r>
+              <a:rPr lang="en-GB" dirty="0" err="1">
+                <a:latin typeface="Consolas"/>
+                <a:ea typeface="Consolas"/>
+                <a:cs typeface="Consolas"/>
+                <a:sym typeface="Consolas"/>
+              </a:rPr>
+              <a:t>quero</a:t>
+            </a:r>
+            <a:r>
+              <a:rPr lang="pt-PT" dirty="0">
+                <a:latin typeface="Consolas"/>
+                <a:ea typeface="Consolas"/>
+                <a:cs typeface="Consolas"/>
+                <a:sym typeface="Consolas"/>
+              </a:rPr>
+              <a:t> implementar as diferentes condições climatéricas.</a:t>
+            </a:r>
+          </a:p>
+        </p:txBody>
+      </p:sp>
+      <p:sp>
+        <p:nvSpPr>
+          <p:cNvPr id="8" name="Google Shape;121;p16">
+            <a:extLst>
+              <a:ext uri="{FF2B5EF4-FFF2-40B4-BE49-F238E27FC236}">
+                <a16:creationId xmlns:a16="http://schemas.microsoft.com/office/drawing/2014/main" id="{805A6E3C-76D1-F106-727D-8DB93F2D4F85}"/>
+              </a:ext>
+            </a:extLst>
+          </p:cNvPr>
+          <p:cNvSpPr/>
+          <p:nvPr/>
+        </p:nvSpPr>
+        <p:spPr>
+          <a:xfrm>
+            <a:off x="18725151" y="1021952"/>
+            <a:ext cx="2410800" cy="2657243"/>
+          </a:xfrm>
+          <a:prstGeom prst="roundRect">
+            <a:avLst>
+              <a:gd name="adj" fmla="val 16667"/>
+            </a:avLst>
+          </a:prstGeom>
+          <a:solidFill>
+            <a:srgbClr val="D0E0E3"/>
+          </a:solidFill>
+          <a:ln w="28575" cap="flat" cmpd="sng">
+            <a:solidFill>
+              <a:srgbClr val="134F5C"/>
+            </a:solidFill>
+            <a:prstDash val="solid"/>
+            <a:round/>
+            <a:headEnd type="none" w="sm" len="sm"/>
+            <a:tailEnd type="none" w="sm" len="sm"/>
+          </a:ln>
+        </p:spPr>
+        <p:txBody>
+          <a:bodyPr spcFirstLastPara="1" wrap="square" lIns="91425" tIns="91425" rIns="91425" bIns="91425" anchor="t" anchorCtr="0">
+            <a:noAutofit/>
+          </a:bodyPr>
+          <a:lstStyle/>
+          <a:p>
+            <a:r>
+              <a:rPr lang="en-GB" dirty="0">
+                <a:latin typeface="Consolas"/>
+                <a:ea typeface="Consolas"/>
+                <a:cs typeface="Consolas"/>
+                <a:sym typeface="Consolas"/>
+              </a:rPr>
+              <a:t>T1: </a:t>
+            </a:r>
+            <a:r>
+              <a:rPr lang="pt-PT" dirty="0">
+                <a:latin typeface="Consolas"/>
+                <a:ea typeface="Consolas"/>
+                <a:cs typeface="Consolas"/>
+                <a:sym typeface="Consolas"/>
+              </a:rPr>
+              <a:t>Fazer Interface de Rankings e “jogar Desafio Semanal”</a:t>
+            </a:r>
+            <a:br>
+              <a:rPr lang="en-GB" dirty="0">
+                <a:latin typeface="Consolas"/>
+                <a:ea typeface="Consolas"/>
+                <a:cs typeface="Consolas"/>
+                <a:sym typeface="Consolas"/>
+              </a:rPr>
+            </a:br>
+            <a:br>
+              <a:rPr lang="en-GB" dirty="0">
+                <a:latin typeface="Consolas"/>
+                <a:ea typeface="Consolas"/>
+                <a:cs typeface="Consolas"/>
+                <a:sym typeface="Consolas"/>
+              </a:rPr>
+            </a:br>
+            <a:endParaRPr lang="en-GB" dirty="0">
+              <a:latin typeface="Consolas"/>
+              <a:ea typeface="Consolas"/>
+              <a:cs typeface="Consolas"/>
+              <a:sym typeface="Consolas"/>
+            </a:endParaRPr>
+          </a:p>
+          <a:p>
+            <a:pPr marL="0" lvl="0" indent="0" algn="l" rtl="0">
+              <a:spcBef>
+                <a:spcPts val="0"/>
+              </a:spcBef>
+              <a:spcAft>
+                <a:spcPts val="0"/>
+              </a:spcAft>
+              <a:buNone/>
+            </a:pPr>
+            <a:endParaRPr dirty="0">
+              <a:latin typeface="Consolas"/>
+              <a:ea typeface="Consolas"/>
+              <a:cs typeface="Consolas"/>
+              <a:sym typeface="Consolas"/>
+            </a:endParaRPr>
+          </a:p>
+        </p:txBody>
+      </p:sp>
+      <p:sp>
+        <p:nvSpPr>
+          <p:cNvPr id="9" name="Google Shape;121;p16">
+            <a:extLst>
+              <a:ext uri="{FF2B5EF4-FFF2-40B4-BE49-F238E27FC236}">
+                <a16:creationId xmlns:a16="http://schemas.microsoft.com/office/drawing/2014/main" id="{28C1938A-8197-12AB-8260-ED0931FE9A60}"/>
+              </a:ext>
+            </a:extLst>
+          </p:cNvPr>
+          <p:cNvSpPr/>
+          <p:nvPr/>
+        </p:nvSpPr>
+        <p:spPr>
+          <a:xfrm>
+            <a:off x="12423686" y="5744289"/>
+            <a:ext cx="2410800" cy="1215821"/>
+          </a:xfrm>
+          <a:prstGeom prst="roundRect">
+            <a:avLst>
+              <a:gd name="adj" fmla="val 16667"/>
+            </a:avLst>
+          </a:prstGeom>
+          <a:solidFill>
+            <a:srgbClr val="D0E0E3"/>
+          </a:solidFill>
+          <a:ln w="28575" cap="flat" cmpd="sng">
+            <a:solidFill>
+              <a:srgbClr val="134F5C"/>
+            </a:solidFill>
+            <a:prstDash val="solid"/>
+            <a:round/>
+            <a:headEnd type="none" w="sm" len="sm"/>
+            <a:tailEnd type="none" w="sm" len="sm"/>
+          </a:ln>
+        </p:spPr>
+        <p:txBody>
+          <a:bodyPr spcFirstLastPara="1" wrap="square" lIns="91425" tIns="91425" rIns="91425" bIns="91425" anchor="t" anchorCtr="0">
+            <a:noAutofit/>
+          </a:bodyPr>
+          <a:lstStyle/>
+          <a:p>
+            <a:r>
+              <a:rPr lang="pt-PT" dirty="0">
+                <a:latin typeface="Consolas"/>
+                <a:ea typeface="Consolas"/>
+                <a:cs typeface="Consolas"/>
+                <a:sym typeface="Consolas"/>
+              </a:rPr>
+              <a:t>T2: Implementar a </a:t>
+            </a:r>
+            <a:r>
+              <a:rPr lang="pt-PT" dirty="0" err="1">
+                <a:latin typeface="Consolas"/>
+                <a:ea typeface="Consolas"/>
+                <a:cs typeface="Consolas"/>
+                <a:sym typeface="Consolas"/>
+              </a:rPr>
+              <a:t>Health</a:t>
+            </a:r>
+            <a:r>
+              <a:rPr lang="pt-PT" dirty="0">
+                <a:latin typeface="Consolas"/>
+                <a:ea typeface="Consolas"/>
+                <a:cs typeface="Consolas"/>
+                <a:sym typeface="Consolas"/>
+              </a:rPr>
+              <a:t> Bar de cada </a:t>
+            </a:r>
+            <a:r>
+              <a:rPr lang="pt-PT" dirty="0" err="1">
+                <a:latin typeface="Consolas"/>
+                <a:ea typeface="Consolas"/>
+                <a:cs typeface="Consolas"/>
+                <a:sym typeface="Consolas"/>
+              </a:rPr>
+              <a:t>wave</a:t>
+            </a:r>
+            <a:r>
+              <a:rPr lang="pt-PT" dirty="0">
+                <a:latin typeface="Consolas"/>
+                <a:ea typeface="Consolas"/>
+                <a:cs typeface="Consolas"/>
+                <a:sym typeface="Consolas"/>
+              </a:rPr>
+              <a:t> de inimigos.</a:t>
+            </a:r>
+          </a:p>
+          <a:p>
+            <a:r>
+              <a:rPr lang="en-GB" dirty="0">
+                <a:latin typeface="Consolas"/>
+                <a:ea typeface="Consolas"/>
+                <a:cs typeface="Consolas"/>
+                <a:sym typeface="Consolas"/>
+              </a:rPr>
+              <a:t> </a:t>
+            </a:r>
+            <a:br>
+              <a:rPr lang="en-GB" dirty="0">
+                <a:latin typeface="Consolas"/>
+                <a:ea typeface="Consolas"/>
+                <a:cs typeface="Consolas"/>
+                <a:sym typeface="Consolas"/>
+              </a:rPr>
+            </a:br>
+            <a:br>
+              <a:rPr lang="en-GB" dirty="0">
+                <a:latin typeface="Consolas"/>
+                <a:ea typeface="Consolas"/>
+                <a:cs typeface="Consolas"/>
+                <a:sym typeface="Consolas"/>
+              </a:rPr>
+            </a:br>
+            <a:endParaRPr lang="en-GB" dirty="0">
+              <a:latin typeface="Consolas"/>
+              <a:ea typeface="Consolas"/>
+              <a:cs typeface="Consolas"/>
+              <a:sym typeface="Consolas"/>
+            </a:endParaRPr>
+          </a:p>
+          <a:p>
+            <a:pPr marL="0" lvl="0" indent="0" algn="l" rtl="0">
+              <a:spcBef>
+                <a:spcPts val="0"/>
+              </a:spcBef>
+              <a:spcAft>
+                <a:spcPts val="0"/>
+              </a:spcAft>
+              <a:buNone/>
+            </a:pPr>
+            <a:endParaRPr dirty="0">
+              <a:latin typeface="Consolas"/>
+              <a:ea typeface="Consolas"/>
+              <a:cs typeface="Consolas"/>
+              <a:sym typeface="Consolas"/>
+            </a:endParaRPr>
+          </a:p>
+        </p:txBody>
+      </p:sp>
+      <p:sp>
+        <p:nvSpPr>
+          <p:cNvPr id="10" name="Google Shape;121;p16">
+            <a:extLst>
+              <a:ext uri="{FF2B5EF4-FFF2-40B4-BE49-F238E27FC236}">
+                <a16:creationId xmlns:a16="http://schemas.microsoft.com/office/drawing/2014/main" id="{A9886EED-CED5-BB23-19B3-3BF9AAFDA0BE}"/>
+              </a:ext>
+            </a:extLst>
+          </p:cNvPr>
+          <p:cNvSpPr/>
+          <p:nvPr/>
+        </p:nvSpPr>
+        <p:spPr>
+          <a:xfrm>
+            <a:off x="12395940" y="4165308"/>
+            <a:ext cx="2410800" cy="749592"/>
+          </a:xfrm>
+          <a:prstGeom prst="roundRect">
+            <a:avLst>
+              <a:gd name="adj" fmla="val 16667"/>
+            </a:avLst>
+          </a:prstGeom>
+          <a:solidFill>
+            <a:srgbClr val="D0E0E3"/>
+          </a:solidFill>
+          <a:ln w="28575" cap="flat" cmpd="sng">
+            <a:solidFill>
+              <a:srgbClr val="134F5C"/>
+            </a:solidFill>
+            <a:prstDash val="solid"/>
+            <a:round/>
+            <a:headEnd type="none" w="sm" len="sm"/>
+            <a:tailEnd type="none" w="sm" len="sm"/>
+          </a:ln>
+        </p:spPr>
+        <p:txBody>
+          <a:bodyPr spcFirstLastPara="1" wrap="square" lIns="91425" tIns="91425" rIns="91425" bIns="91425" anchor="t" anchorCtr="0">
+            <a:noAutofit/>
+          </a:bodyPr>
+          <a:lstStyle/>
+          <a:p>
+            <a:r>
+              <a:rPr lang="pt-PT" dirty="0">
+                <a:latin typeface="Consolas"/>
+                <a:ea typeface="Consolas"/>
+                <a:cs typeface="Consolas"/>
+                <a:sym typeface="Consolas"/>
+              </a:rPr>
+              <a:t>T3: Implementar a parte do Terramoto.</a:t>
+            </a:r>
+          </a:p>
+          <a:p>
+            <a:r>
+              <a:rPr lang="en-GB" dirty="0">
+                <a:latin typeface="Consolas"/>
+                <a:ea typeface="Consolas"/>
+                <a:cs typeface="Consolas"/>
+                <a:sym typeface="Consolas"/>
+              </a:rPr>
+              <a:t> </a:t>
+            </a:r>
+            <a:br>
+              <a:rPr lang="en-GB" dirty="0">
+                <a:latin typeface="Consolas"/>
+                <a:ea typeface="Consolas"/>
+                <a:cs typeface="Consolas"/>
+                <a:sym typeface="Consolas"/>
+              </a:rPr>
+            </a:br>
+            <a:br>
+              <a:rPr lang="en-GB" dirty="0">
+                <a:latin typeface="Consolas"/>
+                <a:ea typeface="Consolas"/>
+                <a:cs typeface="Consolas"/>
+                <a:sym typeface="Consolas"/>
+              </a:rPr>
+            </a:br>
+            <a:endParaRPr lang="en-GB" dirty="0">
+              <a:latin typeface="Consolas"/>
+              <a:ea typeface="Consolas"/>
+              <a:cs typeface="Consolas"/>
+              <a:sym typeface="Consolas"/>
+            </a:endParaRPr>
+          </a:p>
+          <a:p>
+            <a:pPr marL="0" lvl="0" indent="0" algn="l" rtl="0">
+              <a:spcBef>
+                <a:spcPts val="0"/>
+              </a:spcBef>
+              <a:spcAft>
+                <a:spcPts val="0"/>
+              </a:spcAft>
+              <a:buNone/>
+            </a:pPr>
+            <a:endParaRPr dirty="0">
+              <a:latin typeface="Consolas"/>
+              <a:ea typeface="Consolas"/>
+              <a:cs typeface="Consolas"/>
+              <a:sym typeface="Consolas"/>
+            </a:endParaRPr>
+          </a:p>
+        </p:txBody>
+      </p:sp>
+      <p:sp>
+        <p:nvSpPr>
+          <p:cNvPr id="11" name="Google Shape;121;p16">
+            <a:extLst>
+              <a:ext uri="{FF2B5EF4-FFF2-40B4-BE49-F238E27FC236}">
+                <a16:creationId xmlns:a16="http://schemas.microsoft.com/office/drawing/2014/main" id="{EBE4B65A-AE86-108F-6788-C23D95550E8C}"/>
+              </a:ext>
+            </a:extLst>
+          </p:cNvPr>
+          <p:cNvSpPr/>
+          <p:nvPr/>
+        </p:nvSpPr>
+        <p:spPr>
+          <a:xfrm>
+            <a:off x="12395940" y="4784311"/>
+            <a:ext cx="2410800" cy="749592"/>
+          </a:xfrm>
+          <a:prstGeom prst="roundRect">
+            <a:avLst>
+              <a:gd name="adj" fmla="val 16667"/>
+            </a:avLst>
+          </a:prstGeom>
+          <a:solidFill>
+            <a:srgbClr val="D0E0E3"/>
+          </a:solidFill>
+          <a:ln w="28575" cap="flat" cmpd="sng">
+            <a:solidFill>
+              <a:srgbClr val="134F5C"/>
+            </a:solidFill>
+            <a:prstDash val="solid"/>
+            <a:round/>
+            <a:headEnd type="none" w="sm" len="sm"/>
+            <a:tailEnd type="none" w="sm" len="sm"/>
+          </a:ln>
+        </p:spPr>
+        <p:txBody>
+          <a:bodyPr spcFirstLastPara="1" wrap="square" lIns="91425" tIns="91425" rIns="91425" bIns="91425" anchor="t" anchorCtr="0">
+            <a:noAutofit/>
+          </a:bodyPr>
+          <a:lstStyle/>
+          <a:p>
+            <a:r>
+              <a:rPr lang="pt-PT" dirty="0">
+                <a:latin typeface="Consolas"/>
+                <a:ea typeface="Consolas"/>
+                <a:cs typeface="Consolas"/>
+                <a:sym typeface="Consolas"/>
+              </a:rPr>
+              <a:t>T3: Implementar a parte do Tsunami.</a:t>
+            </a:r>
+          </a:p>
+          <a:p>
+            <a:r>
+              <a:rPr lang="en-GB" dirty="0">
+                <a:latin typeface="Consolas"/>
+                <a:ea typeface="Consolas"/>
+                <a:cs typeface="Consolas"/>
+                <a:sym typeface="Consolas"/>
+              </a:rPr>
+              <a:t> </a:t>
+            </a:r>
+            <a:br>
+              <a:rPr lang="en-GB" dirty="0">
+                <a:latin typeface="Consolas"/>
+                <a:ea typeface="Consolas"/>
+                <a:cs typeface="Consolas"/>
+                <a:sym typeface="Consolas"/>
+              </a:rPr>
+            </a:br>
+            <a:br>
+              <a:rPr lang="en-GB" dirty="0">
+                <a:latin typeface="Consolas"/>
+                <a:ea typeface="Consolas"/>
+                <a:cs typeface="Consolas"/>
+                <a:sym typeface="Consolas"/>
+              </a:rPr>
+            </a:br>
+            <a:endParaRPr lang="en-GB" dirty="0">
+              <a:latin typeface="Consolas"/>
+              <a:ea typeface="Consolas"/>
+              <a:cs typeface="Consolas"/>
+              <a:sym typeface="Consolas"/>
+            </a:endParaRPr>
+          </a:p>
+          <a:p>
+            <a:pPr marL="0" lvl="0" indent="0" algn="l" rtl="0">
+              <a:spcBef>
+                <a:spcPts val="0"/>
+              </a:spcBef>
+              <a:spcAft>
+                <a:spcPts val="0"/>
+              </a:spcAft>
+              <a:buNone/>
+            </a:pPr>
+            <a:endParaRPr dirty="0">
+              <a:latin typeface="Consolas"/>
+              <a:ea typeface="Consolas"/>
+              <a:cs typeface="Consolas"/>
+              <a:sym typeface="Consolas"/>
+            </a:endParaRPr>
+          </a:p>
+        </p:txBody>
+      </p:sp>
+      <p:sp>
+        <p:nvSpPr>
+          <p:cNvPr id="18" name="Google Shape;121;p16">
+            <a:extLst>
+              <a:ext uri="{FF2B5EF4-FFF2-40B4-BE49-F238E27FC236}">
+                <a16:creationId xmlns:a16="http://schemas.microsoft.com/office/drawing/2014/main" id="{F0FA35D7-9139-A2A0-6CC2-62013B2B0BBD}"/>
+              </a:ext>
+            </a:extLst>
+          </p:cNvPr>
+          <p:cNvSpPr/>
+          <p:nvPr/>
+        </p:nvSpPr>
+        <p:spPr>
+          <a:xfrm>
+            <a:off x="12423686" y="8891469"/>
+            <a:ext cx="2410800" cy="1215821"/>
+          </a:xfrm>
+          <a:prstGeom prst="roundRect">
+            <a:avLst>
+              <a:gd name="adj" fmla="val 16667"/>
+            </a:avLst>
+          </a:prstGeom>
+          <a:solidFill>
+            <a:srgbClr val="D0E0E3"/>
+          </a:solidFill>
+          <a:ln w="28575" cap="flat" cmpd="sng">
+            <a:solidFill>
+              <a:srgbClr val="134F5C"/>
+            </a:solidFill>
+            <a:prstDash val="solid"/>
+            <a:round/>
+            <a:headEnd type="none" w="sm" len="sm"/>
+            <a:tailEnd type="none" w="sm" len="sm"/>
+          </a:ln>
+        </p:spPr>
+        <p:txBody>
+          <a:bodyPr spcFirstLastPara="1" wrap="square" lIns="91425" tIns="91425" rIns="91425" bIns="91425" anchor="t" anchorCtr="0">
+            <a:noAutofit/>
+          </a:bodyPr>
+          <a:lstStyle/>
+          <a:p>
+            <a:r>
+              <a:rPr lang="pt-PT" dirty="0">
+                <a:latin typeface="Consolas"/>
+                <a:ea typeface="Consolas"/>
+                <a:cs typeface="Consolas"/>
+                <a:sym typeface="Consolas"/>
+              </a:rPr>
+              <a:t>T2: Implementar a </a:t>
+            </a:r>
+            <a:r>
+              <a:rPr lang="pt-PT" dirty="0" err="1">
+                <a:latin typeface="Consolas"/>
+                <a:ea typeface="Consolas"/>
+                <a:cs typeface="Consolas"/>
+                <a:sym typeface="Consolas"/>
+              </a:rPr>
+              <a:t>Health</a:t>
+            </a:r>
+            <a:r>
+              <a:rPr lang="pt-PT" dirty="0">
+                <a:latin typeface="Consolas"/>
+                <a:ea typeface="Consolas"/>
+                <a:cs typeface="Consolas"/>
+                <a:sym typeface="Consolas"/>
+              </a:rPr>
+              <a:t> Bar de cada </a:t>
+            </a:r>
+            <a:r>
+              <a:rPr lang="pt-PT" dirty="0" err="1">
+                <a:latin typeface="Consolas"/>
+                <a:ea typeface="Consolas"/>
+                <a:cs typeface="Consolas"/>
+                <a:sym typeface="Consolas"/>
+              </a:rPr>
+              <a:t>wave</a:t>
+            </a:r>
+            <a:r>
+              <a:rPr lang="pt-PT" dirty="0">
+                <a:latin typeface="Consolas"/>
+                <a:ea typeface="Consolas"/>
+                <a:cs typeface="Consolas"/>
+                <a:sym typeface="Consolas"/>
+              </a:rPr>
+              <a:t> de inimigos.</a:t>
+            </a:r>
+          </a:p>
+          <a:p>
+            <a:r>
+              <a:rPr lang="en-GB" dirty="0">
+                <a:latin typeface="Consolas"/>
+                <a:ea typeface="Consolas"/>
+                <a:cs typeface="Consolas"/>
+                <a:sym typeface="Consolas"/>
+              </a:rPr>
+              <a:t> </a:t>
+            </a:r>
+            <a:br>
+              <a:rPr lang="en-GB" dirty="0">
+                <a:latin typeface="Consolas"/>
+                <a:ea typeface="Consolas"/>
+                <a:cs typeface="Consolas"/>
+                <a:sym typeface="Consolas"/>
+              </a:rPr>
+            </a:br>
+            <a:br>
+              <a:rPr lang="en-GB" dirty="0">
+                <a:latin typeface="Consolas"/>
+                <a:ea typeface="Consolas"/>
+                <a:cs typeface="Consolas"/>
+                <a:sym typeface="Consolas"/>
+              </a:rPr>
+            </a:br>
+            <a:endParaRPr lang="en-GB" dirty="0">
+              <a:latin typeface="Consolas"/>
+              <a:ea typeface="Consolas"/>
+              <a:cs typeface="Consolas"/>
+              <a:sym typeface="Consolas"/>
+            </a:endParaRPr>
+          </a:p>
+          <a:p>
+            <a:pPr marL="0" lvl="0" indent="0" algn="l" rtl="0">
+              <a:spcBef>
+                <a:spcPts val="0"/>
+              </a:spcBef>
+              <a:spcAft>
+                <a:spcPts val="0"/>
+              </a:spcAft>
+              <a:buNone/>
+            </a:pPr>
+            <a:endParaRPr dirty="0">
+              <a:latin typeface="Consolas"/>
+              <a:ea typeface="Consolas"/>
+              <a:cs typeface="Consolas"/>
+              <a:sym typeface="Consolas"/>
+            </a:endParaRPr>
+          </a:p>
+        </p:txBody>
+      </p:sp>
+      <p:sp>
+        <p:nvSpPr>
+          <p:cNvPr id="22" name="Google Shape;121;p16">
+            <a:extLst>
+              <a:ext uri="{FF2B5EF4-FFF2-40B4-BE49-F238E27FC236}">
+                <a16:creationId xmlns:a16="http://schemas.microsoft.com/office/drawing/2014/main" id="{2DA60474-BBB9-8711-8A19-AE7C60FA91EB}"/>
+              </a:ext>
+            </a:extLst>
+          </p:cNvPr>
+          <p:cNvSpPr/>
+          <p:nvPr/>
+        </p:nvSpPr>
+        <p:spPr>
+          <a:xfrm>
+            <a:off x="12423686" y="7368613"/>
+            <a:ext cx="2410800" cy="1215821"/>
+          </a:xfrm>
+          <a:prstGeom prst="roundRect">
+            <a:avLst>
+              <a:gd name="adj" fmla="val 16667"/>
+            </a:avLst>
+          </a:prstGeom>
+          <a:solidFill>
+            <a:srgbClr val="D0E0E3"/>
+          </a:solidFill>
+          <a:ln w="28575" cap="flat" cmpd="sng">
+            <a:solidFill>
+              <a:srgbClr val="134F5C"/>
+            </a:solidFill>
+            <a:prstDash val="solid"/>
+            <a:round/>
+            <a:headEnd type="none" w="sm" len="sm"/>
+            <a:tailEnd type="none" w="sm" len="sm"/>
+          </a:ln>
+        </p:spPr>
+        <p:txBody>
+          <a:bodyPr spcFirstLastPara="1" wrap="square" lIns="91425" tIns="91425" rIns="91425" bIns="91425" anchor="t" anchorCtr="0">
+            <a:noAutofit/>
+          </a:bodyPr>
+          <a:lstStyle/>
+          <a:p>
+            <a:r>
+              <a:rPr lang="pt-PT" dirty="0">
+                <a:latin typeface="Consolas"/>
+                <a:ea typeface="Consolas"/>
+                <a:cs typeface="Consolas"/>
+                <a:sym typeface="Consolas"/>
+              </a:rPr>
+              <a:t>T3: Implementar a parte do Meteorito. </a:t>
+            </a:r>
+          </a:p>
+          <a:p>
+            <a:r>
+              <a:rPr lang="en-GB" dirty="0">
+                <a:latin typeface="Consolas"/>
+                <a:ea typeface="Consolas"/>
+                <a:cs typeface="Consolas"/>
+                <a:sym typeface="Consolas"/>
+              </a:rPr>
+              <a:t> </a:t>
+            </a:r>
+            <a:br>
+              <a:rPr lang="en-GB" dirty="0">
+                <a:latin typeface="Consolas"/>
+                <a:ea typeface="Consolas"/>
+                <a:cs typeface="Consolas"/>
+                <a:sym typeface="Consolas"/>
+              </a:rPr>
+            </a:br>
+            <a:br>
+              <a:rPr lang="en-GB" dirty="0">
+                <a:latin typeface="Consolas"/>
+                <a:ea typeface="Consolas"/>
+                <a:cs typeface="Consolas"/>
+                <a:sym typeface="Consolas"/>
+              </a:rPr>
+            </a:br>
+            <a:endParaRPr lang="en-GB" dirty="0">
+              <a:latin typeface="Consolas"/>
+              <a:ea typeface="Consolas"/>
+              <a:cs typeface="Consolas"/>
+              <a:sym typeface="Consolas"/>
+            </a:endParaRPr>
+          </a:p>
+          <a:p>
+            <a:pPr marL="0" lvl="0" indent="0" algn="l" rtl="0">
+              <a:spcBef>
+                <a:spcPts val="0"/>
+              </a:spcBef>
+              <a:spcAft>
+                <a:spcPts val="0"/>
+              </a:spcAft>
+              <a:buNone/>
+            </a:pPr>
+            <a:endParaRPr lang="en-GB" dirty="0">
+              <a:latin typeface="Consolas"/>
+              <a:ea typeface="Consolas"/>
+              <a:cs typeface="Consolas"/>
+              <a:sym typeface="Consolas"/>
+            </a:endParaRPr>
+          </a:p>
+        </p:txBody>
+      </p:sp>
+      <p:sp>
+        <p:nvSpPr>
+          <p:cNvPr id="24" name="Google Shape;121;p16">
+            <a:extLst>
+              <a:ext uri="{FF2B5EF4-FFF2-40B4-BE49-F238E27FC236}">
+                <a16:creationId xmlns:a16="http://schemas.microsoft.com/office/drawing/2014/main" id="{9AB6F074-F751-26EF-7D7D-8737CC46C84E}"/>
+              </a:ext>
+            </a:extLst>
+          </p:cNvPr>
+          <p:cNvSpPr/>
+          <p:nvPr/>
+        </p:nvSpPr>
+        <p:spPr>
+          <a:xfrm>
+            <a:off x="12395940" y="932272"/>
+            <a:ext cx="2410800" cy="2657243"/>
+          </a:xfrm>
+          <a:prstGeom prst="roundRect">
+            <a:avLst>
+              <a:gd name="adj" fmla="val 16667"/>
+            </a:avLst>
+          </a:prstGeom>
+          <a:solidFill>
+            <a:srgbClr val="D0E0E3"/>
+          </a:solidFill>
+          <a:ln w="28575" cap="flat" cmpd="sng">
+            <a:solidFill>
+              <a:srgbClr val="134F5C"/>
+            </a:solidFill>
+            <a:prstDash val="solid"/>
+            <a:round/>
+            <a:headEnd type="none" w="sm" len="sm"/>
+            <a:tailEnd type="none" w="sm" len="sm"/>
+          </a:ln>
+        </p:spPr>
+        <p:txBody>
+          <a:bodyPr spcFirstLastPara="1" wrap="square" lIns="91425" tIns="91425" rIns="91425" bIns="91425" anchor="t" anchorCtr="0">
+            <a:noAutofit/>
+          </a:bodyPr>
+          <a:lstStyle/>
+          <a:p>
+            <a:r>
+              <a:rPr lang="en-GB" dirty="0">
+                <a:latin typeface="Consolas"/>
+                <a:ea typeface="Consolas"/>
+                <a:cs typeface="Consolas"/>
+                <a:sym typeface="Consolas"/>
+              </a:rPr>
+              <a:t>T1: </a:t>
+            </a:r>
+            <a:r>
+              <a:rPr lang="pt-PT" dirty="0">
+                <a:latin typeface="Consolas"/>
+                <a:ea typeface="Consolas"/>
+                <a:cs typeface="Consolas"/>
+                <a:sym typeface="Consolas"/>
+              </a:rPr>
+              <a:t>Implementar um gerador de mapa semanal.</a:t>
+            </a:r>
+            <a:br>
+              <a:rPr lang="en-GB" dirty="0">
+                <a:latin typeface="Consolas"/>
+                <a:ea typeface="Consolas"/>
+                <a:cs typeface="Consolas"/>
+                <a:sym typeface="Consolas"/>
+              </a:rPr>
+            </a:br>
+            <a:br>
+              <a:rPr lang="en-GB" dirty="0">
+                <a:latin typeface="Consolas"/>
+                <a:ea typeface="Consolas"/>
+                <a:cs typeface="Consolas"/>
+                <a:sym typeface="Consolas"/>
+              </a:rPr>
+            </a:br>
+            <a:endParaRPr lang="en-GB" dirty="0">
+              <a:latin typeface="Consolas"/>
+              <a:ea typeface="Consolas"/>
+              <a:cs typeface="Consolas"/>
+              <a:sym typeface="Consolas"/>
+            </a:endParaRPr>
+          </a:p>
+          <a:p>
+            <a:pPr marL="0" lvl="0" indent="0" algn="l" rtl="0">
+              <a:spcBef>
+                <a:spcPts val="0"/>
+              </a:spcBef>
+              <a:spcAft>
+                <a:spcPts val="0"/>
+              </a:spcAft>
+              <a:buNone/>
+            </a:pPr>
+            <a:endParaRPr dirty="0">
+              <a:latin typeface="Consolas"/>
+              <a:ea typeface="Consolas"/>
+              <a:cs typeface="Consolas"/>
+              <a:sym typeface="Consolas"/>
+            </a:endParaRPr>
+          </a:p>
+        </p:txBody>
+      </p:sp>
+    </p:spTree>
+    <p:extLst>
+      <p:ext uri="{BB962C8B-B14F-4D97-AF65-F5344CB8AC3E}">
+        <p14:creationId xmlns:p14="http://schemas.microsoft.com/office/powerpoint/2010/main" val="1626798297"/>
+      </p:ext>
+    </p:extLst>
+  </p:cSld>
+  <p:clrMapOvr>
+    <a:masterClrMapping/>
+  </p:clrMapOvr>
+</p:sld>
+</file>
+
 <file path=ppt/slides/slide3.xml><?xml version="1.0" encoding="utf-8"?>
 <p:sld xmlns:a="http://schemas.openxmlformats.org/drawingml/2006/main" xmlns:r="http://schemas.openxmlformats.org/officeDocument/2006/relationships" xmlns:p="http://schemas.openxmlformats.org/presentationml/2006/main">
   <p:cSld>

</xml_diff>

<commit_message>
Scrum board middle Sprint 6
</commit_message>
<xml_diff>
--- a/SE202526/Management/Scrum Board.pptx
+++ b/SE202526/Management/Scrum Board.pptx
@@ -5,7 +5,7 @@
     <p:sldMasterId id="2147483659" r:id="rId1"/>
   </p:sldMasterIdLst>
   <p:notesMasterIdLst>
-    <p:notesMasterId r:id="rId24"/>
+    <p:notesMasterId r:id="rId25"/>
   </p:notesMasterIdLst>
   <p:sldIdLst>
     <p:sldId id="256" r:id="rId2"/>
@@ -30,6 +30,7 @@
     <p:sldId id="277" r:id="rId21"/>
     <p:sldId id="279" r:id="rId22"/>
     <p:sldId id="280" r:id="rId23"/>
+    <p:sldId id="281" r:id="rId24"/>
   </p:sldIdLst>
   <p:sldSz cx="21599525" cy="10799763"/>
   <p:notesSz cx="6858000" cy="9144000"/>
@@ -2572,6 +2573,133 @@
     <p:extLst>
       <p:ext uri="{BB962C8B-B14F-4D97-AF65-F5344CB8AC3E}">
         <p14:creationId xmlns:p14="http://schemas.microsoft.com/office/powerpoint/2010/main" val="2467119470"/>
+      </p:ext>
+    </p:extLst>
+  </p:cSld>
+  <p:clrMapOvr>
+    <a:masterClrMapping/>
+  </p:clrMapOvr>
+</p:notes>
+</file>
+
+<file path=ppt/notesSlides/notesSlide23.xml><?xml version="1.0" encoding="utf-8"?>
+<p:notes xmlns:a="http://schemas.openxmlformats.org/drawingml/2006/main" xmlns:r="http://schemas.openxmlformats.org/officeDocument/2006/relationships" xmlns:p="http://schemas.openxmlformats.org/presentationml/2006/main" showMasterSp="0" showMasterPhAnim="0">
+  <p:cSld>
+    <p:spTree>
+      <p:nvGrpSpPr>
+        <p:cNvPr id="1" name="Shape 186">
+          <a:extLst>
+            <a:ext uri="{FF2B5EF4-FFF2-40B4-BE49-F238E27FC236}">
+              <a16:creationId xmlns:a16="http://schemas.microsoft.com/office/drawing/2014/main" id="{606F21FA-2B21-6043-B52D-E3DD9BD5D28E}"/>
+            </a:ext>
+          </a:extLst>
+        </p:cNvPr>
+        <p:cNvGrpSpPr/>
+        <p:nvPr/>
+      </p:nvGrpSpPr>
+      <p:grpSpPr>
+        <a:xfrm>
+          <a:off x="0" y="0"/>
+          <a:ext cx="0" cy="0"/>
+          <a:chOff x="0" y="0"/>
+          <a:chExt cx="0" cy="0"/>
+        </a:xfrm>
+      </p:grpSpPr>
+      <p:sp>
+        <p:nvSpPr>
+          <p:cNvPr id="187" name="Google Shape;187;g3850b307b58_0_218:notes">
+            <a:extLst>
+              <a:ext uri="{FF2B5EF4-FFF2-40B4-BE49-F238E27FC236}">
+                <a16:creationId xmlns:a16="http://schemas.microsoft.com/office/drawing/2014/main" id="{EF352E9E-C058-66C8-8D1E-CC0542E64826}"/>
+              </a:ext>
+            </a:extLst>
+          </p:cNvPr>
+          <p:cNvSpPr>
+            <a:spLocks noGrp="1" noRot="1" noChangeAspect="1"/>
+          </p:cNvSpPr>
+          <p:nvPr>
+            <p:ph type="sldImg" idx="2"/>
+          </p:nvPr>
+        </p:nvSpPr>
+        <p:spPr>
+          <a:xfrm>
+            <a:off x="0" y="685800"/>
+            <a:ext cx="6858000" cy="3429000"/>
+          </a:xfrm>
+          <a:custGeom>
+            <a:avLst/>
+            <a:gdLst/>
+            <a:ahLst/>
+            <a:cxnLst/>
+            <a:rect l="l" t="t" r="r" b="b"/>
+            <a:pathLst>
+              <a:path w="120000" h="120000" extrusionOk="0">
+                <a:moveTo>
+                  <a:pt x="0" y="0"/>
+                </a:moveTo>
+                <a:lnTo>
+                  <a:pt x="120000" y="0"/>
+                </a:lnTo>
+                <a:lnTo>
+                  <a:pt x="120000" y="120000"/>
+                </a:lnTo>
+                <a:lnTo>
+                  <a:pt x="0" y="120000"/>
+                </a:lnTo>
+                <a:close/>
+              </a:path>
+            </a:pathLst>
+          </a:custGeom>
+        </p:spPr>
+      </p:sp>
+      <p:sp>
+        <p:nvSpPr>
+          <p:cNvPr id="188" name="Google Shape;188;g3850b307b58_0_218:notes">
+            <a:extLst>
+              <a:ext uri="{FF2B5EF4-FFF2-40B4-BE49-F238E27FC236}">
+                <a16:creationId xmlns:a16="http://schemas.microsoft.com/office/drawing/2014/main" id="{62DA8749-FB58-2800-5958-3E1D4014360F}"/>
+              </a:ext>
+            </a:extLst>
+          </p:cNvPr>
+          <p:cNvSpPr txBox="1">
+            <a:spLocks noGrp="1"/>
+          </p:cNvSpPr>
+          <p:nvPr>
+            <p:ph type="body" idx="1"/>
+          </p:nvPr>
+        </p:nvSpPr>
+        <p:spPr>
+          <a:xfrm>
+            <a:off x="685800" y="4343400"/>
+            <a:ext cx="5486400" cy="4114800"/>
+          </a:xfrm>
+          <a:prstGeom prst="rect">
+            <a:avLst/>
+          </a:prstGeom>
+        </p:spPr>
+        <p:txBody>
+          <a:bodyPr spcFirstLastPara="1" wrap="square" lIns="91425" tIns="91425" rIns="91425" bIns="91425" anchor="t" anchorCtr="0">
+            <a:noAutofit/>
+          </a:bodyPr>
+          <a:lstStyle/>
+          <a:p>
+            <a:pPr marL="0" lvl="0" indent="0" algn="l" rtl="0">
+              <a:spcBef>
+                <a:spcPts val="0"/>
+              </a:spcBef>
+              <a:spcAft>
+                <a:spcPts val="0"/>
+              </a:spcAft>
+              <a:buNone/>
+            </a:pPr>
+            <a:endParaRPr/>
+          </a:p>
+        </p:txBody>
+      </p:sp>
+    </p:spTree>
+    <p:extLst>
+      <p:ext uri="{BB962C8B-B14F-4D97-AF65-F5344CB8AC3E}">
+        <p14:creationId xmlns:p14="http://schemas.microsoft.com/office/powerpoint/2010/main" val="3023121137"/>
       </p:ext>
     </p:extLst>
   </p:cSld>
@@ -32115,6 +32243,2513 @@
 </p:sld>
 </file>
 
+<file path=ppt/slides/slide23.xml><?xml version="1.0" encoding="utf-8"?>
+<p:sld xmlns:a="http://schemas.openxmlformats.org/drawingml/2006/main" xmlns:r="http://schemas.openxmlformats.org/officeDocument/2006/relationships" xmlns:p="http://schemas.openxmlformats.org/presentationml/2006/main">
+  <p:cSld>
+    <p:spTree>
+      <p:nvGrpSpPr>
+        <p:cNvPr id="1" name="Shape 189">
+          <a:extLst>
+            <a:ext uri="{FF2B5EF4-FFF2-40B4-BE49-F238E27FC236}">
+              <a16:creationId xmlns:a16="http://schemas.microsoft.com/office/drawing/2014/main" id="{4A943328-785A-E29B-AB2A-4D2A05FC6424}"/>
+            </a:ext>
+          </a:extLst>
+        </p:cNvPr>
+        <p:cNvGrpSpPr/>
+        <p:nvPr/>
+      </p:nvGrpSpPr>
+      <p:grpSpPr>
+        <a:xfrm>
+          <a:off x="0" y="0"/>
+          <a:ext cx="0" cy="0"/>
+          <a:chOff x="0" y="0"/>
+          <a:chExt cx="0" cy="0"/>
+        </a:xfrm>
+      </p:grpSpPr>
+      <p:cxnSp>
+        <p:nvCxnSpPr>
+          <p:cNvPr id="190" name="Google Shape;190;p19">
+            <a:extLst>
+              <a:ext uri="{FF2B5EF4-FFF2-40B4-BE49-F238E27FC236}">
+                <a16:creationId xmlns:a16="http://schemas.microsoft.com/office/drawing/2014/main" id="{09F13374-F78C-AD8E-6990-67454CDB8E12}"/>
+              </a:ext>
+            </a:extLst>
+          </p:cNvPr>
+          <p:cNvCxnSpPr/>
+          <p:nvPr/>
+        </p:nvCxnSpPr>
+        <p:spPr>
+          <a:xfrm>
+            <a:off x="5944724" y="-31500"/>
+            <a:ext cx="0" cy="10857000"/>
+          </a:xfrm>
+          <a:prstGeom prst="straightConnector1">
+            <a:avLst/>
+          </a:prstGeom>
+          <a:noFill/>
+          <a:ln w="38100" cap="flat" cmpd="sng">
+            <a:solidFill>
+              <a:srgbClr val="5B0F00"/>
+            </a:solidFill>
+            <a:prstDash val="solid"/>
+            <a:round/>
+            <a:headEnd type="none" w="med" len="med"/>
+            <a:tailEnd type="none" w="med" len="med"/>
+          </a:ln>
+        </p:spPr>
+      </p:cxnSp>
+      <p:sp>
+        <p:nvSpPr>
+          <p:cNvPr id="191" name="Google Shape;191;p19">
+            <a:extLst>
+              <a:ext uri="{FF2B5EF4-FFF2-40B4-BE49-F238E27FC236}">
+                <a16:creationId xmlns:a16="http://schemas.microsoft.com/office/drawing/2014/main" id="{22B1715B-B0EA-CEE4-5E51-1EC35ECE3A2D}"/>
+              </a:ext>
+            </a:extLst>
+          </p:cNvPr>
+          <p:cNvSpPr/>
+          <p:nvPr/>
+        </p:nvSpPr>
+        <p:spPr>
+          <a:xfrm>
+            <a:off x="3197186" y="84312"/>
+            <a:ext cx="2410800" cy="480900"/>
+          </a:xfrm>
+          <a:prstGeom prst="roundRect">
+            <a:avLst>
+              <a:gd name="adj" fmla="val 16667"/>
+            </a:avLst>
+          </a:prstGeom>
+          <a:solidFill>
+            <a:srgbClr val="F9CB9C"/>
+          </a:solidFill>
+          <a:ln w="28575" cap="flat" cmpd="sng">
+            <a:solidFill>
+              <a:srgbClr val="B45F06"/>
+            </a:solidFill>
+            <a:prstDash val="solid"/>
+            <a:round/>
+            <a:headEnd type="none" w="sm" len="sm"/>
+            <a:tailEnd type="none" w="sm" len="sm"/>
+          </a:ln>
+        </p:spPr>
+        <p:txBody>
+          <a:bodyPr spcFirstLastPara="1" wrap="square" lIns="91425" tIns="91425" rIns="91425" bIns="91425" anchor="ctr" anchorCtr="0">
+            <a:noAutofit/>
+          </a:bodyPr>
+          <a:lstStyle/>
+          <a:p>
+            <a:pPr marL="0" lvl="0" indent="0" algn="ctr" rtl="0">
+              <a:spcBef>
+                <a:spcPts val="0"/>
+              </a:spcBef>
+              <a:spcAft>
+                <a:spcPts val="0"/>
+              </a:spcAft>
+              <a:buNone/>
+            </a:pPr>
+            <a:r>
+              <a:rPr lang="en-GB" sz="1800" b="1">
+                <a:latin typeface="Consolas"/>
+                <a:ea typeface="Consolas"/>
+                <a:cs typeface="Consolas"/>
+                <a:sym typeface="Consolas"/>
+              </a:rPr>
+              <a:t>Student ID</a:t>
+            </a:r>
+            <a:endParaRPr sz="1800" b="1">
+              <a:latin typeface="Consolas"/>
+              <a:ea typeface="Consolas"/>
+              <a:cs typeface="Consolas"/>
+              <a:sym typeface="Consolas"/>
+            </a:endParaRPr>
+          </a:p>
+        </p:txBody>
+      </p:sp>
+      <p:sp>
+        <p:nvSpPr>
+          <p:cNvPr id="192" name="Google Shape;192;p19">
+            <a:extLst>
+              <a:ext uri="{FF2B5EF4-FFF2-40B4-BE49-F238E27FC236}">
+                <a16:creationId xmlns:a16="http://schemas.microsoft.com/office/drawing/2014/main" id="{3BF77B78-4886-1159-6173-545795109F39}"/>
+              </a:ext>
+            </a:extLst>
+          </p:cNvPr>
+          <p:cNvSpPr/>
+          <p:nvPr/>
+        </p:nvSpPr>
+        <p:spPr>
+          <a:xfrm>
+            <a:off x="6281636" y="84312"/>
+            <a:ext cx="2410800" cy="480900"/>
+          </a:xfrm>
+          <a:prstGeom prst="roundRect">
+            <a:avLst>
+              <a:gd name="adj" fmla="val 16667"/>
+            </a:avLst>
+          </a:prstGeom>
+          <a:solidFill>
+            <a:srgbClr val="F9CB9C"/>
+          </a:solidFill>
+          <a:ln w="28575" cap="flat" cmpd="sng">
+            <a:solidFill>
+              <a:srgbClr val="B45F06"/>
+            </a:solidFill>
+            <a:prstDash val="solid"/>
+            <a:round/>
+            <a:headEnd type="none" w="sm" len="sm"/>
+            <a:tailEnd type="none" w="sm" len="sm"/>
+          </a:ln>
+        </p:spPr>
+        <p:txBody>
+          <a:bodyPr spcFirstLastPara="1" wrap="square" lIns="91425" tIns="91425" rIns="91425" bIns="91425" anchor="ctr" anchorCtr="0">
+            <a:noAutofit/>
+          </a:bodyPr>
+          <a:lstStyle/>
+          <a:p>
+            <a:pPr marL="0" lvl="0" indent="0" algn="ctr" rtl="0">
+              <a:spcBef>
+                <a:spcPts val="0"/>
+              </a:spcBef>
+              <a:spcAft>
+                <a:spcPts val="0"/>
+              </a:spcAft>
+              <a:buNone/>
+            </a:pPr>
+            <a:r>
+              <a:rPr lang="en-GB" sz="1800" b="1">
+                <a:latin typeface="Consolas"/>
+                <a:ea typeface="Consolas"/>
+                <a:cs typeface="Consolas"/>
+                <a:sym typeface="Consolas"/>
+              </a:rPr>
+              <a:t>Story</a:t>
+            </a:r>
+            <a:endParaRPr sz="1800" b="1">
+              <a:latin typeface="Consolas"/>
+              <a:ea typeface="Consolas"/>
+              <a:cs typeface="Consolas"/>
+              <a:sym typeface="Consolas"/>
+            </a:endParaRPr>
+          </a:p>
+        </p:txBody>
+      </p:sp>
+      <p:sp>
+        <p:nvSpPr>
+          <p:cNvPr id="193" name="Google Shape;193;p19">
+            <a:extLst>
+              <a:ext uri="{FF2B5EF4-FFF2-40B4-BE49-F238E27FC236}">
+                <a16:creationId xmlns:a16="http://schemas.microsoft.com/office/drawing/2014/main" id="{89CDBF29-B239-8926-7DFC-F090B5F22DB2}"/>
+              </a:ext>
+            </a:extLst>
+          </p:cNvPr>
+          <p:cNvSpPr/>
+          <p:nvPr/>
+        </p:nvSpPr>
+        <p:spPr>
+          <a:xfrm>
+            <a:off x="9366071" y="84312"/>
+            <a:ext cx="2410800" cy="480900"/>
+          </a:xfrm>
+          <a:prstGeom prst="roundRect">
+            <a:avLst>
+              <a:gd name="adj" fmla="val 16667"/>
+            </a:avLst>
+          </a:prstGeom>
+          <a:solidFill>
+            <a:srgbClr val="F9CB9C"/>
+          </a:solidFill>
+          <a:ln w="28575" cap="flat" cmpd="sng">
+            <a:solidFill>
+              <a:srgbClr val="B45F06"/>
+            </a:solidFill>
+            <a:prstDash val="solid"/>
+            <a:round/>
+            <a:headEnd type="none" w="sm" len="sm"/>
+            <a:tailEnd type="none" w="sm" len="sm"/>
+          </a:ln>
+        </p:spPr>
+        <p:txBody>
+          <a:bodyPr spcFirstLastPara="1" wrap="square" lIns="91425" tIns="91425" rIns="91425" bIns="91425" anchor="ctr" anchorCtr="0">
+            <a:noAutofit/>
+          </a:bodyPr>
+          <a:lstStyle/>
+          <a:p>
+            <a:pPr marL="0" lvl="0" indent="0" algn="ctr" rtl="0">
+              <a:spcBef>
+                <a:spcPts val="0"/>
+              </a:spcBef>
+              <a:spcAft>
+                <a:spcPts val="0"/>
+              </a:spcAft>
+              <a:buNone/>
+            </a:pPr>
+            <a:r>
+              <a:rPr lang="en-GB" sz="1800" b="1">
+                <a:latin typeface="Consolas"/>
+                <a:ea typeface="Consolas"/>
+                <a:cs typeface="Consolas"/>
+                <a:sym typeface="Consolas"/>
+              </a:rPr>
+              <a:t>To Do</a:t>
+            </a:r>
+            <a:endParaRPr sz="1800" b="1">
+              <a:latin typeface="Consolas"/>
+              <a:ea typeface="Consolas"/>
+              <a:cs typeface="Consolas"/>
+              <a:sym typeface="Consolas"/>
+            </a:endParaRPr>
+          </a:p>
+        </p:txBody>
+      </p:sp>
+      <p:sp>
+        <p:nvSpPr>
+          <p:cNvPr id="194" name="Google Shape;194;p19">
+            <a:extLst>
+              <a:ext uri="{FF2B5EF4-FFF2-40B4-BE49-F238E27FC236}">
+                <a16:creationId xmlns:a16="http://schemas.microsoft.com/office/drawing/2014/main" id="{42048A09-B4EB-AE5E-FB46-678DF6A685F6}"/>
+              </a:ext>
+            </a:extLst>
+          </p:cNvPr>
+          <p:cNvSpPr/>
+          <p:nvPr/>
+        </p:nvSpPr>
+        <p:spPr>
+          <a:xfrm>
+            <a:off x="12395940" y="84312"/>
+            <a:ext cx="2410800" cy="480900"/>
+          </a:xfrm>
+          <a:prstGeom prst="roundRect">
+            <a:avLst>
+              <a:gd name="adj" fmla="val 16667"/>
+            </a:avLst>
+          </a:prstGeom>
+          <a:solidFill>
+            <a:srgbClr val="F9CB9C"/>
+          </a:solidFill>
+          <a:ln w="28575" cap="flat" cmpd="sng">
+            <a:solidFill>
+              <a:srgbClr val="B45F06"/>
+            </a:solidFill>
+            <a:prstDash val="solid"/>
+            <a:round/>
+            <a:headEnd type="none" w="sm" len="sm"/>
+            <a:tailEnd type="none" w="sm" len="sm"/>
+          </a:ln>
+        </p:spPr>
+        <p:txBody>
+          <a:bodyPr spcFirstLastPara="1" wrap="square" lIns="91425" tIns="91425" rIns="91425" bIns="91425" anchor="ctr" anchorCtr="0">
+            <a:noAutofit/>
+          </a:bodyPr>
+          <a:lstStyle/>
+          <a:p>
+            <a:pPr marL="0" lvl="0" indent="0" algn="ctr" rtl="0">
+              <a:spcBef>
+                <a:spcPts val="0"/>
+              </a:spcBef>
+              <a:spcAft>
+                <a:spcPts val="0"/>
+              </a:spcAft>
+              <a:buNone/>
+            </a:pPr>
+            <a:r>
+              <a:rPr lang="en-GB" sz="1800" b="1">
+                <a:latin typeface="Consolas"/>
+                <a:ea typeface="Consolas"/>
+                <a:cs typeface="Consolas"/>
+                <a:sym typeface="Consolas"/>
+              </a:rPr>
+              <a:t>Doing</a:t>
+            </a:r>
+            <a:endParaRPr sz="1800" b="1">
+              <a:latin typeface="Consolas"/>
+              <a:ea typeface="Consolas"/>
+              <a:cs typeface="Consolas"/>
+              <a:sym typeface="Consolas"/>
+            </a:endParaRPr>
+          </a:p>
+        </p:txBody>
+      </p:sp>
+      <p:sp>
+        <p:nvSpPr>
+          <p:cNvPr id="195" name="Google Shape;195;p19">
+            <a:extLst>
+              <a:ext uri="{FF2B5EF4-FFF2-40B4-BE49-F238E27FC236}">
+                <a16:creationId xmlns:a16="http://schemas.microsoft.com/office/drawing/2014/main" id="{27A5B666-8FEB-C601-F640-AFF6918D6168}"/>
+              </a:ext>
+            </a:extLst>
+          </p:cNvPr>
+          <p:cNvSpPr/>
+          <p:nvPr/>
+        </p:nvSpPr>
+        <p:spPr>
+          <a:xfrm>
+            <a:off x="15532407" y="84312"/>
+            <a:ext cx="2410800" cy="480900"/>
+          </a:xfrm>
+          <a:prstGeom prst="roundRect">
+            <a:avLst>
+              <a:gd name="adj" fmla="val 16667"/>
+            </a:avLst>
+          </a:prstGeom>
+          <a:solidFill>
+            <a:srgbClr val="F9CB9C"/>
+          </a:solidFill>
+          <a:ln w="28575" cap="flat" cmpd="sng">
+            <a:solidFill>
+              <a:srgbClr val="B45F06"/>
+            </a:solidFill>
+            <a:prstDash val="solid"/>
+            <a:round/>
+            <a:headEnd type="none" w="sm" len="sm"/>
+            <a:tailEnd type="none" w="sm" len="sm"/>
+          </a:ln>
+        </p:spPr>
+        <p:txBody>
+          <a:bodyPr spcFirstLastPara="1" wrap="square" lIns="91425" tIns="91425" rIns="91425" bIns="91425" anchor="ctr" anchorCtr="0">
+            <a:noAutofit/>
+          </a:bodyPr>
+          <a:lstStyle/>
+          <a:p>
+            <a:pPr marL="0" lvl="0" indent="0" algn="ctr" rtl="0">
+              <a:spcBef>
+                <a:spcPts val="0"/>
+              </a:spcBef>
+              <a:spcAft>
+                <a:spcPts val="0"/>
+              </a:spcAft>
+              <a:buNone/>
+            </a:pPr>
+            <a:r>
+              <a:rPr lang="en-GB" sz="1800" b="1">
+                <a:latin typeface="Consolas"/>
+                <a:ea typeface="Consolas"/>
+                <a:cs typeface="Consolas"/>
+                <a:sym typeface="Consolas"/>
+              </a:rPr>
+              <a:t>Review</a:t>
+            </a:r>
+            <a:endParaRPr sz="1800" b="1">
+              <a:latin typeface="Consolas"/>
+              <a:ea typeface="Consolas"/>
+              <a:cs typeface="Consolas"/>
+              <a:sym typeface="Consolas"/>
+            </a:endParaRPr>
+          </a:p>
+        </p:txBody>
+      </p:sp>
+      <p:sp>
+        <p:nvSpPr>
+          <p:cNvPr id="196" name="Google Shape;196;p19">
+            <a:extLst>
+              <a:ext uri="{FF2B5EF4-FFF2-40B4-BE49-F238E27FC236}">
+                <a16:creationId xmlns:a16="http://schemas.microsoft.com/office/drawing/2014/main" id="{4686B43A-76A6-F4B8-2BDC-E256EE80F128}"/>
+              </a:ext>
+            </a:extLst>
+          </p:cNvPr>
+          <p:cNvSpPr/>
+          <p:nvPr/>
+        </p:nvSpPr>
+        <p:spPr>
+          <a:xfrm>
+            <a:off x="18668888" y="84312"/>
+            <a:ext cx="2410800" cy="480900"/>
+          </a:xfrm>
+          <a:prstGeom prst="roundRect">
+            <a:avLst>
+              <a:gd name="adj" fmla="val 16667"/>
+            </a:avLst>
+          </a:prstGeom>
+          <a:solidFill>
+            <a:srgbClr val="F9CB9C"/>
+          </a:solidFill>
+          <a:ln w="28575" cap="flat" cmpd="sng">
+            <a:solidFill>
+              <a:srgbClr val="B45F06"/>
+            </a:solidFill>
+            <a:prstDash val="solid"/>
+            <a:round/>
+            <a:headEnd type="none" w="sm" len="sm"/>
+            <a:tailEnd type="none" w="sm" len="sm"/>
+          </a:ln>
+        </p:spPr>
+        <p:txBody>
+          <a:bodyPr spcFirstLastPara="1" wrap="square" lIns="91425" tIns="91425" rIns="91425" bIns="91425" anchor="ctr" anchorCtr="0">
+            <a:noAutofit/>
+          </a:bodyPr>
+          <a:lstStyle/>
+          <a:p>
+            <a:pPr marL="0" lvl="0" indent="0" algn="ctr" rtl="0">
+              <a:spcBef>
+                <a:spcPts val="0"/>
+              </a:spcBef>
+              <a:spcAft>
+                <a:spcPts val="0"/>
+              </a:spcAft>
+              <a:buNone/>
+            </a:pPr>
+            <a:r>
+              <a:rPr lang="en-GB" sz="1800" b="1">
+                <a:latin typeface="Consolas"/>
+                <a:ea typeface="Consolas"/>
+                <a:cs typeface="Consolas"/>
+                <a:sym typeface="Consolas"/>
+              </a:rPr>
+              <a:t>Done</a:t>
+            </a:r>
+            <a:endParaRPr sz="1800" b="1">
+              <a:latin typeface="Consolas"/>
+              <a:ea typeface="Consolas"/>
+              <a:cs typeface="Consolas"/>
+              <a:sym typeface="Consolas"/>
+            </a:endParaRPr>
+          </a:p>
+        </p:txBody>
+      </p:sp>
+      <p:sp>
+        <p:nvSpPr>
+          <p:cNvPr id="197" name="Google Shape;197;p19">
+            <a:extLst>
+              <a:ext uri="{FF2B5EF4-FFF2-40B4-BE49-F238E27FC236}">
+                <a16:creationId xmlns:a16="http://schemas.microsoft.com/office/drawing/2014/main" id="{806F9C96-6E39-79B2-A816-6BD0CAB6DC96}"/>
+              </a:ext>
+            </a:extLst>
+          </p:cNvPr>
+          <p:cNvSpPr/>
+          <p:nvPr/>
+        </p:nvSpPr>
+        <p:spPr>
+          <a:xfrm>
+            <a:off x="167288" y="84312"/>
+            <a:ext cx="2410800" cy="480900"/>
+          </a:xfrm>
+          <a:prstGeom prst="roundRect">
+            <a:avLst>
+              <a:gd name="adj" fmla="val 16667"/>
+            </a:avLst>
+          </a:prstGeom>
+          <a:solidFill>
+            <a:srgbClr val="F9CB9C"/>
+          </a:solidFill>
+          <a:ln w="28575" cap="flat" cmpd="sng">
+            <a:solidFill>
+              <a:srgbClr val="B45F06"/>
+            </a:solidFill>
+            <a:prstDash val="solid"/>
+            <a:round/>
+            <a:headEnd type="none" w="sm" len="sm"/>
+            <a:tailEnd type="none" w="sm" len="sm"/>
+          </a:ln>
+        </p:spPr>
+        <p:txBody>
+          <a:bodyPr spcFirstLastPara="1" wrap="square" lIns="91425" tIns="91425" rIns="91425" bIns="91425" anchor="ctr" anchorCtr="0">
+            <a:noAutofit/>
+          </a:bodyPr>
+          <a:lstStyle/>
+          <a:p>
+            <a:pPr marL="0" lvl="0" indent="0" algn="ctr" rtl="0">
+              <a:spcBef>
+                <a:spcPts val="0"/>
+              </a:spcBef>
+              <a:spcAft>
+                <a:spcPts val="0"/>
+              </a:spcAft>
+              <a:buNone/>
+            </a:pPr>
+            <a:r>
+              <a:rPr lang="en-GB" sz="1800" b="1">
+                <a:latin typeface="Consolas"/>
+                <a:ea typeface="Consolas"/>
+                <a:cs typeface="Consolas"/>
+                <a:sym typeface="Consolas"/>
+              </a:rPr>
+              <a:t>Backlog</a:t>
+            </a:r>
+            <a:endParaRPr sz="1800" b="1">
+              <a:latin typeface="Consolas"/>
+              <a:ea typeface="Consolas"/>
+              <a:cs typeface="Consolas"/>
+              <a:sym typeface="Consolas"/>
+            </a:endParaRPr>
+          </a:p>
+        </p:txBody>
+      </p:sp>
+      <p:cxnSp>
+        <p:nvCxnSpPr>
+          <p:cNvPr id="204" name="Google Shape;204;p19">
+            <a:extLst>
+              <a:ext uri="{FF2B5EF4-FFF2-40B4-BE49-F238E27FC236}">
+                <a16:creationId xmlns:a16="http://schemas.microsoft.com/office/drawing/2014/main" id="{E521A9CC-31A5-5FAA-F7E4-F6C595DF6197}"/>
+              </a:ext>
+            </a:extLst>
+          </p:cNvPr>
+          <p:cNvCxnSpPr/>
+          <p:nvPr/>
+        </p:nvCxnSpPr>
+        <p:spPr>
+          <a:xfrm>
+            <a:off x="5607986" y="1626038"/>
+            <a:ext cx="16042200" cy="0"/>
+          </a:xfrm>
+          <a:prstGeom prst="straightConnector1">
+            <a:avLst/>
+          </a:prstGeom>
+          <a:noFill/>
+          <a:ln w="28575" cap="flat" cmpd="sng">
+            <a:solidFill>
+              <a:srgbClr val="999999"/>
+            </a:solidFill>
+            <a:prstDash val="dash"/>
+            <a:round/>
+            <a:headEnd type="none" w="med" len="med"/>
+            <a:tailEnd type="none" w="med" len="med"/>
+          </a:ln>
+        </p:spPr>
+      </p:cxnSp>
+      <p:cxnSp>
+        <p:nvCxnSpPr>
+          <p:cNvPr id="205" name="Google Shape;205;p19">
+            <a:extLst>
+              <a:ext uri="{FF2B5EF4-FFF2-40B4-BE49-F238E27FC236}">
+                <a16:creationId xmlns:a16="http://schemas.microsoft.com/office/drawing/2014/main" id="{448FECDA-C7BD-14CB-AC1A-C20AF905E499}"/>
+              </a:ext>
+            </a:extLst>
+          </p:cNvPr>
+          <p:cNvCxnSpPr/>
+          <p:nvPr/>
+        </p:nvCxnSpPr>
+        <p:spPr>
+          <a:xfrm>
+            <a:off x="5607986" y="3203476"/>
+            <a:ext cx="16042200" cy="0"/>
+          </a:xfrm>
+          <a:prstGeom prst="straightConnector1">
+            <a:avLst/>
+          </a:prstGeom>
+          <a:noFill/>
+          <a:ln w="28575" cap="flat" cmpd="sng">
+            <a:solidFill>
+              <a:srgbClr val="999999"/>
+            </a:solidFill>
+            <a:prstDash val="dash"/>
+            <a:round/>
+            <a:headEnd type="none" w="med" len="med"/>
+            <a:tailEnd type="none" w="med" len="med"/>
+          </a:ln>
+        </p:spPr>
+      </p:cxnSp>
+      <p:cxnSp>
+        <p:nvCxnSpPr>
+          <p:cNvPr id="206" name="Google Shape;206;p19">
+            <a:extLst>
+              <a:ext uri="{FF2B5EF4-FFF2-40B4-BE49-F238E27FC236}">
+                <a16:creationId xmlns:a16="http://schemas.microsoft.com/office/drawing/2014/main" id="{9AE07E07-62EE-DF0C-BBA1-C0B8BE8B74B5}"/>
+              </a:ext>
+            </a:extLst>
+          </p:cNvPr>
+          <p:cNvCxnSpPr/>
+          <p:nvPr/>
+        </p:nvCxnSpPr>
+        <p:spPr>
+          <a:xfrm>
+            <a:off x="5607986" y="4777838"/>
+            <a:ext cx="16042200" cy="0"/>
+          </a:xfrm>
+          <a:prstGeom prst="straightConnector1">
+            <a:avLst/>
+          </a:prstGeom>
+          <a:noFill/>
+          <a:ln w="28575" cap="flat" cmpd="sng">
+            <a:solidFill>
+              <a:srgbClr val="999999"/>
+            </a:solidFill>
+            <a:prstDash val="dash"/>
+            <a:round/>
+            <a:headEnd type="none" w="med" len="med"/>
+            <a:tailEnd type="none" w="med" len="med"/>
+          </a:ln>
+        </p:spPr>
+      </p:cxnSp>
+      <p:cxnSp>
+        <p:nvCxnSpPr>
+          <p:cNvPr id="207" name="Google Shape;207;p19">
+            <a:extLst>
+              <a:ext uri="{FF2B5EF4-FFF2-40B4-BE49-F238E27FC236}">
+                <a16:creationId xmlns:a16="http://schemas.microsoft.com/office/drawing/2014/main" id="{3C133FF5-D8D7-79AB-DA4A-7B08166C64E8}"/>
+              </a:ext>
+            </a:extLst>
+          </p:cNvPr>
+          <p:cNvCxnSpPr/>
+          <p:nvPr/>
+        </p:nvCxnSpPr>
+        <p:spPr>
+          <a:xfrm>
+            <a:off x="5607986" y="6353738"/>
+            <a:ext cx="16042200" cy="0"/>
+          </a:xfrm>
+          <a:prstGeom prst="straightConnector1">
+            <a:avLst/>
+          </a:prstGeom>
+          <a:noFill/>
+          <a:ln w="28575" cap="flat" cmpd="sng">
+            <a:solidFill>
+              <a:srgbClr val="999999"/>
+            </a:solidFill>
+            <a:prstDash val="dash"/>
+            <a:round/>
+            <a:headEnd type="none" w="med" len="med"/>
+            <a:tailEnd type="none" w="med" len="med"/>
+          </a:ln>
+        </p:spPr>
+      </p:cxnSp>
+      <p:cxnSp>
+        <p:nvCxnSpPr>
+          <p:cNvPr id="208" name="Google Shape;208;p19">
+            <a:extLst>
+              <a:ext uri="{FF2B5EF4-FFF2-40B4-BE49-F238E27FC236}">
+                <a16:creationId xmlns:a16="http://schemas.microsoft.com/office/drawing/2014/main" id="{1C55A161-900E-DD2E-ED6A-1B39AAD8B2AF}"/>
+              </a:ext>
+            </a:extLst>
+          </p:cNvPr>
+          <p:cNvCxnSpPr/>
+          <p:nvPr/>
+        </p:nvCxnSpPr>
+        <p:spPr>
+          <a:xfrm>
+            <a:off x="5607986" y="7929638"/>
+            <a:ext cx="16042200" cy="0"/>
+          </a:xfrm>
+          <a:prstGeom prst="straightConnector1">
+            <a:avLst/>
+          </a:prstGeom>
+          <a:noFill/>
+          <a:ln w="28575" cap="flat" cmpd="sng">
+            <a:solidFill>
+              <a:srgbClr val="999999"/>
+            </a:solidFill>
+            <a:prstDash val="dash"/>
+            <a:round/>
+            <a:headEnd type="none" w="med" len="med"/>
+            <a:tailEnd type="none" w="med" len="med"/>
+          </a:ln>
+        </p:spPr>
+      </p:cxnSp>
+      <p:cxnSp>
+        <p:nvCxnSpPr>
+          <p:cNvPr id="209" name="Google Shape;209;p19">
+            <a:extLst>
+              <a:ext uri="{FF2B5EF4-FFF2-40B4-BE49-F238E27FC236}">
+                <a16:creationId xmlns:a16="http://schemas.microsoft.com/office/drawing/2014/main" id="{8B98A1E3-A2C3-CF04-53CA-F0EB6CF01297}"/>
+              </a:ext>
+            </a:extLst>
+          </p:cNvPr>
+          <p:cNvCxnSpPr/>
+          <p:nvPr/>
+        </p:nvCxnSpPr>
+        <p:spPr>
+          <a:xfrm>
+            <a:off x="5607986" y="9505538"/>
+            <a:ext cx="16042200" cy="0"/>
+          </a:xfrm>
+          <a:prstGeom prst="straightConnector1">
+            <a:avLst/>
+          </a:prstGeom>
+          <a:noFill/>
+          <a:ln w="28575" cap="flat" cmpd="sng">
+            <a:solidFill>
+              <a:srgbClr val="999999"/>
+            </a:solidFill>
+            <a:prstDash val="dash"/>
+            <a:round/>
+            <a:headEnd type="none" w="med" len="med"/>
+            <a:tailEnd type="none" w="med" len="med"/>
+          </a:ln>
+        </p:spPr>
+      </p:cxnSp>
+      <p:cxnSp>
+        <p:nvCxnSpPr>
+          <p:cNvPr id="215" name="Google Shape;215;p19">
+            <a:extLst>
+              <a:ext uri="{FF2B5EF4-FFF2-40B4-BE49-F238E27FC236}">
+                <a16:creationId xmlns:a16="http://schemas.microsoft.com/office/drawing/2014/main" id="{C5E52549-E9B3-FBB3-E232-A78E25647975}"/>
+              </a:ext>
+            </a:extLst>
+          </p:cNvPr>
+          <p:cNvCxnSpPr/>
+          <p:nvPr/>
+        </p:nvCxnSpPr>
+        <p:spPr>
+          <a:xfrm>
+            <a:off x="2874374" y="-28500"/>
+            <a:ext cx="0" cy="10857000"/>
+          </a:xfrm>
+          <a:prstGeom prst="straightConnector1">
+            <a:avLst/>
+          </a:prstGeom>
+          <a:noFill/>
+          <a:ln w="38100" cap="flat" cmpd="sng">
+            <a:solidFill>
+              <a:srgbClr val="5B0F00"/>
+            </a:solidFill>
+            <a:prstDash val="solid"/>
+            <a:round/>
+            <a:headEnd type="none" w="med" len="med"/>
+            <a:tailEnd type="none" w="med" len="med"/>
+          </a:ln>
+        </p:spPr>
+      </p:cxnSp>
+      <p:sp>
+        <p:nvSpPr>
+          <p:cNvPr id="2" name="Google Shape;74;p15">
+            <a:extLst>
+              <a:ext uri="{FF2B5EF4-FFF2-40B4-BE49-F238E27FC236}">
+                <a16:creationId xmlns:a16="http://schemas.microsoft.com/office/drawing/2014/main" id="{B0C8E30B-2B5F-6D0C-0A7B-3E694EC10C9C}"/>
+              </a:ext>
+            </a:extLst>
+          </p:cNvPr>
+          <p:cNvSpPr/>
+          <p:nvPr/>
+        </p:nvSpPr>
+        <p:spPr>
+          <a:xfrm>
+            <a:off x="3197186" y="1385588"/>
+            <a:ext cx="2410800" cy="480900"/>
+          </a:xfrm>
+          <a:prstGeom prst="roundRect">
+            <a:avLst>
+              <a:gd name="adj" fmla="val 16667"/>
+            </a:avLst>
+          </a:prstGeom>
+          <a:solidFill>
+            <a:srgbClr val="E6B8AF"/>
+          </a:solidFill>
+          <a:ln w="28575" cap="flat" cmpd="sng">
+            <a:solidFill>
+              <a:srgbClr val="5B0F00"/>
+            </a:solidFill>
+            <a:prstDash val="solid"/>
+            <a:round/>
+            <a:headEnd type="none" w="sm" len="sm"/>
+            <a:tailEnd type="none" w="sm" len="sm"/>
+          </a:ln>
+        </p:spPr>
+        <p:txBody>
+          <a:bodyPr spcFirstLastPara="1" wrap="square" lIns="91425" tIns="91425" rIns="91425" bIns="91425" anchor="ctr" anchorCtr="0">
+            <a:noAutofit/>
+          </a:bodyPr>
+          <a:lstStyle/>
+          <a:p>
+            <a:pPr marL="0" lvl="0" indent="0" algn="ctr" rtl="0">
+              <a:spcBef>
+                <a:spcPts val="0"/>
+              </a:spcBef>
+              <a:spcAft>
+                <a:spcPts val="0"/>
+              </a:spcAft>
+              <a:buNone/>
+            </a:pPr>
+            <a:r>
+              <a:rPr lang="en-GB" sz="1800" b="1" dirty="0">
+                <a:latin typeface="Consolas"/>
+                <a:ea typeface="Consolas"/>
+                <a:cs typeface="Consolas"/>
+                <a:sym typeface="Consolas"/>
+              </a:rPr>
+              <a:t>68338</a:t>
+            </a:r>
+            <a:endParaRPr sz="1800" b="1" dirty="0">
+              <a:latin typeface="Consolas"/>
+              <a:ea typeface="Consolas"/>
+              <a:cs typeface="Consolas"/>
+              <a:sym typeface="Consolas"/>
+            </a:endParaRPr>
+          </a:p>
+        </p:txBody>
+      </p:sp>
+      <p:sp>
+        <p:nvSpPr>
+          <p:cNvPr id="3" name="Google Shape;75;p15">
+            <a:extLst>
+              <a:ext uri="{FF2B5EF4-FFF2-40B4-BE49-F238E27FC236}">
+                <a16:creationId xmlns:a16="http://schemas.microsoft.com/office/drawing/2014/main" id="{0A9BE16D-E72E-7895-EC5B-8382E9CA171A}"/>
+              </a:ext>
+            </a:extLst>
+          </p:cNvPr>
+          <p:cNvSpPr/>
+          <p:nvPr/>
+        </p:nvSpPr>
+        <p:spPr>
+          <a:xfrm>
+            <a:off x="3197186" y="2961501"/>
+            <a:ext cx="2410800" cy="480900"/>
+          </a:xfrm>
+          <a:prstGeom prst="roundRect">
+            <a:avLst>
+              <a:gd name="adj" fmla="val 16667"/>
+            </a:avLst>
+          </a:prstGeom>
+          <a:solidFill>
+            <a:srgbClr val="E6B8AF"/>
+          </a:solidFill>
+          <a:ln w="28575" cap="flat" cmpd="sng">
+            <a:solidFill>
+              <a:srgbClr val="5B0F00"/>
+            </a:solidFill>
+            <a:prstDash val="solid"/>
+            <a:round/>
+            <a:headEnd type="none" w="sm" len="sm"/>
+            <a:tailEnd type="none" w="sm" len="sm"/>
+          </a:ln>
+        </p:spPr>
+        <p:txBody>
+          <a:bodyPr spcFirstLastPara="1" wrap="square" lIns="91425" tIns="91425" rIns="91425" bIns="91425" anchor="ctr" anchorCtr="0">
+            <a:noAutofit/>
+          </a:bodyPr>
+          <a:lstStyle/>
+          <a:p>
+            <a:pPr marL="0" lvl="0" indent="0" algn="ctr" rtl="0">
+              <a:spcBef>
+                <a:spcPts val="0"/>
+              </a:spcBef>
+              <a:spcAft>
+                <a:spcPts val="0"/>
+              </a:spcAft>
+              <a:buNone/>
+            </a:pPr>
+            <a:r>
+              <a:rPr lang="en-GB" sz="1800" b="1" dirty="0">
+                <a:latin typeface="Consolas"/>
+                <a:ea typeface="Consolas"/>
+                <a:cs typeface="Consolas"/>
+                <a:sym typeface="Consolas"/>
+              </a:rPr>
+              <a:t>68245</a:t>
+            </a:r>
+            <a:endParaRPr sz="1800" b="1" dirty="0">
+              <a:latin typeface="Consolas"/>
+              <a:ea typeface="Consolas"/>
+              <a:cs typeface="Consolas"/>
+              <a:sym typeface="Consolas"/>
+            </a:endParaRPr>
+          </a:p>
+        </p:txBody>
+      </p:sp>
+      <p:sp>
+        <p:nvSpPr>
+          <p:cNvPr id="4" name="Google Shape;76;p15">
+            <a:extLst>
+              <a:ext uri="{FF2B5EF4-FFF2-40B4-BE49-F238E27FC236}">
+                <a16:creationId xmlns:a16="http://schemas.microsoft.com/office/drawing/2014/main" id="{38FD56A0-C44E-03ED-9A4A-4E54E2A5BAE1}"/>
+              </a:ext>
+            </a:extLst>
+          </p:cNvPr>
+          <p:cNvSpPr/>
+          <p:nvPr/>
+        </p:nvSpPr>
+        <p:spPr>
+          <a:xfrm>
+            <a:off x="3197186" y="4537410"/>
+            <a:ext cx="2410800" cy="480900"/>
+          </a:xfrm>
+          <a:prstGeom prst="roundRect">
+            <a:avLst>
+              <a:gd name="adj" fmla="val 16667"/>
+            </a:avLst>
+          </a:prstGeom>
+          <a:solidFill>
+            <a:srgbClr val="E6B8AF"/>
+          </a:solidFill>
+          <a:ln w="28575" cap="flat" cmpd="sng">
+            <a:solidFill>
+              <a:srgbClr val="5B0F00"/>
+            </a:solidFill>
+            <a:prstDash val="solid"/>
+            <a:round/>
+            <a:headEnd type="none" w="sm" len="sm"/>
+            <a:tailEnd type="none" w="sm" len="sm"/>
+          </a:ln>
+        </p:spPr>
+        <p:txBody>
+          <a:bodyPr spcFirstLastPara="1" wrap="square" lIns="91425" tIns="91425" rIns="91425" bIns="91425" anchor="ctr" anchorCtr="0">
+            <a:noAutofit/>
+          </a:bodyPr>
+          <a:lstStyle/>
+          <a:p>
+            <a:pPr marL="0" lvl="0" indent="0" algn="ctr" rtl="0">
+              <a:spcBef>
+                <a:spcPts val="0"/>
+              </a:spcBef>
+              <a:spcAft>
+                <a:spcPts val="0"/>
+              </a:spcAft>
+              <a:buNone/>
+            </a:pPr>
+            <a:r>
+              <a:rPr lang="en-GB" sz="1800" b="1" dirty="0">
+                <a:latin typeface="Consolas"/>
+                <a:ea typeface="Consolas"/>
+                <a:cs typeface="Consolas"/>
+                <a:sym typeface="Consolas"/>
+              </a:rPr>
+              <a:t>68725</a:t>
+            </a:r>
+            <a:endParaRPr sz="1800" b="1" dirty="0">
+              <a:latin typeface="Consolas"/>
+              <a:ea typeface="Consolas"/>
+              <a:cs typeface="Consolas"/>
+              <a:sym typeface="Consolas"/>
+            </a:endParaRPr>
+          </a:p>
+        </p:txBody>
+      </p:sp>
+      <p:sp>
+        <p:nvSpPr>
+          <p:cNvPr id="5" name="Google Shape;77;p15">
+            <a:extLst>
+              <a:ext uri="{FF2B5EF4-FFF2-40B4-BE49-F238E27FC236}">
+                <a16:creationId xmlns:a16="http://schemas.microsoft.com/office/drawing/2014/main" id="{FAD72093-2ACB-0387-C6E8-506A13080931}"/>
+              </a:ext>
+            </a:extLst>
+          </p:cNvPr>
+          <p:cNvSpPr/>
+          <p:nvPr/>
+        </p:nvSpPr>
+        <p:spPr>
+          <a:xfrm>
+            <a:off x="3197186" y="6113307"/>
+            <a:ext cx="2410800" cy="480900"/>
+          </a:xfrm>
+          <a:prstGeom prst="roundRect">
+            <a:avLst>
+              <a:gd name="adj" fmla="val 16667"/>
+            </a:avLst>
+          </a:prstGeom>
+          <a:solidFill>
+            <a:srgbClr val="E6B8AF"/>
+          </a:solidFill>
+          <a:ln w="28575" cap="flat" cmpd="sng">
+            <a:solidFill>
+              <a:srgbClr val="5B0F00"/>
+            </a:solidFill>
+            <a:prstDash val="solid"/>
+            <a:round/>
+            <a:headEnd type="none" w="sm" len="sm"/>
+            <a:tailEnd type="none" w="sm" len="sm"/>
+          </a:ln>
+        </p:spPr>
+        <p:txBody>
+          <a:bodyPr spcFirstLastPara="1" wrap="square" lIns="91425" tIns="91425" rIns="91425" bIns="91425" anchor="ctr" anchorCtr="0">
+            <a:noAutofit/>
+          </a:bodyPr>
+          <a:lstStyle/>
+          <a:p>
+            <a:pPr marL="0" lvl="0" indent="0" algn="ctr" rtl="0">
+              <a:spcBef>
+                <a:spcPts val="0"/>
+              </a:spcBef>
+              <a:spcAft>
+                <a:spcPts val="0"/>
+              </a:spcAft>
+              <a:buNone/>
+            </a:pPr>
+            <a:r>
+              <a:rPr lang="en-GB" sz="1800" b="1" dirty="0">
+                <a:latin typeface="Consolas"/>
+                <a:ea typeface="Consolas"/>
+                <a:cs typeface="Consolas"/>
+                <a:sym typeface="Consolas"/>
+              </a:rPr>
+              <a:t>68180</a:t>
+            </a:r>
+            <a:endParaRPr sz="1800" b="1" dirty="0">
+              <a:latin typeface="Consolas"/>
+              <a:ea typeface="Consolas"/>
+              <a:cs typeface="Consolas"/>
+              <a:sym typeface="Consolas"/>
+            </a:endParaRPr>
+          </a:p>
+        </p:txBody>
+      </p:sp>
+      <p:sp>
+        <p:nvSpPr>
+          <p:cNvPr id="6" name="Google Shape;78;p15">
+            <a:extLst>
+              <a:ext uri="{FF2B5EF4-FFF2-40B4-BE49-F238E27FC236}">
+                <a16:creationId xmlns:a16="http://schemas.microsoft.com/office/drawing/2014/main" id="{85B59DC2-D1CE-EEF1-89BB-609D0FC1CD16}"/>
+              </a:ext>
+            </a:extLst>
+          </p:cNvPr>
+          <p:cNvSpPr/>
+          <p:nvPr/>
+        </p:nvSpPr>
+        <p:spPr>
+          <a:xfrm>
+            <a:off x="3197186" y="7689198"/>
+            <a:ext cx="2410800" cy="480900"/>
+          </a:xfrm>
+          <a:prstGeom prst="roundRect">
+            <a:avLst>
+              <a:gd name="adj" fmla="val 16667"/>
+            </a:avLst>
+          </a:prstGeom>
+          <a:solidFill>
+            <a:srgbClr val="E6B8AF"/>
+          </a:solidFill>
+          <a:ln w="28575" cap="flat" cmpd="sng">
+            <a:solidFill>
+              <a:srgbClr val="5B0F00"/>
+            </a:solidFill>
+            <a:prstDash val="solid"/>
+            <a:round/>
+            <a:headEnd type="none" w="sm" len="sm"/>
+            <a:tailEnd type="none" w="sm" len="sm"/>
+          </a:ln>
+        </p:spPr>
+        <p:txBody>
+          <a:bodyPr spcFirstLastPara="1" wrap="square" lIns="91425" tIns="91425" rIns="91425" bIns="91425" anchor="ctr" anchorCtr="0">
+            <a:noAutofit/>
+          </a:bodyPr>
+          <a:lstStyle/>
+          <a:p>
+            <a:pPr marL="0" lvl="0" indent="0" algn="ctr" rtl="0">
+              <a:spcBef>
+                <a:spcPts val="0"/>
+              </a:spcBef>
+              <a:spcAft>
+                <a:spcPts val="0"/>
+              </a:spcAft>
+              <a:buNone/>
+            </a:pPr>
+            <a:r>
+              <a:rPr lang="en-GB" sz="1800" b="1" dirty="0">
+                <a:latin typeface="Consolas"/>
+                <a:ea typeface="Consolas"/>
+                <a:cs typeface="Consolas"/>
+                <a:sym typeface="Consolas"/>
+              </a:rPr>
+              <a:t>67912</a:t>
+            </a:r>
+            <a:endParaRPr sz="1800" b="1" dirty="0">
+              <a:latin typeface="Consolas"/>
+              <a:ea typeface="Consolas"/>
+              <a:cs typeface="Consolas"/>
+              <a:sym typeface="Consolas"/>
+            </a:endParaRPr>
+          </a:p>
+        </p:txBody>
+      </p:sp>
+      <p:sp>
+        <p:nvSpPr>
+          <p:cNvPr id="7" name="Google Shape;79;p15">
+            <a:extLst>
+              <a:ext uri="{FF2B5EF4-FFF2-40B4-BE49-F238E27FC236}">
+                <a16:creationId xmlns:a16="http://schemas.microsoft.com/office/drawing/2014/main" id="{BC873F4F-6C71-F84A-0DD7-133231249620}"/>
+              </a:ext>
+            </a:extLst>
+          </p:cNvPr>
+          <p:cNvSpPr/>
+          <p:nvPr/>
+        </p:nvSpPr>
+        <p:spPr>
+          <a:xfrm>
+            <a:off x="3197186" y="9265103"/>
+            <a:ext cx="2410800" cy="480900"/>
+          </a:xfrm>
+          <a:prstGeom prst="roundRect">
+            <a:avLst>
+              <a:gd name="adj" fmla="val 16667"/>
+            </a:avLst>
+          </a:prstGeom>
+          <a:solidFill>
+            <a:srgbClr val="E6B8AF"/>
+          </a:solidFill>
+          <a:ln w="28575" cap="flat" cmpd="sng">
+            <a:solidFill>
+              <a:srgbClr val="5B0F00"/>
+            </a:solidFill>
+            <a:prstDash val="solid"/>
+            <a:round/>
+            <a:headEnd type="none" w="sm" len="sm"/>
+            <a:tailEnd type="none" w="sm" len="sm"/>
+          </a:ln>
+        </p:spPr>
+        <p:txBody>
+          <a:bodyPr spcFirstLastPara="1" wrap="square" lIns="91425" tIns="91425" rIns="91425" bIns="91425" anchor="ctr" anchorCtr="0">
+            <a:noAutofit/>
+          </a:bodyPr>
+          <a:lstStyle/>
+          <a:p>
+            <a:pPr marL="0" lvl="0" indent="0" algn="ctr" rtl="0">
+              <a:spcBef>
+                <a:spcPts val="0"/>
+              </a:spcBef>
+              <a:spcAft>
+                <a:spcPts val="0"/>
+              </a:spcAft>
+              <a:buNone/>
+            </a:pPr>
+            <a:r>
+              <a:rPr lang="en-GB" sz="1800" b="1" dirty="0">
+                <a:latin typeface="Consolas"/>
+                <a:ea typeface="Consolas"/>
+                <a:cs typeface="Consolas"/>
+                <a:sym typeface="Consolas"/>
+              </a:rPr>
+              <a:t>67870</a:t>
+            </a:r>
+            <a:endParaRPr sz="1800" b="1" dirty="0">
+              <a:latin typeface="Consolas"/>
+              <a:ea typeface="Consolas"/>
+              <a:cs typeface="Consolas"/>
+              <a:sym typeface="Consolas"/>
+            </a:endParaRPr>
+          </a:p>
+        </p:txBody>
+      </p:sp>
+      <p:sp>
+        <p:nvSpPr>
+          <p:cNvPr id="19" name="Google Shape;86;p15">
+            <a:extLst>
+              <a:ext uri="{FF2B5EF4-FFF2-40B4-BE49-F238E27FC236}">
+                <a16:creationId xmlns:a16="http://schemas.microsoft.com/office/drawing/2014/main" id="{DA10F264-644F-ABE0-7824-34D0F4708A10}"/>
+              </a:ext>
+            </a:extLst>
+          </p:cNvPr>
+          <p:cNvSpPr/>
+          <p:nvPr/>
+        </p:nvSpPr>
+        <p:spPr>
+          <a:xfrm>
+            <a:off x="6113258" y="1294224"/>
+            <a:ext cx="2609591" cy="8864188"/>
+          </a:xfrm>
+          <a:prstGeom prst="roundRect">
+            <a:avLst>
+              <a:gd name="adj" fmla="val 16667"/>
+            </a:avLst>
+          </a:prstGeom>
+          <a:solidFill>
+            <a:srgbClr val="D9EAD3"/>
+          </a:solidFill>
+          <a:ln w="28575" cap="flat" cmpd="sng">
+            <a:solidFill>
+              <a:srgbClr val="274E13"/>
+            </a:solidFill>
+            <a:prstDash val="solid"/>
+            <a:round/>
+            <a:headEnd type="none" w="sm" len="sm"/>
+            <a:tailEnd type="none" w="sm" len="sm"/>
+          </a:ln>
+        </p:spPr>
+        <p:txBody>
+          <a:bodyPr spcFirstLastPara="1" wrap="square" lIns="91425" tIns="91425" rIns="91425" bIns="91425" anchor="t" anchorCtr="0">
+            <a:noAutofit/>
+          </a:bodyPr>
+          <a:lstStyle/>
+          <a:p>
+            <a:pPr marL="0" lvl="0" indent="0" rtl="0">
+              <a:spcBef>
+                <a:spcPts val="0"/>
+              </a:spcBef>
+              <a:spcAft>
+                <a:spcPts val="0"/>
+              </a:spcAft>
+              <a:buNone/>
+            </a:pPr>
+            <a:r>
+              <a:rPr lang="en-GB" dirty="0">
+                <a:latin typeface="Consolas"/>
+                <a:ea typeface="Consolas"/>
+                <a:cs typeface="Consolas"/>
+                <a:sym typeface="Consolas"/>
+              </a:rPr>
+              <a:t>US1: Como </a:t>
+            </a:r>
+            <a:r>
+              <a:rPr lang="en-GB" dirty="0" err="1">
+                <a:latin typeface="Consolas"/>
+                <a:ea typeface="Consolas"/>
+                <a:cs typeface="Consolas"/>
+                <a:sym typeface="Consolas"/>
+              </a:rPr>
+              <a:t>membro</a:t>
+            </a:r>
+            <a:r>
+              <a:rPr lang="en-GB" dirty="0">
+                <a:latin typeface="Consolas"/>
+                <a:ea typeface="Consolas"/>
+                <a:cs typeface="Consolas"/>
+                <a:sym typeface="Consolas"/>
+              </a:rPr>
+              <a:t> da </a:t>
+            </a:r>
+            <a:r>
+              <a:rPr lang="en-GB" dirty="0" err="1">
+                <a:latin typeface="Consolas"/>
+                <a:ea typeface="Consolas"/>
+                <a:cs typeface="Consolas"/>
+                <a:sym typeface="Consolas"/>
+              </a:rPr>
+              <a:t>equipa</a:t>
+            </a:r>
+            <a:r>
+              <a:rPr lang="en-GB" dirty="0">
+                <a:latin typeface="Consolas"/>
+                <a:ea typeface="Consolas"/>
+                <a:cs typeface="Consolas"/>
+                <a:sym typeface="Consolas"/>
+              </a:rPr>
+              <a:t>, </a:t>
+            </a:r>
+            <a:r>
+              <a:rPr lang="en-GB" dirty="0" err="1">
+                <a:latin typeface="Consolas"/>
+                <a:ea typeface="Consolas"/>
+                <a:cs typeface="Consolas"/>
+                <a:sym typeface="Consolas"/>
+              </a:rPr>
+              <a:t>quero</a:t>
+            </a:r>
+            <a:r>
+              <a:rPr lang="en-GB" dirty="0">
+                <a:latin typeface="Consolas"/>
+                <a:ea typeface="Consolas"/>
+                <a:cs typeface="Consolas"/>
+                <a:sym typeface="Consolas"/>
+              </a:rPr>
+              <a:t> </a:t>
+            </a:r>
+            <a:r>
+              <a:rPr lang="en-GB" dirty="0" err="1">
+                <a:latin typeface="Consolas"/>
+                <a:ea typeface="Consolas"/>
+                <a:cs typeface="Consolas"/>
+                <a:sym typeface="Consolas"/>
+              </a:rPr>
+              <a:t>implementar</a:t>
+            </a:r>
+            <a:r>
+              <a:rPr lang="en-GB" dirty="0">
+                <a:latin typeface="Consolas"/>
+                <a:ea typeface="Consolas"/>
+                <a:cs typeface="Consolas"/>
+                <a:sym typeface="Consolas"/>
+              </a:rPr>
+              <a:t> um modo de </a:t>
+            </a:r>
+            <a:r>
+              <a:rPr lang="en-GB" dirty="0" err="1">
+                <a:latin typeface="Consolas"/>
+                <a:ea typeface="Consolas"/>
+                <a:cs typeface="Consolas"/>
+                <a:sym typeface="Consolas"/>
+              </a:rPr>
+              <a:t>jogo</a:t>
+            </a:r>
+            <a:r>
+              <a:rPr lang="en-GB" dirty="0">
+                <a:latin typeface="Consolas"/>
+                <a:ea typeface="Consolas"/>
+                <a:cs typeface="Consolas"/>
+                <a:sym typeface="Consolas"/>
+              </a:rPr>
+              <a:t> </a:t>
+            </a:r>
+            <a:r>
+              <a:rPr lang="en-GB" dirty="0" err="1">
+                <a:latin typeface="Consolas"/>
+                <a:ea typeface="Consolas"/>
+                <a:cs typeface="Consolas"/>
+                <a:sym typeface="Consolas"/>
+              </a:rPr>
+              <a:t>onde</a:t>
+            </a:r>
+            <a:r>
+              <a:rPr lang="en-GB" dirty="0">
+                <a:latin typeface="Consolas"/>
+                <a:ea typeface="Consolas"/>
+                <a:cs typeface="Consolas"/>
+                <a:sym typeface="Consolas"/>
+              </a:rPr>
+              <a:t> o </a:t>
+            </a:r>
+            <a:r>
+              <a:rPr lang="en-GB" dirty="0" err="1">
+                <a:latin typeface="Consolas"/>
+                <a:ea typeface="Consolas"/>
+                <a:cs typeface="Consolas"/>
+                <a:sym typeface="Consolas"/>
+              </a:rPr>
+              <a:t>mapa</a:t>
+            </a:r>
+            <a:r>
+              <a:rPr lang="en-GB" dirty="0">
+                <a:latin typeface="Consolas"/>
+                <a:ea typeface="Consolas"/>
+                <a:cs typeface="Consolas"/>
+                <a:sym typeface="Consolas"/>
+              </a:rPr>
+              <a:t> </a:t>
+            </a:r>
+            <a:r>
+              <a:rPr lang="en-GB" dirty="0" err="1">
+                <a:latin typeface="Consolas"/>
+                <a:ea typeface="Consolas"/>
+                <a:cs typeface="Consolas"/>
+                <a:sym typeface="Consolas"/>
+              </a:rPr>
+              <a:t>muda</a:t>
+            </a:r>
+            <a:r>
+              <a:rPr lang="en-GB" dirty="0">
+                <a:latin typeface="Consolas"/>
+                <a:ea typeface="Consolas"/>
+                <a:cs typeface="Consolas"/>
+                <a:sym typeface="Consolas"/>
+              </a:rPr>
+              <a:t> </a:t>
+            </a:r>
+            <a:r>
+              <a:rPr lang="en-GB" dirty="0" err="1">
+                <a:latin typeface="Consolas"/>
+                <a:ea typeface="Consolas"/>
+                <a:cs typeface="Consolas"/>
+                <a:sym typeface="Consolas"/>
+              </a:rPr>
+              <a:t>semanalmente</a:t>
+            </a:r>
+            <a:r>
+              <a:rPr lang="en-GB" dirty="0">
+                <a:latin typeface="Consolas"/>
+                <a:ea typeface="Consolas"/>
+                <a:cs typeface="Consolas"/>
+                <a:sym typeface="Consolas"/>
+              </a:rPr>
+              <a:t> e </a:t>
+            </a:r>
+            <a:r>
+              <a:rPr lang="en-GB" dirty="0" err="1">
+                <a:latin typeface="Consolas"/>
+                <a:ea typeface="Consolas"/>
+                <a:cs typeface="Consolas"/>
+                <a:sym typeface="Consolas"/>
+              </a:rPr>
+              <a:t>possui</a:t>
+            </a:r>
+            <a:r>
+              <a:rPr lang="en-GB" dirty="0">
+                <a:latin typeface="Consolas"/>
+                <a:ea typeface="Consolas"/>
+                <a:cs typeface="Consolas"/>
+                <a:sym typeface="Consolas"/>
+              </a:rPr>
+              <a:t> um ranking </a:t>
+            </a:r>
+            <a:r>
+              <a:rPr lang="en-GB" dirty="0" err="1">
+                <a:latin typeface="Consolas"/>
+                <a:ea typeface="Consolas"/>
+                <a:cs typeface="Consolas"/>
+                <a:sym typeface="Consolas"/>
+              </a:rPr>
+              <a:t>baseado</a:t>
+            </a:r>
+            <a:r>
+              <a:rPr lang="en-GB" dirty="0">
+                <a:latin typeface="Consolas"/>
+                <a:ea typeface="Consolas"/>
+                <a:cs typeface="Consolas"/>
+                <a:sym typeface="Consolas"/>
+              </a:rPr>
+              <a:t> </a:t>
+            </a:r>
+            <a:r>
+              <a:rPr lang="en-GB" dirty="0" err="1">
+                <a:latin typeface="Consolas"/>
+                <a:ea typeface="Consolas"/>
+                <a:cs typeface="Consolas"/>
+                <a:sym typeface="Consolas"/>
+              </a:rPr>
+              <a:t>na</a:t>
+            </a:r>
+            <a:r>
+              <a:rPr lang="en-GB" dirty="0">
+                <a:latin typeface="Consolas"/>
+                <a:ea typeface="Consolas"/>
+                <a:cs typeface="Consolas"/>
+                <a:sym typeface="Consolas"/>
+              </a:rPr>
+              <a:t> performance.</a:t>
+            </a:r>
+            <a:endParaRPr dirty="0">
+              <a:latin typeface="Consolas"/>
+              <a:ea typeface="Consolas"/>
+              <a:cs typeface="Consolas"/>
+              <a:sym typeface="Consolas"/>
+            </a:endParaRPr>
+          </a:p>
+        </p:txBody>
+      </p:sp>
+      <p:sp>
+        <p:nvSpPr>
+          <p:cNvPr id="20" name="Google Shape;92;p15">
+            <a:extLst>
+              <a:ext uri="{FF2B5EF4-FFF2-40B4-BE49-F238E27FC236}">
+                <a16:creationId xmlns:a16="http://schemas.microsoft.com/office/drawing/2014/main" id="{472925EA-32E9-5AD5-80FE-6685DF5E21DC}"/>
+              </a:ext>
+            </a:extLst>
+          </p:cNvPr>
+          <p:cNvSpPr/>
+          <p:nvPr/>
+        </p:nvSpPr>
+        <p:spPr>
+          <a:xfrm>
+            <a:off x="6113258" y="3203475"/>
+            <a:ext cx="2609587" cy="7609683"/>
+          </a:xfrm>
+          <a:prstGeom prst="roundRect">
+            <a:avLst>
+              <a:gd name="adj" fmla="val 16667"/>
+            </a:avLst>
+          </a:prstGeom>
+          <a:solidFill>
+            <a:srgbClr val="D9EAD3"/>
+          </a:solidFill>
+          <a:ln w="28575" cap="flat" cmpd="sng">
+            <a:solidFill>
+              <a:srgbClr val="274E13"/>
+            </a:solidFill>
+            <a:prstDash val="solid"/>
+            <a:round/>
+            <a:headEnd type="none" w="sm" len="sm"/>
+            <a:tailEnd type="none" w="sm" len="sm"/>
+          </a:ln>
+        </p:spPr>
+        <p:txBody>
+          <a:bodyPr spcFirstLastPara="1" wrap="square" lIns="91425" tIns="91425" rIns="91425" bIns="91425" anchor="t" anchorCtr="0">
+            <a:noAutofit/>
+          </a:bodyPr>
+          <a:lstStyle/>
+          <a:p>
+            <a:pPr lvl="0"/>
+            <a:r>
+              <a:rPr lang="en-GB" dirty="0">
+                <a:latin typeface="Consolas"/>
+                <a:ea typeface="Consolas"/>
+                <a:cs typeface="Consolas"/>
+                <a:sym typeface="Consolas"/>
+              </a:rPr>
+              <a:t>US2: Como </a:t>
+            </a:r>
+            <a:r>
+              <a:rPr lang="en-GB" dirty="0" err="1">
+                <a:latin typeface="Consolas"/>
+                <a:ea typeface="Consolas"/>
+                <a:cs typeface="Consolas"/>
+                <a:sym typeface="Consolas"/>
+              </a:rPr>
+              <a:t>membro</a:t>
+            </a:r>
+            <a:r>
+              <a:rPr lang="en-GB" dirty="0">
+                <a:latin typeface="Consolas"/>
+                <a:ea typeface="Consolas"/>
+                <a:cs typeface="Consolas"/>
+                <a:sym typeface="Consolas"/>
+              </a:rPr>
+              <a:t> da </a:t>
+            </a:r>
+            <a:r>
+              <a:rPr lang="en-GB" dirty="0" err="1">
+                <a:latin typeface="Consolas"/>
+                <a:ea typeface="Consolas"/>
+                <a:cs typeface="Consolas"/>
+                <a:sym typeface="Consolas"/>
+              </a:rPr>
+              <a:t>equipa</a:t>
+            </a:r>
+            <a:r>
+              <a:rPr lang="en-GB" dirty="0">
+                <a:latin typeface="Consolas"/>
+                <a:ea typeface="Consolas"/>
+                <a:cs typeface="Consolas"/>
+                <a:sym typeface="Consolas"/>
+              </a:rPr>
+              <a:t> </a:t>
+            </a:r>
+            <a:r>
+              <a:rPr lang="en-GB" dirty="0" err="1">
+                <a:latin typeface="Consolas"/>
+                <a:ea typeface="Consolas"/>
+                <a:cs typeface="Consolas"/>
+                <a:sym typeface="Consolas"/>
+              </a:rPr>
+              <a:t>quero</a:t>
+            </a:r>
+            <a:r>
+              <a:rPr lang="pt-PT" dirty="0">
+                <a:latin typeface="Consolas"/>
+                <a:ea typeface="Consolas"/>
+                <a:cs typeface="Consolas"/>
+                <a:sym typeface="Consolas"/>
+              </a:rPr>
+              <a:t> implementar a </a:t>
+            </a:r>
+            <a:r>
+              <a:rPr lang="pt-PT" dirty="0" err="1">
+                <a:latin typeface="Consolas"/>
+                <a:ea typeface="Consolas"/>
+                <a:cs typeface="Consolas"/>
+                <a:sym typeface="Consolas"/>
+              </a:rPr>
+              <a:t>Health</a:t>
+            </a:r>
+            <a:r>
+              <a:rPr lang="pt-PT" dirty="0">
+                <a:latin typeface="Consolas"/>
+                <a:ea typeface="Consolas"/>
+                <a:cs typeface="Consolas"/>
+                <a:sym typeface="Consolas"/>
+              </a:rPr>
+              <a:t> Bar de cada </a:t>
+            </a:r>
+            <a:r>
+              <a:rPr lang="pt-PT" dirty="0" err="1">
+                <a:latin typeface="Consolas"/>
+                <a:ea typeface="Consolas"/>
+                <a:cs typeface="Consolas"/>
+                <a:sym typeface="Consolas"/>
+              </a:rPr>
+              <a:t>wave</a:t>
+            </a:r>
+            <a:r>
+              <a:rPr lang="pt-PT" dirty="0">
+                <a:latin typeface="Consolas"/>
+                <a:ea typeface="Consolas"/>
+                <a:cs typeface="Consolas"/>
+                <a:sym typeface="Consolas"/>
+              </a:rPr>
+              <a:t> de inimigos.</a:t>
+            </a:r>
+            <a:endParaRPr dirty="0">
+              <a:latin typeface="Consolas"/>
+              <a:ea typeface="Consolas"/>
+              <a:cs typeface="Consolas"/>
+              <a:sym typeface="Consolas"/>
+            </a:endParaRPr>
+          </a:p>
+        </p:txBody>
+      </p:sp>
+      <p:sp>
+        <p:nvSpPr>
+          <p:cNvPr id="21" name="Google Shape;92;p15">
+            <a:extLst>
+              <a:ext uri="{FF2B5EF4-FFF2-40B4-BE49-F238E27FC236}">
+                <a16:creationId xmlns:a16="http://schemas.microsoft.com/office/drawing/2014/main" id="{ED4BB08E-DED3-DC2B-8E63-4BDA60D6AF64}"/>
+              </a:ext>
+            </a:extLst>
+          </p:cNvPr>
+          <p:cNvSpPr/>
+          <p:nvPr/>
+        </p:nvSpPr>
+        <p:spPr>
+          <a:xfrm>
+            <a:off x="6136546" y="4644094"/>
+            <a:ext cx="2609586" cy="6208084"/>
+          </a:xfrm>
+          <a:prstGeom prst="roundRect">
+            <a:avLst>
+              <a:gd name="adj" fmla="val 16667"/>
+            </a:avLst>
+          </a:prstGeom>
+          <a:solidFill>
+            <a:srgbClr val="D9EAD3"/>
+          </a:solidFill>
+          <a:ln w="28575" cap="flat" cmpd="sng">
+            <a:solidFill>
+              <a:srgbClr val="274E13"/>
+            </a:solidFill>
+            <a:prstDash val="solid"/>
+            <a:round/>
+            <a:headEnd type="none" w="sm" len="sm"/>
+            <a:tailEnd type="none" w="sm" len="sm"/>
+          </a:ln>
+        </p:spPr>
+        <p:txBody>
+          <a:bodyPr spcFirstLastPara="1" wrap="square" lIns="91425" tIns="91425" rIns="91425" bIns="91425" anchor="t" anchorCtr="0">
+            <a:noAutofit/>
+          </a:bodyPr>
+          <a:lstStyle/>
+          <a:p>
+            <a:pPr lvl="0"/>
+            <a:r>
+              <a:rPr lang="en-GB" dirty="0">
+                <a:latin typeface="Consolas"/>
+                <a:ea typeface="Consolas"/>
+                <a:cs typeface="Consolas"/>
+                <a:sym typeface="Consolas"/>
+              </a:rPr>
+              <a:t>US3: Como </a:t>
+            </a:r>
+            <a:r>
+              <a:rPr lang="en-GB" dirty="0" err="1">
+                <a:latin typeface="Consolas"/>
+                <a:ea typeface="Consolas"/>
+                <a:cs typeface="Consolas"/>
+                <a:sym typeface="Consolas"/>
+              </a:rPr>
+              <a:t>membro</a:t>
+            </a:r>
+            <a:r>
+              <a:rPr lang="en-GB" dirty="0">
+                <a:latin typeface="Consolas"/>
+                <a:ea typeface="Consolas"/>
+                <a:cs typeface="Consolas"/>
+                <a:sym typeface="Consolas"/>
+              </a:rPr>
+              <a:t> da </a:t>
+            </a:r>
+            <a:r>
+              <a:rPr lang="en-GB" dirty="0" err="1">
+                <a:latin typeface="Consolas"/>
+                <a:ea typeface="Consolas"/>
+                <a:cs typeface="Consolas"/>
+                <a:sym typeface="Consolas"/>
+              </a:rPr>
+              <a:t>equipa</a:t>
+            </a:r>
+            <a:r>
+              <a:rPr lang="en-GB" dirty="0">
+                <a:latin typeface="Consolas"/>
+                <a:ea typeface="Consolas"/>
+                <a:cs typeface="Consolas"/>
+                <a:sym typeface="Consolas"/>
+              </a:rPr>
+              <a:t> </a:t>
+            </a:r>
+            <a:r>
+              <a:rPr lang="en-GB" dirty="0" err="1">
+                <a:latin typeface="Consolas"/>
+                <a:ea typeface="Consolas"/>
+                <a:cs typeface="Consolas"/>
+                <a:sym typeface="Consolas"/>
+              </a:rPr>
+              <a:t>quero</a:t>
+            </a:r>
+            <a:r>
+              <a:rPr lang="pt-PT" dirty="0">
+                <a:latin typeface="Consolas"/>
+                <a:ea typeface="Consolas"/>
+                <a:cs typeface="Consolas"/>
+                <a:sym typeface="Consolas"/>
+              </a:rPr>
+              <a:t> implementar as diferentes condições climatéricas.</a:t>
+            </a:r>
+          </a:p>
+        </p:txBody>
+      </p:sp>
+      <p:sp>
+        <p:nvSpPr>
+          <p:cNvPr id="8" name="Google Shape;121;p16">
+            <a:extLst>
+              <a:ext uri="{FF2B5EF4-FFF2-40B4-BE49-F238E27FC236}">
+                <a16:creationId xmlns:a16="http://schemas.microsoft.com/office/drawing/2014/main" id="{BEF1B6F1-8FB8-9FE0-1753-62E155ABC3B4}"/>
+              </a:ext>
+            </a:extLst>
+          </p:cNvPr>
+          <p:cNvSpPr/>
+          <p:nvPr/>
+        </p:nvSpPr>
+        <p:spPr>
+          <a:xfrm>
+            <a:off x="18725151" y="1021952"/>
+            <a:ext cx="2410800" cy="2657243"/>
+          </a:xfrm>
+          <a:prstGeom prst="roundRect">
+            <a:avLst>
+              <a:gd name="adj" fmla="val 16667"/>
+            </a:avLst>
+          </a:prstGeom>
+          <a:solidFill>
+            <a:srgbClr val="D0E0E3"/>
+          </a:solidFill>
+          <a:ln w="28575" cap="flat" cmpd="sng">
+            <a:solidFill>
+              <a:srgbClr val="134F5C"/>
+            </a:solidFill>
+            <a:prstDash val="solid"/>
+            <a:round/>
+            <a:headEnd type="none" w="sm" len="sm"/>
+            <a:tailEnd type="none" w="sm" len="sm"/>
+          </a:ln>
+        </p:spPr>
+        <p:txBody>
+          <a:bodyPr spcFirstLastPara="1" wrap="square" lIns="91425" tIns="91425" rIns="91425" bIns="91425" anchor="t" anchorCtr="0">
+            <a:noAutofit/>
+          </a:bodyPr>
+          <a:lstStyle/>
+          <a:p>
+            <a:r>
+              <a:rPr lang="en-GB" dirty="0">
+                <a:latin typeface="Consolas"/>
+                <a:ea typeface="Consolas"/>
+                <a:cs typeface="Consolas"/>
+                <a:sym typeface="Consolas"/>
+              </a:rPr>
+              <a:t>T1: </a:t>
+            </a:r>
+            <a:r>
+              <a:rPr lang="pt-PT" dirty="0">
+                <a:latin typeface="Consolas"/>
+                <a:ea typeface="Consolas"/>
+                <a:cs typeface="Consolas"/>
+                <a:sym typeface="Consolas"/>
+              </a:rPr>
+              <a:t>Fazer Interface de Rankings e “jogar Desafio Semanal”</a:t>
+            </a:r>
+            <a:br>
+              <a:rPr lang="en-GB" dirty="0">
+                <a:latin typeface="Consolas"/>
+                <a:ea typeface="Consolas"/>
+                <a:cs typeface="Consolas"/>
+                <a:sym typeface="Consolas"/>
+              </a:rPr>
+            </a:br>
+            <a:br>
+              <a:rPr lang="en-GB" dirty="0">
+                <a:latin typeface="Consolas"/>
+                <a:ea typeface="Consolas"/>
+                <a:cs typeface="Consolas"/>
+                <a:sym typeface="Consolas"/>
+              </a:rPr>
+            </a:br>
+            <a:endParaRPr lang="en-GB" dirty="0">
+              <a:latin typeface="Consolas"/>
+              <a:ea typeface="Consolas"/>
+              <a:cs typeface="Consolas"/>
+              <a:sym typeface="Consolas"/>
+            </a:endParaRPr>
+          </a:p>
+          <a:p>
+            <a:pPr marL="0" lvl="0" indent="0" algn="l" rtl="0">
+              <a:spcBef>
+                <a:spcPts val="0"/>
+              </a:spcBef>
+              <a:spcAft>
+                <a:spcPts val="0"/>
+              </a:spcAft>
+              <a:buNone/>
+            </a:pPr>
+            <a:endParaRPr dirty="0">
+              <a:latin typeface="Consolas"/>
+              <a:ea typeface="Consolas"/>
+              <a:cs typeface="Consolas"/>
+              <a:sym typeface="Consolas"/>
+            </a:endParaRPr>
+          </a:p>
+        </p:txBody>
+      </p:sp>
+      <p:sp>
+        <p:nvSpPr>
+          <p:cNvPr id="10" name="Google Shape;121;p16">
+            <a:extLst>
+              <a:ext uri="{FF2B5EF4-FFF2-40B4-BE49-F238E27FC236}">
+                <a16:creationId xmlns:a16="http://schemas.microsoft.com/office/drawing/2014/main" id="{A606BEAF-9116-4F00-8812-64682D257184}"/>
+              </a:ext>
+            </a:extLst>
+          </p:cNvPr>
+          <p:cNvSpPr/>
+          <p:nvPr/>
+        </p:nvSpPr>
+        <p:spPr>
+          <a:xfrm>
+            <a:off x="12395940" y="4165308"/>
+            <a:ext cx="2410800" cy="749592"/>
+          </a:xfrm>
+          <a:prstGeom prst="roundRect">
+            <a:avLst>
+              <a:gd name="adj" fmla="val 16667"/>
+            </a:avLst>
+          </a:prstGeom>
+          <a:solidFill>
+            <a:srgbClr val="D0E0E3"/>
+          </a:solidFill>
+          <a:ln w="28575" cap="flat" cmpd="sng">
+            <a:solidFill>
+              <a:srgbClr val="134F5C"/>
+            </a:solidFill>
+            <a:prstDash val="solid"/>
+            <a:round/>
+            <a:headEnd type="none" w="sm" len="sm"/>
+            <a:tailEnd type="none" w="sm" len="sm"/>
+          </a:ln>
+        </p:spPr>
+        <p:txBody>
+          <a:bodyPr spcFirstLastPara="1" wrap="square" lIns="91425" tIns="91425" rIns="91425" bIns="91425" anchor="t" anchorCtr="0">
+            <a:noAutofit/>
+          </a:bodyPr>
+          <a:lstStyle/>
+          <a:p>
+            <a:r>
+              <a:rPr lang="pt-PT" dirty="0">
+                <a:latin typeface="Consolas"/>
+                <a:ea typeface="Consolas"/>
+                <a:cs typeface="Consolas"/>
+                <a:sym typeface="Consolas"/>
+              </a:rPr>
+              <a:t>T3: Implementar a parte do Terramoto.</a:t>
+            </a:r>
+          </a:p>
+          <a:p>
+            <a:r>
+              <a:rPr lang="en-GB" dirty="0">
+                <a:latin typeface="Consolas"/>
+                <a:ea typeface="Consolas"/>
+                <a:cs typeface="Consolas"/>
+                <a:sym typeface="Consolas"/>
+              </a:rPr>
+              <a:t> </a:t>
+            </a:r>
+            <a:br>
+              <a:rPr lang="en-GB" dirty="0">
+                <a:latin typeface="Consolas"/>
+                <a:ea typeface="Consolas"/>
+                <a:cs typeface="Consolas"/>
+                <a:sym typeface="Consolas"/>
+              </a:rPr>
+            </a:br>
+            <a:br>
+              <a:rPr lang="en-GB" dirty="0">
+                <a:latin typeface="Consolas"/>
+                <a:ea typeface="Consolas"/>
+                <a:cs typeface="Consolas"/>
+                <a:sym typeface="Consolas"/>
+              </a:rPr>
+            </a:br>
+            <a:endParaRPr lang="en-GB" dirty="0">
+              <a:latin typeface="Consolas"/>
+              <a:ea typeface="Consolas"/>
+              <a:cs typeface="Consolas"/>
+              <a:sym typeface="Consolas"/>
+            </a:endParaRPr>
+          </a:p>
+          <a:p>
+            <a:pPr marL="0" lvl="0" indent="0" algn="l" rtl="0">
+              <a:spcBef>
+                <a:spcPts val="0"/>
+              </a:spcBef>
+              <a:spcAft>
+                <a:spcPts val="0"/>
+              </a:spcAft>
+              <a:buNone/>
+            </a:pPr>
+            <a:endParaRPr dirty="0">
+              <a:latin typeface="Consolas"/>
+              <a:ea typeface="Consolas"/>
+              <a:cs typeface="Consolas"/>
+              <a:sym typeface="Consolas"/>
+            </a:endParaRPr>
+          </a:p>
+        </p:txBody>
+      </p:sp>
+      <p:sp>
+        <p:nvSpPr>
+          <p:cNvPr id="11" name="Google Shape;121;p16">
+            <a:extLst>
+              <a:ext uri="{FF2B5EF4-FFF2-40B4-BE49-F238E27FC236}">
+                <a16:creationId xmlns:a16="http://schemas.microsoft.com/office/drawing/2014/main" id="{929F78E0-460F-8738-6BAD-E9AC471B3059}"/>
+              </a:ext>
+            </a:extLst>
+          </p:cNvPr>
+          <p:cNvSpPr/>
+          <p:nvPr/>
+        </p:nvSpPr>
+        <p:spPr>
+          <a:xfrm>
+            <a:off x="12395940" y="4784311"/>
+            <a:ext cx="2410800" cy="749592"/>
+          </a:xfrm>
+          <a:prstGeom prst="roundRect">
+            <a:avLst>
+              <a:gd name="adj" fmla="val 16667"/>
+            </a:avLst>
+          </a:prstGeom>
+          <a:solidFill>
+            <a:srgbClr val="D0E0E3"/>
+          </a:solidFill>
+          <a:ln w="28575" cap="flat" cmpd="sng">
+            <a:solidFill>
+              <a:srgbClr val="134F5C"/>
+            </a:solidFill>
+            <a:prstDash val="solid"/>
+            <a:round/>
+            <a:headEnd type="none" w="sm" len="sm"/>
+            <a:tailEnd type="none" w="sm" len="sm"/>
+          </a:ln>
+        </p:spPr>
+        <p:txBody>
+          <a:bodyPr spcFirstLastPara="1" wrap="square" lIns="91425" tIns="91425" rIns="91425" bIns="91425" anchor="t" anchorCtr="0">
+            <a:noAutofit/>
+          </a:bodyPr>
+          <a:lstStyle/>
+          <a:p>
+            <a:r>
+              <a:rPr lang="pt-PT" dirty="0">
+                <a:latin typeface="Consolas"/>
+                <a:ea typeface="Consolas"/>
+                <a:cs typeface="Consolas"/>
+                <a:sym typeface="Consolas"/>
+              </a:rPr>
+              <a:t>T3: Implementar a parte do Tsunami.</a:t>
+            </a:r>
+          </a:p>
+          <a:p>
+            <a:r>
+              <a:rPr lang="en-GB" dirty="0">
+                <a:latin typeface="Consolas"/>
+                <a:ea typeface="Consolas"/>
+                <a:cs typeface="Consolas"/>
+                <a:sym typeface="Consolas"/>
+              </a:rPr>
+              <a:t> </a:t>
+            </a:r>
+            <a:br>
+              <a:rPr lang="en-GB" dirty="0">
+                <a:latin typeface="Consolas"/>
+                <a:ea typeface="Consolas"/>
+                <a:cs typeface="Consolas"/>
+                <a:sym typeface="Consolas"/>
+              </a:rPr>
+            </a:br>
+            <a:br>
+              <a:rPr lang="en-GB" dirty="0">
+                <a:latin typeface="Consolas"/>
+                <a:ea typeface="Consolas"/>
+                <a:cs typeface="Consolas"/>
+                <a:sym typeface="Consolas"/>
+              </a:rPr>
+            </a:br>
+            <a:endParaRPr lang="en-GB" dirty="0">
+              <a:latin typeface="Consolas"/>
+              <a:ea typeface="Consolas"/>
+              <a:cs typeface="Consolas"/>
+              <a:sym typeface="Consolas"/>
+            </a:endParaRPr>
+          </a:p>
+          <a:p>
+            <a:pPr marL="0" lvl="0" indent="0" algn="l" rtl="0">
+              <a:spcBef>
+                <a:spcPts val="0"/>
+              </a:spcBef>
+              <a:spcAft>
+                <a:spcPts val="0"/>
+              </a:spcAft>
+              <a:buNone/>
+            </a:pPr>
+            <a:endParaRPr dirty="0">
+              <a:latin typeface="Consolas"/>
+              <a:ea typeface="Consolas"/>
+              <a:cs typeface="Consolas"/>
+              <a:sym typeface="Consolas"/>
+            </a:endParaRPr>
+          </a:p>
+        </p:txBody>
+      </p:sp>
+      <p:sp>
+        <p:nvSpPr>
+          <p:cNvPr id="22" name="Google Shape;121;p16">
+            <a:extLst>
+              <a:ext uri="{FF2B5EF4-FFF2-40B4-BE49-F238E27FC236}">
+                <a16:creationId xmlns:a16="http://schemas.microsoft.com/office/drawing/2014/main" id="{7941DD71-F202-F4A0-7B0D-8269DED1F424}"/>
+              </a:ext>
+            </a:extLst>
+          </p:cNvPr>
+          <p:cNvSpPr/>
+          <p:nvPr/>
+        </p:nvSpPr>
+        <p:spPr>
+          <a:xfrm>
+            <a:off x="12423686" y="7368613"/>
+            <a:ext cx="2410800" cy="1215821"/>
+          </a:xfrm>
+          <a:prstGeom prst="roundRect">
+            <a:avLst>
+              <a:gd name="adj" fmla="val 16667"/>
+            </a:avLst>
+          </a:prstGeom>
+          <a:solidFill>
+            <a:srgbClr val="D0E0E3"/>
+          </a:solidFill>
+          <a:ln w="28575" cap="flat" cmpd="sng">
+            <a:solidFill>
+              <a:srgbClr val="134F5C"/>
+            </a:solidFill>
+            <a:prstDash val="solid"/>
+            <a:round/>
+            <a:headEnd type="none" w="sm" len="sm"/>
+            <a:tailEnd type="none" w="sm" len="sm"/>
+          </a:ln>
+        </p:spPr>
+        <p:txBody>
+          <a:bodyPr spcFirstLastPara="1" wrap="square" lIns="91425" tIns="91425" rIns="91425" bIns="91425" anchor="t" anchorCtr="0">
+            <a:noAutofit/>
+          </a:bodyPr>
+          <a:lstStyle/>
+          <a:p>
+            <a:r>
+              <a:rPr lang="pt-PT" dirty="0">
+                <a:latin typeface="Consolas"/>
+                <a:ea typeface="Consolas"/>
+                <a:cs typeface="Consolas"/>
+                <a:sym typeface="Consolas"/>
+              </a:rPr>
+              <a:t>T3: Implementar a parte do Meteorito. </a:t>
+            </a:r>
+          </a:p>
+          <a:p>
+            <a:r>
+              <a:rPr lang="en-GB" dirty="0">
+                <a:latin typeface="Consolas"/>
+                <a:ea typeface="Consolas"/>
+                <a:cs typeface="Consolas"/>
+                <a:sym typeface="Consolas"/>
+              </a:rPr>
+              <a:t> </a:t>
+            </a:r>
+            <a:br>
+              <a:rPr lang="en-GB" dirty="0">
+                <a:latin typeface="Consolas"/>
+                <a:ea typeface="Consolas"/>
+                <a:cs typeface="Consolas"/>
+                <a:sym typeface="Consolas"/>
+              </a:rPr>
+            </a:br>
+            <a:br>
+              <a:rPr lang="en-GB" dirty="0">
+                <a:latin typeface="Consolas"/>
+                <a:ea typeface="Consolas"/>
+                <a:cs typeface="Consolas"/>
+                <a:sym typeface="Consolas"/>
+              </a:rPr>
+            </a:br>
+            <a:endParaRPr lang="en-GB" dirty="0">
+              <a:latin typeface="Consolas"/>
+              <a:ea typeface="Consolas"/>
+              <a:cs typeface="Consolas"/>
+              <a:sym typeface="Consolas"/>
+            </a:endParaRPr>
+          </a:p>
+          <a:p>
+            <a:pPr marL="0" lvl="0" indent="0" algn="l" rtl="0">
+              <a:spcBef>
+                <a:spcPts val="0"/>
+              </a:spcBef>
+              <a:spcAft>
+                <a:spcPts val="0"/>
+              </a:spcAft>
+              <a:buNone/>
+            </a:pPr>
+            <a:endParaRPr lang="en-GB" dirty="0">
+              <a:latin typeface="Consolas"/>
+              <a:ea typeface="Consolas"/>
+              <a:cs typeface="Consolas"/>
+              <a:sym typeface="Consolas"/>
+            </a:endParaRPr>
+          </a:p>
+        </p:txBody>
+      </p:sp>
+      <p:sp>
+        <p:nvSpPr>
+          <p:cNvPr id="24" name="Google Shape;121;p16">
+            <a:extLst>
+              <a:ext uri="{FF2B5EF4-FFF2-40B4-BE49-F238E27FC236}">
+                <a16:creationId xmlns:a16="http://schemas.microsoft.com/office/drawing/2014/main" id="{E182894F-059D-7592-5B69-8062FAFEDA38}"/>
+              </a:ext>
+            </a:extLst>
+          </p:cNvPr>
+          <p:cNvSpPr/>
+          <p:nvPr/>
+        </p:nvSpPr>
+        <p:spPr>
+          <a:xfrm>
+            <a:off x="12395940" y="932272"/>
+            <a:ext cx="2410800" cy="2657243"/>
+          </a:xfrm>
+          <a:prstGeom prst="roundRect">
+            <a:avLst>
+              <a:gd name="adj" fmla="val 16667"/>
+            </a:avLst>
+          </a:prstGeom>
+          <a:solidFill>
+            <a:srgbClr val="D0E0E3"/>
+          </a:solidFill>
+          <a:ln w="28575" cap="flat" cmpd="sng">
+            <a:solidFill>
+              <a:srgbClr val="134F5C"/>
+            </a:solidFill>
+            <a:prstDash val="solid"/>
+            <a:round/>
+            <a:headEnd type="none" w="sm" len="sm"/>
+            <a:tailEnd type="none" w="sm" len="sm"/>
+          </a:ln>
+        </p:spPr>
+        <p:txBody>
+          <a:bodyPr spcFirstLastPara="1" wrap="square" lIns="91425" tIns="91425" rIns="91425" bIns="91425" anchor="t" anchorCtr="0">
+            <a:noAutofit/>
+          </a:bodyPr>
+          <a:lstStyle/>
+          <a:p>
+            <a:r>
+              <a:rPr lang="en-GB" dirty="0">
+                <a:latin typeface="Consolas"/>
+                <a:ea typeface="Consolas"/>
+                <a:cs typeface="Consolas"/>
+                <a:sym typeface="Consolas"/>
+              </a:rPr>
+              <a:t>T1: </a:t>
+            </a:r>
+            <a:r>
+              <a:rPr lang="pt-PT" dirty="0">
+                <a:latin typeface="Consolas"/>
+                <a:ea typeface="Consolas"/>
+                <a:cs typeface="Consolas"/>
+                <a:sym typeface="Consolas"/>
+              </a:rPr>
+              <a:t>Implementar um gerador de mapa semanal.</a:t>
+            </a:r>
+            <a:br>
+              <a:rPr lang="en-GB" dirty="0">
+                <a:latin typeface="Consolas"/>
+                <a:ea typeface="Consolas"/>
+                <a:cs typeface="Consolas"/>
+                <a:sym typeface="Consolas"/>
+              </a:rPr>
+            </a:br>
+            <a:br>
+              <a:rPr lang="en-GB" dirty="0">
+                <a:latin typeface="Consolas"/>
+                <a:ea typeface="Consolas"/>
+                <a:cs typeface="Consolas"/>
+                <a:sym typeface="Consolas"/>
+              </a:rPr>
+            </a:br>
+            <a:endParaRPr lang="en-GB" dirty="0">
+              <a:latin typeface="Consolas"/>
+              <a:ea typeface="Consolas"/>
+              <a:cs typeface="Consolas"/>
+              <a:sym typeface="Consolas"/>
+            </a:endParaRPr>
+          </a:p>
+          <a:p>
+            <a:pPr marL="0" lvl="0" indent="0" algn="l" rtl="0">
+              <a:spcBef>
+                <a:spcPts val="0"/>
+              </a:spcBef>
+              <a:spcAft>
+                <a:spcPts val="0"/>
+              </a:spcAft>
+              <a:buNone/>
+            </a:pPr>
+            <a:endParaRPr dirty="0">
+              <a:latin typeface="Consolas"/>
+              <a:ea typeface="Consolas"/>
+              <a:cs typeface="Consolas"/>
+              <a:sym typeface="Consolas"/>
+            </a:endParaRPr>
+          </a:p>
+        </p:txBody>
+      </p:sp>
+      <p:sp>
+        <p:nvSpPr>
+          <p:cNvPr id="23" name="Google Shape;121;p16">
+            <a:extLst>
+              <a:ext uri="{FF2B5EF4-FFF2-40B4-BE49-F238E27FC236}">
+                <a16:creationId xmlns:a16="http://schemas.microsoft.com/office/drawing/2014/main" id="{5DE13A3A-6939-390F-0212-85EBC489CED2}"/>
+              </a:ext>
+            </a:extLst>
+          </p:cNvPr>
+          <p:cNvSpPr/>
+          <p:nvPr/>
+        </p:nvSpPr>
+        <p:spPr>
+          <a:xfrm>
+            <a:off x="12423686" y="5744289"/>
+            <a:ext cx="2410800" cy="1215821"/>
+          </a:xfrm>
+          <a:prstGeom prst="roundRect">
+            <a:avLst>
+              <a:gd name="adj" fmla="val 16667"/>
+            </a:avLst>
+          </a:prstGeom>
+          <a:solidFill>
+            <a:srgbClr val="D0E0E3"/>
+          </a:solidFill>
+          <a:ln w="28575" cap="flat" cmpd="sng">
+            <a:solidFill>
+              <a:srgbClr val="134F5C"/>
+            </a:solidFill>
+            <a:prstDash val="solid"/>
+            <a:round/>
+            <a:headEnd type="none" w="sm" len="sm"/>
+            <a:tailEnd type="none" w="sm" len="sm"/>
+          </a:ln>
+        </p:spPr>
+        <p:txBody>
+          <a:bodyPr spcFirstLastPara="1" wrap="square" lIns="91425" tIns="91425" rIns="91425" bIns="91425" anchor="t" anchorCtr="0">
+            <a:noAutofit/>
+          </a:bodyPr>
+          <a:lstStyle/>
+          <a:p>
+            <a:r>
+              <a:rPr lang="pt-PT" dirty="0">
+                <a:latin typeface="Consolas"/>
+                <a:ea typeface="Consolas"/>
+                <a:cs typeface="Consolas"/>
+                <a:sym typeface="Consolas"/>
+              </a:rPr>
+              <a:t>T2: Implementar a </a:t>
+            </a:r>
+            <a:r>
+              <a:rPr lang="pt-PT" dirty="0" err="1">
+                <a:latin typeface="Consolas"/>
+                <a:ea typeface="Consolas"/>
+                <a:cs typeface="Consolas"/>
+                <a:sym typeface="Consolas"/>
+              </a:rPr>
+              <a:t>Health</a:t>
+            </a:r>
+            <a:r>
+              <a:rPr lang="pt-PT" dirty="0">
+                <a:latin typeface="Consolas"/>
+                <a:ea typeface="Consolas"/>
+                <a:cs typeface="Consolas"/>
+                <a:sym typeface="Consolas"/>
+              </a:rPr>
+              <a:t> Bar de cada </a:t>
+            </a:r>
+            <a:r>
+              <a:rPr lang="pt-PT" dirty="0" err="1">
+                <a:latin typeface="Consolas"/>
+                <a:ea typeface="Consolas"/>
+                <a:cs typeface="Consolas"/>
+                <a:sym typeface="Consolas"/>
+              </a:rPr>
+              <a:t>wave</a:t>
+            </a:r>
+            <a:r>
+              <a:rPr lang="pt-PT" dirty="0">
+                <a:latin typeface="Consolas"/>
+                <a:ea typeface="Consolas"/>
+                <a:cs typeface="Consolas"/>
+                <a:sym typeface="Consolas"/>
+              </a:rPr>
+              <a:t> de inimigos.</a:t>
+            </a:r>
+          </a:p>
+          <a:p>
+            <a:r>
+              <a:rPr lang="en-GB" dirty="0">
+                <a:latin typeface="Consolas"/>
+                <a:ea typeface="Consolas"/>
+                <a:cs typeface="Consolas"/>
+                <a:sym typeface="Consolas"/>
+              </a:rPr>
+              <a:t> </a:t>
+            </a:r>
+            <a:br>
+              <a:rPr lang="en-GB" dirty="0">
+                <a:latin typeface="Consolas"/>
+                <a:ea typeface="Consolas"/>
+                <a:cs typeface="Consolas"/>
+                <a:sym typeface="Consolas"/>
+              </a:rPr>
+            </a:br>
+            <a:br>
+              <a:rPr lang="en-GB" dirty="0">
+                <a:latin typeface="Consolas"/>
+                <a:ea typeface="Consolas"/>
+                <a:cs typeface="Consolas"/>
+                <a:sym typeface="Consolas"/>
+              </a:rPr>
+            </a:br>
+            <a:endParaRPr lang="en-GB" dirty="0">
+              <a:latin typeface="Consolas"/>
+              <a:ea typeface="Consolas"/>
+              <a:cs typeface="Consolas"/>
+              <a:sym typeface="Consolas"/>
+            </a:endParaRPr>
+          </a:p>
+          <a:p>
+            <a:pPr marL="0" lvl="0" indent="0" algn="l" rtl="0">
+              <a:spcBef>
+                <a:spcPts val="0"/>
+              </a:spcBef>
+              <a:spcAft>
+                <a:spcPts val="0"/>
+              </a:spcAft>
+              <a:buNone/>
+            </a:pPr>
+            <a:endParaRPr dirty="0">
+              <a:latin typeface="Consolas"/>
+              <a:ea typeface="Consolas"/>
+              <a:cs typeface="Consolas"/>
+              <a:sym typeface="Consolas"/>
+            </a:endParaRPr>
+          </a:p>
+        </p:txBody>
+      </p:sp>
+      <p:sp>
+        <p:nvSpPr>
+          <p:cNvPr id="25" name="Google Shape;121;p16">
+            <a:extLst>
+              <a:ext uri="{FF2B5EF4-FFF2-40B4-BE49-F238E27FC236}">
+                <a16:creationId xmlns:a16="http://schemas.microsoft.com/office/drawing/2014/main" id="{94350274-4D68-8DD9-B2AD-A15404260A94}"/>
+              </a:ext>
+            </a:extLst>
+          </p:cNvPr>
+          <p:cNvSpPr/>
+          <p:nvPr/>
+        </p:nvSpPr>
+        <p:spPr>
+          <a:xfrm>
+            <a:off x="12395940" y="8946051"/>
+            <a:ext cx="2410800" cy="1215821"/>
+          </a:xfrm>
+          <a:prstGeom prst="roundRect">
+            <a:avLst>
+              <a:gd name="adj" fmla="val 16667"/>
+            </a:avLst>
+          </a:prstGeom>
+          <a:solidFill>
+            <a:srgbClr val="D0E0E3"/>
+          </a:solidFill>
+          <a:ln w="28575" cap="flat" cmpd="sng">
+            <a:solidFill>
+              <a:srgbClr val="134F5C"/>
+            </a:solidFill>
+            <a:prstDash val="solid"/>
+            <a:round/>
+            <a:headEnd type="none" w="sm" len="sm"/>
+            <a:tailEnd type="none" w="sm" len="sm"/>
+          </a:ln>
+        </p:spPr>
+        <p:txBody>
+          <a:bodyPr spcFirstLastPara="1" wrap="square" lIns="91425" tIns="91425" rIns="91425" bIns="91425" anchor="t" anchorCtr="0">
+            <a:noAutofit/>
+          </a:bodyPr>
+          <a:lstStyle/>
+          <a:p>
+            <a:r>
+              <a:rPr lang="pt-PT" dirty="0">
+                <a:latin typeface="Consolas"/>
+                <a:ea typeface="Consolas"/>
+                <a:cs typeface="Consolas"/>
+                <a:sym typeface="Consolas"/>
+              </a:rPr>
+              <a:t>T2: Implementar a </a:t>
+            </a:r>
+            <a:r>
+              <a:rPr lang="pt-PT" dirty="0" err="1">
+                <a:latin typeface="Consolas"/>
+                <a:ea typeface="Consolas"/>
+                <a:cs typeface="Consolas"/>
+                <a:sym typeface="Consolas"/>
+              </a:rPr>
+              <a:t>Health</a:t>
+            </a:r>
+            <a:r>
+              <a:rPr lang="pt-PT" dirty="0">
+                <a:latin typeface="Consolas"/>
+                <a:ea typeface="Consolas"/>
+                <a:cs typeface="Consolas"/>
+                <a:sym typeface="Consolas"/>
+              </a:rPr>
+              <a:t> Bar de cada </a:t>
+            </a:r>
+            <a:r>
+              <a:rPr lang="pt-PT" dirty="0" err="1">
+                <a:latin typeface="Consolas"/>
+                <a:ea typeface="Consolas"/>
+                <a:cs typeface="Consolas"/>
+                <a:sym typeface="Consolas"/>
+              </a:rPr>
+              <a:t>wave</a:t>
+            </a:r>
+            <a:r>
+              <a:rPr lang="pt-PT" dirty="0">
+                <a:latin typeface="Consolas"/>
+                <a:ea typeface="Consolas"/>
+                <a:cs typeface="Consolas"/>
+                <a:sym typeface="Consolas"/>
+              </a:rPr>
+              <a:t> de inimigos.</a:t>
+            </a:r>
+          </a:p>
+          <a:p>
+            <a:r>
+              <a:rPr lang="en-GB" dirty="0">
+                <a:latin typeface="Consolas"/>
+                <a:ea typeface="Consolas"/>
+                <a:cs typeface="Consolas"/>
+                <a:sym typeface="Consolas"/>
+              </a:rPr>
+              <a:t> </a:t>
+            </a:r>
+            <a:br>
+              <a:rPr lang="en-GB" dirty="0">
+                <a:latin typeface="Consolas"/>
+                <a:ea typeface="Consolas"/>
+                <a:cs typeface="Consolas"/>
+                <a:sym typeface="Consolas"/>
+              </a:rPr>
+            </a:br>
+            <a:br>
+              <a:rPr lang="en-GB" dirty="0">
+                <a:latin typeface="Consolas"/>
+                <a:ea typeface="Consolas"/>
+                <a:cs typeface="Consolas"/>
+                <a:sym typeface="Consolas"/>
+              </a:rPr>
+            </a:br>
+            <a:endParaRPr lang="en-GB" dirty="0">
+              <a:latin typeface="Consolas"/>
+              <a:ea typeface="Consolas"/>
+              <a:cs typeface="Consolas"/>
+              <a:sym typeface="Consolas"/>
+            </a:endParaRPr>
+          </a:p>
+          <a:p>
+            <a:pPr marL="0" lvl="0" indent="0" algn="l" rtl="0">
+              <a:spcBef>
+                <a:spcPts val="0"/>
+              </a:spcBef>
+              <a:spcAft>
+                <a:spcPts val="0"/>
+              </a:spcAft>
+              <a:buNone/>
+            </a:pPr>
+            <a:endParaRPr dirty="0">
+              <a:latin typeface="Consolas"/>
+              <a:ea typeface="Consolas"/>
+              <a:cs typeface="Consolas"/>
+              <a:sym typeface="Consolas"/>
+            </a:endParaRPr>
+          </a:p>
+        </p:txBody>
+      </p:sp>
+    </p:spTree>
+    <p:extLst>
+      <p:ext uri="{BB962C8B-B14F-4D97-AF65-F5344CB8AC3E}">
+        <p14:creationId xmlns:p14="http://schemas.microsoft.com/office/powerpoint/2010/main" val="2237403785"/>
+      </p:ext>
+    </p:extLst>
+  </p:cSld>
+  <p:clrMapOvr>
+    <a:masterClrMapping/>
+  </p:clrMapOvr>
+</p:sld>
+</file>
+
 <file path=ppt/slides/slide3.xml><?xml version="1.0" encoding="utf-8"?>
 <p:sld xmlns:a="http://schemas.openxmlformats.org/drawingml/2006/main" xmlns:r="http://schemas.openxmlformats.org/officeDocument/2006/relationships" xmlns:p="http://schemas.openxmlformats.org/presentationml/2006/main">
   <p:cSld>

</xml_diff>

<commit_message>
Sprint 6 final commit
</commit_message>
<xml_diff>
--- a/SE202526/Management/Scrum Board.pptx
+++ b/SE202526/Management/Scrum Board.pptx
@@ -5,7 +5,7 @@
     <p:sldMasterId id="2147483659" r:id="rId1"/>
   </p:sldMasterIdLst>
   <p:notesMasterIdLst>
-    <p:notesMasterId r:id="rId25"/>
+    <p:notesMasterId r:id="rId26"/>
   </p:notesMasterIdLst>
   <p:sldIdLst>
     <p:sldId id="256" r:id="rId2"/>
@@ -31,6 +31,7 @@
     <p:sldId id="279" r:id="rId22"/>
     <p:sldId id="280" r:id="rId23"/>
     <p:sldId id="281" r:id="rId24"/>
+    <p:sldId id="282" r:id="rId25"/>
   </p:sldIdLst>
   <p:sldSz cx="21599525" cy="10799763"/>
   <p:notesSz cx="6858000" cy="9144000"/>
@@ -2700,6 +2701,133 @@
     <p:extLst>
       <p:ext uri="{BB962C8B-B14F-4D97-AF65-F5344CB8AC3E}">
         <p14:creationId xmlns:p14="http://schemas.microsoft.com/office/powerpoint/2010/main" val="3023121137"/>
+      </p:ext>
+    </p:extLst>
+  </p:cSld>
+  <p:clrMapOvr>
+    <a:masterClrMapping/>
+  </p:clrMapOvr>
+</p:notes>
+</file>
+
+<file path=ppt/notesSlides/notesSlide24.xml><?xml version="1.0" encoding="utf-8"?>
+<p:notes xmlns:a="http://schemas.openxmlformats.org/drawingml/2006/main" xmlns:r="http://schemas.openxmlformats.org/officeDocument/2006/relationships" xmlns:p="http://schemas.openxmlformats.org/presentationml/2006/main" showMasterSp="0" showMasterPhAnim="0">
+  <p:cSld>
+    <p:spTree>
+      <p:nvGrpSpPr>
+        <p:cNvPr id="1" name="Shape 186">
+          <a:extLst>
+            <a:ext uri="{FF2B5EF4-FFF2-40B4-BE49-F238E27FC236}">
+              <a16:creationId xmlns:a16="http://schemas.microsoft.com/office/drawing/2014/main" id="{411F47C8-CD0E-EFC0-BDD5-E64BC118C24F}"/>
+            </a:ext>
+          </a:extLst>
+        </p:cNvPr>
+        <p:cNvGrpSpPr/>
+        <p:nvPr/>
+      </p:nvGrpSpPr>
+      <p:grpSpPr>
+        <a:xfrm>
+          <a:off x="0" y="0"/>
+          <a:ext cx="0" cy="0"/>
+          <a:chOff x="0" y="0"/>
+          <a:chExt cx="0" cy="0"/>
+        </a:xfrm>
+      </p:grpSpPr>
+      <p:sp>
+        <p:nvSpPr>
+          <p:cNvPr id="187" name="Google Shape;187;g3850b307b58_0_218:notes">
+            <a:extLst>
+              <a:ext uri="{FF2B5EF4-FFF2-40B4-BE49-F238E27FC236}">
+                <a16:creationId xmlns:a16="http://schemas.microsoft.com/office/drawing/2014/main" id="{A38726B4-9622-9675-460E-BD2B87E709DF}"/>
+              </a:ext>
+            </a:extLst>
+          </p:cNvPr>
+          <p:cNvSpPr>
+            <a:spLocks noGrp="1" noRot="1" noChangeAspect="1"/>
+          </p:cNvSpPr>
+          <p:nvPr>
+            <p:ph type="sldImg" idx="2"/>
+          </p:nvPr>
+        </p:nvSpPr>
+        <p:spPr>
+          <a:xfrm>
+            <a:off x="0" y="685800"/>
+            <a:ext cx="6858000" cy="3429000"/>
+          </a:xfrm>
+          <a:custGeom>
+            <a:avLst/>
+            <a:gdLst/>
+            <a:ahLst/>
+            <a:cxnLst/>
+            <a:rect l="l" t="t" r="r" b="b"/>
+            <a:pathLst>
+              <a:path w="120000" h="120000" extrusionOk="0">
+                <a:moveTo>
+                  <a:pt x="0" y="0"/>
+                </a:moveTo>
+                <a:lnTo>
+                  <a:pt x="120000" y="0"/>
+                </a:lnTo>
+                <a:lnTo>
+                  <a:pt x="120000" y="120000"/>
+                </a:lnTo>
+                <a:lnTo>
+                  <a:pt x="0" y="120000"/>
+                </a:lnTo>
+                <a:close/>
+              </a:path>
+            </a:pathLst>
+          </a:custGeom>
+        </p:spPr>
+      </p:sp>
+      <p:sp>
+        <p:nvSpPr>
+          <p:cNvPr id="188" name="Google Shape;188;g3850b307b58_0_218:notes">
+            <a:extLst>
+              <a:ext uri="{FF2B5EF4-FFF2-40B4-BE49-F238E27FC236}">
+                <a16:creationId xmlns:a16="http://schemas.microsoft.com/office/drawing/2014/main" id="{FB2F7FEB-CF25-917F-1D6C-A61FEDC41B30}"/>
+              </a:ext>
+            </a:extLst>
+          </p:cNvPr>
+          <p:cNvSpPr txBox="1">
+            <a:spLocks noGrp="1"/>
+          </p:cNvSpPr>
+          <p:nvPr>
+            <p:ph type="body" idx="1"/>
+          </p:nvPr>
+        </p:nvSpPr>
+        <p:spPr>
+          <a:xfrm>
+            <a:off x="685800" y="4343400"/>
+            <a:ext cx="5486400" cy="4114800"/>
+          </a:xfrm>
+          <a:prstGeom prst="rect">
+            <a:avLst/>
+          </a:prstGeom>
+        </p:spPr>
+        <p:txBody>
+          <a:bodyPr spcFirstLastPara="1" wrap="square" lIns="91425" tIns="91425" rIns="91425" bIns="91425" anchor="t" anchorCtr="0">
+            <a:noAutofit/>
+          </a:bodyPr>
+          <a:lstStyle/>
+          <a:p>
+            <a:pPr marL="0" lvl="0" indent="0" algn="l" rtl="0">
+              <a:spcBef>
+                <a:spcPts val="0"/>
+              </a:spcBef>
+              <a:spcAft>
+                <a:spcPts val="0"/>
+              </a:spcAft>
+              <a:buNone/>
+            </a:pPr>
+            <a:endParaRPr/>
+          </a:p>
+        </p:txBody>
+      </p:sp>
+    </p:spTree>
+    <p:extLst>
+      <p:ext uri="{BB962C8B-B14F-4D97-AF65-F5344CB8AC3E}">
+        <p14:creationId xmlns:p14="http://schemas.microsoft.com/office/powerpoint/2010/main" val="3285944390"/>
       </p:ext>
     </p:extLst>
   </p:cSld>
@@ -34750,6 +34878,2513 @@
 </p:sld>
 </file>
 
+<file path=ppt/slides/slide24.xml><?xml version="1.0" encoding="utf-8"?>
+<p:sld xmlns:a="http://schemas.openxmlformats.org/drawingml/2006/main" xmlns:r="http://schemas.openxmlformats.org/officeDocument/2006/relationships" xmlns:p="http://schemas.openxmlformats.org/presentationml/2006/main">
+  <p:cSld>
+    <p:spTree>
+      <p:nvGrpSpPr>
+        <p:cNvPr id="1" name="Shape 189">
+          <a:extLst>
+            <a:ext uri="{FF2B5EF4-FFF2-40B4-BE49-F238E27FC236}">
+              <a16:creationId xmlns:a16="http://schemas.microsoft.com/office/drawing/2014/main" id="{F9E85B5D-FC84-D2D4-4E1F-4727C764A63B}"/>
+            </a:ext>
+          </a:extLst>
+        </p:cNvPr>
+        <p:cNvGrpSpPr/>
+        <p:nvPr/>
+      </p:nvGrpSpPr>
+      <p:grpSpPr>
+        <a:xfrm>
+          <a:off x="0" y="0"/>
+          <a:ext cx="0" cy="0"/>
+          <a:chOff x="0" y="0"/>
+          <a:chExt cx="0" cy="0"/>
+        </a:xfrm>
+      </p:grpSpPr>
+      <p:cxnSp>
+        <p:nvCxnSpPr>
+          <p:cNvPr id="190" name="Google Shape;190;p19">
+            <a:extLst>
+              <a:ext uri="{FF2B5EF4-FFF2-40B4-BE49-F238E27FC236}">
+                <a16:creationId xmlns:a16="http://schemas.microsoft.com/office/drawing/2014/main" id="{47FE4E93-58BE-6BCA-F348-ABFECD54BA21}"/>
+              </a:ext>
+            </a:extLst>
+          </p:cNvPr>
+          <p:cNvCxnSpPr/>
+          <p:nvPr/>
+        </p:nvCxnSpPr>
+        <p:spPr>
+          <a:xfrm>
+            <a:off x="5944724" y="-31500"/>
+            <a:ext cx="0" cy="10857000"/>
+          </a:xfrm>
+          <a:prstGeom prst="straightConnector1">
+            <a:avLst/>
+          </a:prstGeom>
+          <a:noFill/>
+          <a:ln w="38100" cap="flat" cmpd="sng">
+            <a:solidFill>
+              <a:srgbClr val="5B0F00"/>
+            </a:solidFill>
+            <a:prstDash val="solid"/>
+            <a:round/>
+            <a:headEnd type="none" w="med" len="med"/>
+            <a:tailEnd type="none" w="med" len="med"/>
+          </a:ln>
+        </p:spPr>
+      </p:cxnSp>
+      <p:sp>
+        <p:nvSpPr>
+          <p:cNvPr id="191" name="Google Shape;191;p19">
+            <a:extLst>
+              <a:ext uri="{FF2B5EF4-FFF2-40B4-BE49-F238E27FC236}">
+                <a16:creationId xmlns:a16="http://schemas.microsoft.com/office/drawing/2014/main" id="{53E08A80-6406-3243-AA15-9A32B89F703D}"/>
+              </a:ext>
+            </a:extLst>
+          </p:cNvPr>
+          <p:cNvSpPr/>
+          <p:nvPr/>
+        </p:nvSpPr>
+        <p:spPr>
+          <a:xfrm>
+            <a:off x="3197186" y="84312"/>
+            <a:ext cx="2410800" cy="480900"/>
+          </a:xfrm>
+          <a:prstGeom prst="roundRect">
+            <a:avLst>
+              <a:gd name="adj" fmla="val 16667"/>
+            </a:avLst>
+          </a:prstGeom>
+          <a:solidFill>
+            <a:srgbClr val="F9CB9C"/>
+          </a:solidFill>
+          <a:ln w="28575" cap="flat" cmpd="sng">
+            <a:solidFill>
+              <a:srgbClr val="B45F06"/>
+            </a:solidFill>
+            <a:prstDash val="solid"/>
+            <a:round/>
+            <a:headEnd type="none" w="sm" len="sm"/>
+            <a:tailEnd type="none" w="sm" len="sm"/>
+          </a:ln>
+        </p:spPr>
+        <p:txBody>
+          <a:bodyPr spcFirstLastPara="1" wrap="square" lIns="91425" tIns="91425" rIns="91425" bIns="91425" anchor="ctr" anchorCtr="0">
+            <a:noAutofit/>
+          </a:bodyPr>
+          <a:lstStyle/>
+          <a:p>
+            <a:pPr marL="0" lvl="0" indent="0" algn="ctr" rtl="0">
+              <a:spcBef>
+                <a:spcPts val="0"/>
+              </a:spcBef>
+              <a:spcAft>
+                <a:spcPts val="0"/>
+              </a:spcAft>
+              <a:buNone/>
+            </a:pPr>
+            <a:r>
+              <a:rPr lang="en-GB" sz="1800" b="1">
+                <a:latin typeface="Consolas"/>
+                <a:ea typeface="Consolas"/>
+                <a:cs typeface="Consolas"/>
+                <a:sym typeface="Consolas"/>
+              </a:rPr>
+              <a:t>Student ID</a:t>
+            </a:r>
+            <a:endParaRPr sz="1800" b="1">
+              <a:latin typeface="Consolas"/>
+              <a:ea typeface="Consolas"/>
+              <a:cs typeface="Consolas"/>
+              <a:sym typeface="Consolas"/>
+            </a:endParaRPr>
+          </a:p>
+        </p:txBody>
+      </p:sp>
+      <p:sp>
+        <p:nvSpPr>
+          <p:cNvPr id="192" name="Google Shape;192;p19">
+            <a:extLst>
+              <a:ext uri="{FF2B5EF4-FFF2-40B4-BE49-F238E27FC236}">
+                <a16:creationId xmlns:a16="http://schemas.microsoft.com/office/drawing/2014/main" id="{B766C8BB-9C1C-C812-78D6-ADF10B5330C3}"/>
+              </a:ext>
+            </a:extLst>
+          </p:cNvPr>
+          <p:cNvSpPr/>
+          <p:nvPr/>
+        </p:nvSpPr>
+        <p:spPr>
+          <a:xfrm>
+            <a:off x="6281636" y="84312"/>
+            <a:ext cx="2410800" cy="480900"/>
+          </a:xfrm>
+          <a:prstGeom prst="roundRect">
+            <a:avLst>
+              <a:gd name="adj" fmla="val 16667"/>
+            </a:avLst>
+          </a:prstGeom>
+          <a:solidFill>
+            <a:srgbClr val="F9CB9C"/>
+          </a:solidFill>
+          <a:ln w="28575" cap="flat" cmpd="sng">
+            <a:solidFill>
+              <a:srgbClr val="B45F06"/>
+            </a:solidFill>
+            <a:prstDash val="solid"/>
+            <a:round/>
+            <a:headEnd type="none" w="sm" len="sm"/>
+            <a:tailEnd type="none" w="sm" len="sm"/>
+          </a:ln>
+        </p:spPr>
+        <p:txBody>
+          <a:bodyPr spcFirstLastPara="1" wrap="square" lIns="91425" tIns="91425" rIns="91425" bIns="91425" anchor="ctr" anchorCtr="0">
+            <a:noAutofit/>
+          </a:bodyPr>
+          <a:lstStyle/>
+          <a:p>
+            <a:pPr marL="0" lvl="0" indent="0" algn="ctr" rtl="0">
+              <a:spcBef>
+                <a:spcPts val="0"/>
+              </a:spcBef>
+              <a:spcAft>
+                <a:spcPts val="0"/>
+              </a:spcAft>
+              <a:buNone/>
+            </a:pPr>
+            <a:r>
+              <a:rPr lang="en-GB" sz="1800" b="1">
+                <a:latin typeface="Consolas"/>
+                <a:ea typeface="Consolas"/>
+                <a:cs typeface="Consolas"/>
+                <a:sym typeface="Consolas"/>
+              </a:rPr>
+              <a:t>Story</a:t>
+            </a:r>
+            <a:endParaRPr sz="1800" b="1">
+              <a:latin typeface="Consolas"/>
+              <a:ea typeface="Consolas"/>
+              <a:cs typeface="Consolas"/>
+              <a:sym typeface="Consolas"/>
+            </a:endParaRPr>
+          </a:p>
+        </p:txBody>
+      </p:sp>
+      <p:sp>
+        <p:nvSpPr>
+          <p:cNvPr id="193" name="Google Shape;193;p19">
+            <a:extLst>
+              <a:ext uri="{FF2B5EF4-FFF2-40B4-BE49-F238E27FC236}">
+                <a16:creationId xmlns:a16="http://schemas.microsoft.com/office/drawing/2014/main" id="{A2DA2C03-21CB-0279-7188-179D1987853C}"/>
+              </a:ext>
+            </a:extLst>
+          </p:cNvPr>
+          <p:cNvSpPr/>
+          <p:nvPr/>
+        </p:nvSpPr>
+        <p:spPr>
+          <a:xfrm>
+            <a:off x="9366071" y="84312"/>
+            <a:ext cx="2410800" cy="480900"/>
+          </a:xfrm>
+          <a:prstGeom prst="roundRect">
+            <a:avLst>
+              <a:gd name="adj" fmla="val 16667"/>
+            </a:avLst>
+          </a:prstGeom>
+          <a:solidFill>
+            <a:srgbClr val="F9CB9C"/>
+          </a:solidFill>
+          <a:ln w="28575" cap="flat" cmpd="sng">
+            <a:solidFill>
+              <a:srgbClr val="B45F06"/>
+            </a:solidFill>
+            <a:prstDash val="solid"/>
+            <a:round/>
+            <a:headEnd type="none" w="sm" len="sm"/>
+            <a:tailEnd type="none" w="sm" len="sm"/>
+          </a:ln>
+        </p:spPr>
+        <p:txBody>
+          <a:bodyPr spcFirstLastPara="1" wrap="square" lIns="91425" tIns="91425" rIns="91425" bIns="91425" anchor="ctr" anchorCtr="0">
+            <a:noAutofit/>
+          </a:bodyPr>
+          <a:lstStyle/>
+          <a:p>
+            <a:pPr marL="0" lvl="0" indent="0" algn="ctr" rtl="0">
+              <a:spcBef>
+                <a:spcPts val="0"/>
+              </a:spcBef>
+              <a:spcAft>
+                <a:spcPts val="0"/>
+              </a:spcAft>
+              <a:buNone/>
+            </a:pPr>
+            <a:r>
+              <a:rPr lang="en-GB" sz="1800" b="1">
+                <a:latin typeface="Consolas"/>
+                <a:ea typeface="Consolas"/>
+                <a:cs typeface="Consolas"/>
+                <a:sym typeface="Consolas"/>
+              </a:rPr>
+              <a:t>To Do</a:t>
+            </a:r>
+            <a:endParaRPr sz="1800" b="1">
+              <a:latin typeface="Consolas"/>
+              <a:ea typeface="Consolas"/>
+              <a:cs typeface="Consolas"/>
+              <a:sym typeface="Consolas"/>
+            </a:endParaRPr>
+          </a:p>
+        </p:txBody>
+      </p:sp>
+      <p:sp>
+        <p:nvSpPr>
+          <p:cNvPr id="194" name="Google Shape;194;p19">
+            <a:extLst>
+              <a:ext uri="{FF2B5EF4-FFF2-40B4-BE49-F238E27FC236}">
+                <a16:creationId xmlns:a16="http://schemas.microsoft.com/office/drawing/2014/main" id="{D74CCBD2-2A8B-CE03-A44D-2026B1890118}"/>
+              </a:ext>
+            </a:extLst>
+          </p:cNvPr>
+          <p:cNvSpPr/>
+          <p:nvPr/>
+        </p:nvSpPr>
+        <p:spPr>
+          <a:xfrm>
+            <a:off x="12395940" y="84312"/>
+            <a:ext cx="2410800" cy="480900"/>
+          </a:xfrm>
+          <a:prstGeom prst="roundRect">
+            <a:avLst>
+              <a:gd name="adj" fmla="val 16667"/>
+            </a:avLst>
+          </a:prstGeom>
+          <a:solidFill>
+            <a:srgbClr val="F9CB9C"/>
+          </a:solidFill>
+          <a:ln w="28575" cap="flat" cmpd="sng">
+            <a:solidFill>
+              <a:srgbClr val="B45F06"/>
+            </a:solidFill>
+            <a:prstDash val="solid"/>
+            <a:round/>
+            <a:headEnd type="none" w="sm" len="sm"/>
+            <a:tailEnd type="none" w="sm" len="sm"/>
+          </a:ln>
+        </p:spPr>
+        <p:txBody>
+          <a:bodyPr spcFirstLastPara="1" wrap="square" lIns="91425" tIns="91425" rIns="91425" bIns="91425" anchor="ctr" anchorCtr="0">
+            <a:noAutofit/>
+          </a:bodyPr>
+          <a:lstStyle/>
+          <a:p>
+            <a:pPr marL="0" lvl="0" indent="0" algn="ctr" rtl="0">
+              <a:spcBef>
+                <a:spcPts val="0"/>
+              </a:spcBef>
+              <a:spcAft>
+                <a:spcPts val="0"/>
+              </a:spcAft>
+              <a:buNone/>
+            </a:pPr>
+            <a:r>
+              <a:rPr lang="en-GB" sz="1800" b="1">
+                <a:latin typeface="Consolas"/>
+                <a:ea typeface="Consolas"/>
+                <a:cs typeface="Consolas"/>
+                <a:sym typeface="Consolas"/>
+              </a:rPr>
+              <a:t>Doing</a:t>
+            </a:r>
+            <a:endParaRPr sz="1800" b="1">
+              <a:latin typeface="Consolas"/>
+              <a:ea typeface="Consolas"/>
+              <a:cs typeface="Consolas"/>
+              <a:sym typeface="Consolas"/>
+            </a:endParaRPr>
+          </a:p>
+        </p:txBody>
+      </p:sp>
+      <p:sp>
+        <p:nvSpPr>
+          <p:cNvPr id="195" name="Google Shape;195;p19">
+            <a:extLst>
+              <a:ext uri="{FF2B5EF4-FFF2-40B4-BE49-F238E27FC236}">
+                <a16:creationId xmlns:a16="http://schemas.microsoft.com/office/drawing/2014/main" id="{9D76B7A0-C5FB-0F50-0BEB-4AA072E00F33}"/>
+              </a:ext>
+            </a:extLst>
+          </p:cNvPr>
+          <p:cNvSpPr/>
+          <p:nvPr/>
+        </p:nvSpPr>
+        <p:spPr>
+          <a:xfrm>
+            <a:off x="15532407" y="84312"/>
+            <a:ext cx="2410800" cy="480900"/>
+          </a:xfrm>
+          <a:prstGeom prst="roundRect">
+            <a:avLst>
+              <a:gd name="adj" fmla="val 16667"/>
+            </a:avLst>
+          </a:prstGeom>
+          <a:solidFill>
+            <a:srgbClr val="F9CB9C"/>
+          </a:solidFill>
+          <a:ln w="28575" cap="flat" cmpd="sng">
+            <a:solidFill>
+              <a:srgbClr val="B45F06"/>
+            </a:solidFill>
+            <a:prstDash val="solid"/>
+            <a:round/>
+            <a:headEnd type="none" w="sm" len="sm"/>
+            <a:tailEnd type="none" w="sm" len="sm"/>
+          </a:ln>
+        </p:spPr>
+        <p:txBody>
+          <a:bodyPr spcFirstLastPara="1" wrap="square" lIns="91425" tIns="91425" rIns="91425" bIns="91425" anchor="ctr" anchorCtr="0">
+            <a:noAutofit/>
+          </a:bodyPr>
+          <a:lstStyle/>
+          <a:p>
+            <a:pPr marL="0" lvl="0" indent="0" algn="ctr" rtl="0">
+              <a:spcBef>
+                <a:spcPts val="0"/>
+              </a:spcBef>
+              <a:spcAft>
+                <a:spcPts val="0"/>
+              </a:spcAft>
+              <a:buNone/>
+            </a:pPr>
+            <a:r>
+              <a:rPr lang="en-GB" sz="1800" b="1">
+                <a:latin typeface="Consolas"/>
+                <a:ea typeface="Consolas"/>
+                <a:cs typeface="Consolas"/>
+                <a:sym typeface="Consolas"/>
+              </a:rPr>
+              <a:t>Review</a:t>
+            </a:r>
+            <a:endParaRPr sz="1800" b="1">
+              <a:latin typeface="Consolas"/>
+              <a:ea typeface="Consolas"/>
+              <a:cs typeface="Consolas"/>
+              <a:sym typeface="Consolas"/>
+            </a:endParaRPr>
+          </a:p>
+        </p:txBody>
+      </p:sp>
+      <p:sp>
+        <p:nvSpPr>
+          <p:cNvPr id="196" name="Google Shape;196;p19">
+            <a:extLst>
+              <a:ext uri="{FF2B5EF4-FFF2-40B4-BE49-F238E27FC236}">
+                <a16:creationId xmlns:a16="http://schemas.microsoft.com/office/drawing/2014/main" id="{397AA720-78A6-8660-5802-13ABA8179A39}"/>
+              </a:ext>
+            </a:extLst>
+          </p:cNvPr>
+          <p:cNvSpPr/>
+          <p:nvPr/>
+        </p:nvSpPr>
+        <p:spPr>
+          <a:xfrm>
+            <a:off x="18668888" y="84312"/>
+            <a:ext cx="2410800" cy="480900"/>
+          </a:xfrm>
+          <a:prstGeom prst="roundRect">
+            <a:avLst>
+              <a:gd name="adj" fmla="val 16667"/>
+            </a:avLst>
+          </a:prstGeom>
+          <a:solidFill>
+            <a:srgbClr val="F9CB9C"/>
+          </a:solidFill>
+          <a:ln w="28575" cap="flat" cmpd="sng">
+            <a:solidFill>
+              <a:srgbClr val="B45F06"/>
+            </a:solidFill>
+            <a:prstDash val="solid"/>
+            <a:round/>
+            <a:headEnd type="none" w="sm" len="sm"/>
+            <a:tailEnd type="none" w="sm" len="sm"/>
+          </a:ln>
+        </p:spPr>
+        <p:txBody>
+          <a:bodyPr spcFirstLastPara="1" wrap="square" lIns="91425" tIns="91425" rIns="91425" bIns="91425" anchor="ctr" anchorCtr="0">
+            <a:noAutofit/>
+          </a:bodyPr>
+          <a:lstStyle/>
+          <a:p>
+            <a:pPr marL="0" lvl="0" indent="0" algn="ctr" rtl="0">
+              <a:spcBef>
+                <a:spcPts val="0"/>
+              </a:spcBef>
+              <a:spcAft>
+                <a:spcPts val="0"/>
+              </a:spcAft>
+              <a:buNone/>
+            </a:pPr>
+            <a:r>
+              <a:rPr lang="en-GB" sz="1800" b="1">
+                <a:latin typeface="Consolas"/>
+                <a:ea typeface="Consolas"/>
+                <a:cs typeface="Consolas"/>
+                <a:sym typeface="Consolas"/>
+              </a:rPr>
+              <a:t>Done</a:t>
+            </a:r>
+            <a:endParaRPr sz="1800" b="1">
+              <a:latin typeface="Consolas"/>
+              <a:ea typeface="Consolas"/>
+              <a:cs typeface="Consolas"/>
+              <a:sym typeface="Consolas"/>
+            </a:endParaRPr>
+          </a:p>
+        </p:txBody>
+      </p:sp>
+      <p:sp>
+        <p:nvSpPr>
+          <p:cNvPr id="197" name="Google Shape;197;p19">
+            <a:extLst>
+              <a:ext uri="{FF2B5EF4-FFF2-40B4-BE49-F238E27FC236}">
+                <a16:creationId xmlns:a16="http://schemas.microsoft.com/office/drawing/2014/main" id="{EBBFF82B-E7C5-8DA3-48A6-F78E8D19BB64}"/>
+              </a:ext>
+            </a:extLst>
+          </p:cNvPr>
+          <p:cNvSpPr/>
+          <p:nvPr/>
+        </p:nvSpPr>
+        <p:spPr>
+          <a:xfrm>
+            <a:off x="167288" y="84312"/>
+            <a:ext cx="2410800" cy="480900"/>
+          </a:xfrm>
+          <a:prstGeom prst="roundRect">
+            <a:avLst>
+              <a:gd name="adj" fmla="val 16667"/>
+            </a:avLst>
+          </a:prstGeom>
+          <a:solidFill>
+            <a:srgbClr val="F9CB9C"/>
+          </a:solidFill>
+          <a:ln w="28575" cap="flat" cmpd="sng">
+            <a:solidFill>
+              <a:srgbClr val="B45F06"/>
+            </a:solidFill>
+            <a:prstDash val="solid"/>
+            <a:round/>
+            <a:headEnd type="none" w="sm" len="sm"/>
+            <a:tailEnd type="none" w="sm" len="sm"/>
+          </a:ln>
+        </p:spPr>
+        <p:txBody>
+          <a:bodyPr spcFirstLastPara="1" wrap="square" lIns="91425" tIns="91425" rIns="91425" bIns="91425" anchor="ctr" anchorCtr="0">
+            <a:noAutofit/>
+          </a:bodyPr>
+          <a:lstStyle/>
+          <a:p>
+            <a:pPr marL="0" lvl="0" indent="0" algn="ctr" rtl="0">
+              <a:spcBef>
+                <a:spcPts val="0"/>
+              </a:spcBef>
+              <a:spcAft>
+                <a:spcPts val="0"/>
+              </a:spcAft>
+              <a:buNone/>
+            </a:pPr>
+            <a:r>
+              <a:rPr lang="en-GB" sz="1800" b="1">
+                <a:latin typeface="Consolas"/>
+                <a:ea typeface="Consolas"/>
+                <a:cs typeface="Consolas"/>
+                <a:sym typeface="Consolas"/>
+              </a:rPr>
+              <a:t>Backlog</a:t>
+            </a:r>
+            <a:endParaRPr sz="1800" b="1">
+              <a:latin typeface="Consolas"/>
+              <a:ea typeface="Consolas"/>
+              <a:cs typeface="Consolas"/>
+              <a:sym typeface="Consolas"/>
+            </a:endParaRPr>
+          </a:p>
+        </p:txBody>
+      </p:sp>
+      <p:cxnSp>
+        <p:nvCxnSpPr>
+          <p:cNvPr id="204" name="Google Shape;204;p19">
+            <a:extLst>
+              <a:ext uri="{FF2B5EF4-FFF2-40B4-BE49-F238E27FC236}">
+                <a16:creationId xmlns:a16="http://schemas.microsoft.com/office/drawing/2014/main" id="{2259EB59-B273-F2DB-06DF-675D24754971}"/>
+              </a:ext>
+            </a:extLst>
+          </p:cNvPr>
+          <p:cNvCxnSpPr/>
+          <p:nvPr/>
+        </p:nvCxnSpPr>
+        <p:spPr>
+          <a:xfrm>
+            <a:off x="5607986" y="1626038"/>
+            <a:ext cx="16042200" cy="0"/>
+          </a:xfrm>
+          <a:prstGeom prst="straightConnector1">
+            <a:avLst/>
+          </a:prstGeom>
+          <a:noFill/>
+          <a:ln w="28575" cap="flat" cmpd="sng">
+            <a:solidFill>
+              <a:srgbClr val="999999"/>
+            </a:solidFill>
+            <a:prstDash val="dash"/>
+            <a:round/>
+            <a:headEnd type="none" w="med" len="med"/>
+            <a:tailEnd type="none" w="med" len="med"/>
+          </a:ln>
+        </p:spPr>
+      </p:cxnSp>
+      <p:cxnSp>
+        <p:nvCxnSpPr>
+          <p:cNvPr id="205" name="Google Shape;205;p19">
+            <a:extLst>
+              <a:ext uri="{FF2B5EF4-FFF2-40B4-BE49-F238E27FC236}">
+                <a16:creationId xmlns:a16="http://schemas.microsoft.com/office/drawing/2014/main" id="{55DC087E-745A-CF31-CAC7-0B8C8673F78F}"/>
+              </a:ext>
+            </a:extLst>
+          </p:cNvPr>
+          <p:cNvCxnSpPr/>
+          <p:nvPr/>
+        </p:nvCxnSpPr>
+        <p:spPr>
+          <a:xfrm>
+            <a:off x="5607986" y="3203476"/>
+            <a:ext cx="16042200" cy="0"/>
+          </a:xfrm>
+          <a:prstGeom prst="straightConnector1">
+            <a:avLst/>
+          </a:prstGeom>
+          <a:noFill/>
+          <a:ln w="28575" cap="flat" cmpd="sng">
+            <a:solidFill>
+              <a:srgbClr val="999999"/>
+            </a:solidFill>
+            <a:prstDash val="dash"/>
+            <a:round/>
+            <a:headEnd type="none" w="med" len="med"/>
+            <a:tailEnd type="none" w="med" len="med"/>
+          </a:ln>
+        </p:spPr>
+      </p:cxnSp>
+      <p:cxnSp>
+        <p:nvCxnSpPr>
+          <p:cNvPr id="206" name="Google Shape;206;p19">
+            <a:extLst>
+              <a:ext uri="{FF2B5EF4-FFF2-40B4-BE49-F238E27FC236}">
+                <a16:creationId xmlns:a16="http://schemas.microsoft.com/office/drawing/2014/main" id="{1DA534EC-E995-21D9-4ACF-4F2A6AD07B77}"/>
+              </a:ext>
+            </a:extLst>
+          </p:cNvPr>
+          <p:cNvCxnSpPr/>
+          <p:nvPr/>
+        </p:nvCxnSpPr>
+        <p:spPr>
+          <a:xfrm>
+            <a:off x="5607986" y="4777838"/>
+            <a:ext cx="16042200" cy="0"/>
+          </a:xfrm>
+          <a:prstGeom prst="straightConnector1">
+            <a:avLst/>
+          </a:prstGeom>
+          <a:noFill/>
+          <a:ln w="28575" cap="flat" cmpd="sng">
+            <a:solidFill>
+              <a:srgbClr val="999999"/>
+            </a:solidFill>
+            <a:prstDash val="dash"/>
+            <a:round/>
+            <a:headEnd type="none" w="med" len="med"/>
+            <a:tailEnd type="none" w="med" len="med"/>
+          </a:ln>
+        </p:spPr>
+      </p:cxnSp>
+      <p:cxnSp>
+        <p:nvCxnSpPr>
+          <p:cNvPr id="207" name="Google Shape;207;p19">
+            <a:extLst>
+              <a:ext uri="{FF2B5EF4-FFF2-40B4-BE49-F238E27FC236}">
+                <a16:creationId xmlns:a16="http://schemas.microsoft.com/office/drawing/2014/main" id="{A76697D3-F098-B859-4770-1D8FF517EA5D}"/>
+              </a:ext>
+            </a:extLst>
+          </p:cNvPr>
+          <p:cNvCxnSpPr/>
+          <p:nvPr/>
+        </p:nvCxnSpPr>
+        <p:spPr>
+          <a:xfrm>
+            <a:off x="5607986" y="6353738"/>
+            <a:ext cx="16042200" cy="0"/>
+          </a:xfrm>
+          <a:prstGeom prst="straightConnector1">
+            <a:avLst/>
+          </a:prstGeom>
+          <a:noFill/>
+          <a:ln w="28575" cap="flat" cmpd="sng">
+            <a:solidFill>
+              <a:srgbClr val="999999"/>
+            </a:solidFill>
+            <a:prstDash val="dash"/>
+            <a:round/>
+            <a:headEnd type="none" w="med" len="med"/>
+            <a:tailEnd type="none" w="med" len="med"/>
+          </a:ln>
+        </p:spPr>
+      </p:cxnSp>
+      <p:cxnSp>
+        <p:nvCxnSpPr>
+          <p:cNvPr id="208" name="Google Shape;208;p19">
+            <a:extLst>
+              <a:ext uri="{FF2B5EF4-FFF2-40B4-BE49-F238E27FC236}">
+                <a16:creationId xmlns:a16="http://schemas.microsoft.com/office/drawing/2014/main" id="{52A52FAC-76B2-F704-781C-CD0063BE627E}"/>
+              </a:ext>
+            </a:extLst>
+          </p:cNvPr>
+          <p:cNvCxnSpPr/>
+          <p:nvPr/>
+        </p:nvCxnSpPr>
+        <p:spPr>
+          <a:xfrm>
+            <a:off x="5607986" y="7929638"/>
+            <a:ext cx="16042200" cy="0"/>
+          </a:xfrm>
+          <a:prstGeom prst="straightConnector1">
+            <a:avLst/>
+          </a:prstGeom>
+          <a:noFill/>
+          <a:ln w="28575" cap="flat" cmpd="sng">
+            <a:solidFill>
+              <a:srgbClr val="999999"/>
+            </a:solidFill>
+            <a:prstDash val="dash"/>
+            <a:round/>
+            <a:headEnd type="none" w="med" len="med"/>
+            <a:tailEnd type="none" w="med" len="med"/>
+          </a:ln>
+        </p:spPr>
+      </p:cxnSp>
+      <p:cxnSp>
+        <p:nvCxnSpPr>
+          <p:cNvPr id="209" name="Google Shape;209;p19">
+            <a:extLst>
+              <a:ext uri="{FF2B5EF4-FFF2-40B4-BE49-F238E27FC236}">
+                <a16:creationId xmlns:a16="http://schemas.microsoft.com/office/drawing/2014/main" id="{4ECB4353-E440-A9BB-BD0C-1A56B112E6ED}"/>
+              </a:ext>
+            </a:extLst>
+          </p:cNvPr>
+          <p:cNvCxnSpPr/>
+          <p:nvPr/>
+        </p:nvCxnSpPr>
+        <p:spPr>
+          <a:xfrm>
+            <a:off x="5607986" y="9505538"/>
+            <a:ext cx="16042200" cy="0"/>
+          </a:xfrm>
+          <a:prstGeom prst="straightConnector1">
+            <a:avLst/>
+          </a:prstGeom>
+          <a:noFill/>
+          <a:ln w="28575" cap="flat" cmpd="sng">
+            <a:solidFill>
+              <a:srgbClr val="999999"/>
+            </a:solidFill>
+            <a:prstDash val="dash"/>
+            <a:round/>
+            <a:headEnd type="none" w="med" len="med"/>
+            <a:tailEnd type="none" w="med" len="med"/>
+          </a:ln>
+        </p:spPr>
+      </p:cxnSp>
+      <p:cxnSp>
+        <p:nvCxnSpPr>
+          <p:cNvPr id="215" name="Google Shape;215;p19">
+            <a:extLst>
+              <a:ext uri="{FF2B5EF4-FFF2-40B4-BE49-F238E27FC236}">
+                <a16:creationId xmlns:a16="http://schemas.microsoft.com/office/drawing/2014/main" id="{EEC22EA1-A931-13F1-9761-991C769F43F3}"/>
+              </a:ext>
+            </a:extLst>
+          </p:cNvPr>
+          <p:cNvCxnSpPr/>
+          <p:nvPr/>
+        </p:nvCxnSpPr>
+        <p:spPr>
+          <a:xfrm>
+            <a:off x="2874374" y="-28500"/>
+            <a:ext cx="0" cy="10857000"/>
+          </a:xfrm>
+          <a:prstGeom prst="straightConnector1">
+            <a:avLst/>
+          </a:prstGeom>
+          <a:noFill/>
+          <a:ln w="38100" cap="flat" cmpd="sng">
+            <a:solidFill>
+              <a:srgbClr val="5B0F00"/>
+            </a:solidFill>
+            <a:prstDash val="solid"/>
+            <a:round/>
+            <a:headEnd type="none" w="med" len="med"/>
+            <a:tailEnd type="none" w="med" len="med"/>
+          </a:ln>
+        </p:spPr>
+      </p:cxnSp>
+      <p:sp>
+        <p:nvSpPr>
+          <p:cNvPr id="2" name="Google Shape;74;p15">
+            <a:extLst>
+              <a:ext uri="{FF2B5EF4-FFF2-40B4-BE49-F238E27FC236}">
+                <a16:creationId xmlns:a16="http://schemas.microsoft.com/office/drawing/2014/main" id="{33251596-01CF-6617-6B2B-D9144C95B4AB}"/>
+              </a:ext>
+            </a:extLst>
+          </p:cNvPr>
+          <p:cNvSpPr/>
+          <p:nvPr/>
+        </p:nvSpPr>
+        <p:spPr>
+          <a:xfrm>
+            <a:off x="3197186" y="1385588"/>
+            <a:ext cx="2410800" cy="480900"/>
+          </a:xfrm>
+          <a:prstGeom prst="roundRect">
+            <a:avLst>
+              <a:gd name="adj" fmla="val 16667"/>
+            </a:avLst>
+          </a:prstGeom>
+          <a:solidFill>
+            <a:srgbClr val="E6B8AF"/>
+          </a:solidFill>
+          <a:ln w="28575" cap="flat" cmpd="sng">
+            <a:solidFill>
+              <a:srgbClr val="5B0F00"/>
+            </a:solidFill>
+            <a:prstDash val="solid"/>
+            <a:round/>
+            <a:headEnd type="none" w="sm" len="sm"/>
+            <a:tailEnd type="none" w="sm" len="sm"/>
+          </a:ln>
+        </p:spPr>
+        <p:txBody>
+          <a:bodyPr spcFirstLastPara="1" wrap="square" lIns="91425" tIns="91425" rIns="91425" bIns="91425" anchor="ctr" anchorCtr="0">
+            <a:noAutofit/>
+          </a:bodyPr>
+          <a:lstStyle/>
+          <a:p>
+            <a:pPr marL="0" lvl="0" indent="0" algn="ctr" rtl="0">
+              <a:spcBef>
+                <a:spcPts val="0"/>
+              </a:spcBef>
+              <a:spcAft>
+                <a:spcPts val="0"/>
+              </a:spcAft>
+              <a:buNone/>
+            </a:pPr>
+            <a:r>
+              <a:rPr lang="en-GB" sz="1800" b="1" dirty="0">
+                <a:latin typeface="Consolas"/>
+                <a:ea typeface="Consolas"/>
+                <a:cs typeface="Consolas"/>
+                <a:sym typeface="Consolas"/>
+              </a:rPr>
+              <a:t>68338</a:t>
+            </a:r>
+            <a:endParaRPr sz="1800" b="1" dirty="0">
+              <a:latin typeface="Consolas"/>
+              <a:ea typeface="Consolas"/>
+              <a:cs typeface="Consolas"/>
+              <a:sym typeface="Consolas"/>
+            </a:endParaRPr>
+          </a:p>
+        </p:txBody>
+      </p:sp>
+      <p:sp>
+        <p:nvSpPr>
+          <p:cNvPr id="3" name="Google Shape;75;p15">
+            <a:extLst>
+              <a:ext uri="{FF2B5EF4-FFF2-40B4-BE49-F238E27FC236}">
+                <a16:creationId xmlns:a16="http://schemas.microsoft.com/office/drawing/2014/main" id="{1E7C6928-90D1-CF6D-BD5E-3436820C16A5}"/>
+              </a:ext>
+            </a:extLst>
+          </p:cNvPr>
+          <p:cNvSpPr/>
+          <p:nvPr/>
+        </p:nvSpPr>
+        <p:spPr>
+          <a:xfrm>
+            <a:off x="3197186" y="2961501"/>
+            <a:ext cx="2410800" cy="480900"/>
+          </a:xfrm>
+          <a:prstGeom prst="roundRect">
+            <a:avLst>
+              <a:gd name="adj" fmla="val 16667"/>
+            </a:avLst>
+          </a:prstGeom>
+          <a:solidFill>
+            <a:srgbClr val="E6B8AF"/>
+          </a:solidFill>
+          <a:ln w="28575" cap="flat" cmpd="sng">
+            <a:solidFill>
+              <a:srgbClr val="5B0F00"/>
+            </a:solidFill>
+            <a:prstDash val="solid"/>
+            <a:round/>
+            <a:headEnd type="none" w="sm" len="sm"/>
+            <a:tailEnd type="none" w="sm" len="sm"/>
+          </a:ln>
+        </p:spPr>
+        <p:txBody>
+          <a:bodyPr spcFirstLastPara="1" wrap="square" lIns="91425" tIns="91425" rIns="91425" bIns="91425" anchor="ctr" anchorCtr="0">
+            <a:noAutofit/>
+          </a:bodyPr>
+          <a:lstStyle/>
+          <a:p>
+            <a:pPr marL="0" lvl="0" indent="0" algn="ctr" rtl="0">
+              <a:spcBef>
+                <a:spcPts val="0"/>
+              </a:spcBef>
+              <a:spcAft>
+                <a:spcPts val="0"/>
+              </a:spcAft>
+              <a:buNone/>
+            </a:pPr>
+            <a:r>
+              <a:rPr lang="en-GB" sz="1800" b="1" dirty="0">
+                <a:latin typeface="Consolas"/>
+                <a:ea typeface="Consolas"/>
+                <a:cs typeface="Consolas"/>
+                <a:sym typeface="Consolas"/>
+              </a:rPr>
+              <a:t>68245</a:t>
+            </a:r>
+            <a:endParaRPr sz="1800" b="1" dirty="0">
+              <a:latin typeface="Consolas"/>
+              <a:ea typeface="Consolas"/>
+              <a:cs typeface="Consolas"/>
+              <a:sym typeface="Consolas"/>
+            </a:endParaRPr>
+          </a:p>
+        </p:txBody>
+      </p:sp>
+      <p:sp>
+        <p:nvSpPr>
+          <p:cNvPr id="4" name="Google Shape;76;p15">
+            <a:extLst>
+              <a:ext uri="{FF2B5EF4-FFF2-40B4-BE49-F238E27FC236}">
+                <a16:creationId xmlns:a16="http://schemas.microsoft.com/office/drawing/2014/main" id="{6CFEA7C7-F3F9-84A8-77E2-A78AE9233EE8}"/>
+              </a:ext>
+            </a:extLst>
+          </p:cNvPr>
+          <p:cNvSpPr/>
+          <p:nvPr/>
+        </p:nvSpPr>
+        <p:spPr>
+          <a:xfrm>
+            <a:off x="3197186" y="4537410"/>
+            <a:ext cx="2410800" cy="480900"/>
+          </a:xfrm>
+          <a:prstGeom prst="roundRect">
+            <a:avLst>
+              <a:gd name="adj" fmla="val 16667"/>
+            </a:avLst>
+          </a:prstGeom>
+          <a:solidFill>
+            <a:srgbClr val="E6B8AF"/>
+          </a:solidFill>
+          <a:ln w="28575" cap="flat" cmpd="sng">
+            <a:solidFill>
+              <a:srgbClr val="5B0F00"/>
+            </a:solidFill>
+            <a:prstDash val="solid"/>
+            <a:round/>
+            <a:headEnd type="none" w="sm" len="sm"/>
+            <a:tailEnd type="none" w="sm" len="sm"/>
+          </a:ln>
+        </p:spPr>
+        <p:txBody>
+          <a:bodyPr spcFirstLastPara="1" wrap="square" lIns="91425" tIns="91425" rIns="91425" bIns="91425" anchor="ctr" anchorCtr="0">
+            <a:noAutofit/>
+          </a:bodyPr>
+          <a:lstStyle/>
+          <a:p>
+            <a:pPr marL="0" lvl="0" indent="0" algn="ctr" rtl="0">
+              <a:spcBef>
+                <a:spcPts val="0"/>
+              </a:spcBef>
+              <a:spcAft>
+                <a:spcPts val="0"/>
+              </a:spcAft>
+              <a:buNone/>
+            </a:pPr>
+            <a:r>
+              <a:rPr lang="en-GB" sz="1800" b="1" dirty="0">
+                <a:latin typeface="Consolas"/>
+                <a:ea typeface="Consolas"/>
+                <a:cs typeface="Consolas"/>
+                <a:sym typeface="Consolas"/>
+              </a:rPr>
+              <a:t>68725</a:t>
+            </a:r>
+            <a:endParaRPr sz="1800" b="1" dirty="0">
+              <a:latin typeface="Consolas"/>
+              <a:ea typeface="Consolas"/>
+              <a:cs typeface="Consolas"/>
+              <a:sym typeface="Consolas"/>
+            </a:endParaRPr>
+          </a:p>
+        </p:txBody>
+      </p:sp>
+      <p:sp>
+        <p:nvSpPr>
+          <p:cNvPr id="5" name="Google Shape;77;p15">
+            <a:extLst>
+              <a:ext uri="{FF2B5EF4-FFF2-40B4-BE49-F238E27FC236}">
+                <a16:creationId xmlns:a16="http://schemas.microsoft.com/office/drawing/2014/main" id="{85273765-67E8-BB48-AD7C-8C86130B67F1}"/>
+              </a:ext>
+            </a:extLst>
+          </p:cNvPr>
+          <p:cNvSpPr/>
+          <p:nvPr/>
+        </p:nvSpPr>
+        <p:spPr>
+          <a:xfrm>
+            <a:off x="3197186" y="6113307"/>
+            <a:ext cx="2410800" cy="480900"/>
+          </a:xfrm>
+          <a:prstGeom prst="roundRect">
+            <a:avLst>
+              <a:gd name="adj" fmla="val 16667"/>
+            </a:avLst>
+          </a:prstGeom>
+          <a:solidFill>
+            <a:srgbClr val="E6B8AF"/>
+          </a:solidFill>
+          <a:ln w="28575" cap="flat" cmpd="sng">
+            <a:solidFill>
+              <a:srgbClr val="5B0F00"/>
+            </a:solidFill>
+            <a:prstDash val="solid"/>
+            <a:round/>
+            <a:headEnd type="none" w="sm" len="sm"/>
+            <a:tailEnd type="none" w="sm" len="sm"/>
+          </a:ln>
+        </p:spPr>
+        <p:txBody>
+          <a:bodyPr spcFirstLastPara="1" wrap="square" lIns="91425" tIns="91425" rIns="91425" bIns="91425" anchor="ctr" anchorCtr="0">
+            <a:noAutofit/>
+          </a:bodyPr>
+          <a:lstStyle/>
+          <a:p>
+            <a:pPr marL="0" lvl="0" indent="0" algn="ctr" rtl="0">
+              <a:spcBef>
+                <a:spcPts val="0"/>
+              </a:spcBef>
+              <a:spcAft>
+                <a:spcPts val="0"/>
+              </a:spcAft>
+              <a:buNone/>
+            </a:pPr>
+            <a:r>
+              <a:rPr lang="en-GB" sz="1800" b="1" dirty="0">
+                <a:latin typeface="Consolas"/>
+                <a:ea typeface="Consolas"/>
+                <a:cs typeface="Consolas"/>
+                <a:sym typeface="Consolas"/>
+              </a:rPr>
+              <a:t>68180</a:t>
+            </a:r>
+            <a:endParaRPr sz="1800" b="1" dirty="0">
+              <a:latin typeface="Consolas"/>
+              <a:ea typeface="Consolas"/>
+              <a:cs typeface="Consolas"/>
+              <a:sym typeface="Consolas"/>
+            </a:endParaRPr>
+          </a:p>
+        </p:txBody>
+      </p:sp>
+      <p:sp>
+        <p:nvSpPr>
+          <p:cNvPr id="6" name="Google Shape;78;p15">
+            <a:extLst>
+              <a:ext uri="{FF2B5EF4-FFF2-40B4-BE49-F238E27FC236}">
+                <a16:creationId xmlns:a16="http://schemas.microsoft.com/office/drawing/2014/main" id="{22F3ED50-C031-2025-955B-D50A506816B8}"/>
+              </a:ext>
+            </a:extLst>
+          </p:cNvPr>
+          <p:cNvSpPr/>
+          <p:nvPr/>
+        </p:nvSpPr>
+        <p:spPr>
+          <a:xfrm>
+            <a:off x="3197186" y="7689198"/>
+            <a:ext cx="2410800" cy="480900"/>
+          </a:xfrm>
+          <a:prstGeom prst="roundRect">
+            <a:avLst>
+              <a:gd name="adj" fmla="val 16667"/>
+            </a:avLst>
+          </a:prstGeom>
+          <a:solidFill>
+            <a:srgbClr val="E6B8AF"/>
+          </a:solidFill>
+          <a:ln w="28575" cap="flat" cmpd="sng">
+            <a:solidFill>
+              <a:srgbClr val="5B0F00"/>
+            </a:solidFill>
+            <a:prstDash val="solid"/>
+            <a:round/>
+            <a:headEnd type="none" w="sm" len="sm"/>
+            <a:tailEnd type="none" w="sm" len="sm"/>
+          </a:ln>
+        </p:spPr>
+        <p:txBody>
+          <a:bodyPr spcFirstLastPara="1" wrap="square" lIns="91425" tIns="91425" rIns="91425" bIns="91425" anchor="ctr" anchorCtr="0">
+            <a:noAutofit/>
+          </a:bodyPr>
+          <a:lstStyle/>
+          <a:p>
+            <a:pPr marL="0" lvl="0" indent="0" algn="ctr" rtl="0">
+              <a:spcBef>
+                <a:spcPts val="0"/>
+              </a:spcBef>
+              <a:spcAft>
+                <a:spcPts val="0"/>
+              </a:spcAft>
+              <a:buNone/>
+            </a:pPr>
+            <a:r>
+              <a:rPr lang="en-GB" sz="1800" b="1" dirty="0">
+                <a:latin typeface="Consolas"/>
+                <a:ea typeface="Consolas"/>
+                <a:cs typeface="Consolas"/>
+                <a:sym typeface="Consolas"/>
+              </a:rPr>
+              <a:t>67912</a:t>
+            </a:r>
+            <a:endParaRPr sz="1800" b="1" dirty="0">
+              <a:latin typeface="Consolas"/>
+              <a:ea typeface="Consolas"/>
+              <a:cs typeface="Consolas"/>
+              <a:sym typeface="Consolas"/>
+            </a:endParaRPr>
+          </a:p>
+        </p:txBody>
+      </p:sp>
+      <p:sp>
+        <p:nvSpPr>
+          <p:cNvPr id="7" name="Google Shape;79;p15">
+            <a:extLst>
+              <a:ext uri="{FF2B5EF4-FFF2-40B4-BE49-F238E27FC236}">
+                <a16:creationId xmlns:a16="http://schemas.microsoft.com/office/drawing/2014/main" id="{AA0E5BFF-83AC-CFFD-C788-1B75F342BDDF}"/>
+              </a:ext>
+            </a:extLst>
+          </p:cNvPr>
+          <p:cNvSpPr/>
+          <p:nvPr/>
+        </p:nvSpPr>
+        <p:spPr>
+          <a:xfrm>
+            <a:off x="3197186" y="9265103"/>
+            <a:ext cx="2410800" cy="480900"/>
+          </a:xfrm>
+          <a:prstGeom prst="roundRect">
+            <a:avLst>
+              <a:gd name="adj" fmla="val 16667"/>
+            </a:avLst>
+          </a:prstGeom>
+          <a:solidFill>
+            <a:srgbClr val="E6B8AF"/>
+          </a:solidFill>
+          <a:ln w="28575" cap="flat" cmpd="sng">
+            <a:solidFill>
+              <a:srgbClr val="5B0F00"/>
+            </a:solidFill>
+            <a:prstDash val="solid"/>
+            <a:round/>
+            <a:headEnd type="none" w="sm" len="sm"/>
+            <a:tailEnd type="none" w="sm" len="sm"/>
+          </a:ln>
+        </p:spPr>
+        <p:txBody>
+          <a:bodyPr spcFirstLastPara="1" wrap="square" lIns="91425" tIns="91425" rIns="91425" bIns="91425" anchor="ctr" anchorCtr="0">
+            <a:noAutofit/>
+          </a:bodyPr>
+          <a:lstStyle/>
+          <a:p>
+            <a:pPr marL="0" lvl="0" indent="0" algn="ctr" rtl="0">
+              <a:spcBef>
+                <a:spcPts val="0"/>
+              </a:spcBef>
+              <a:spcAft>
+                <a:spcPts val="0"/>
+              </a:spcAft>
+              <a:buNone/>
+            </a:pPr>
+            <a:r>
+              <a:rPr lang="en-GB" sz="1800" b="1" dirty="0">
+                <a:latin typeface="Consolas"/>
+                <a:ea typeface="Consolas"/>
+                <a:cs typeface="Consolas"/>
+                <a:sym typeface="Consolas"/>
+              </a:rPr>
+              <a:t>67870</a:t>
+            </a:r>
+            <a:endParaRPr sz="1800" b="1" dirty="0">
+              <a:latin typeface="Consolas"/>
+              <a:ea typeface="Consolas"/>
+              <a:cs typeface="Consolas"/>
+              <a:sym typeface="Consolas"/>
+            </a:endParaRPr>
+          </a:p>
+        </p:txBody>
+      </p:sp>
+      <p:sp>
+        <p:nvSpPr>
+          <p:cNvPr id="19" name="Google Shape;86;p15">
+            <a:extLst>
+              <a:ext uri="{FF2B5EF4-FFF2-40B4-BE49-F238E27FC236}">
+                <a16:creationId xmlns:a16="http://schemas.microsoft.com/office/drawing/2014/main" id="{6CA111D6-AFBA-EBD9-48F0-7FACABD6E572}"/>
+              </a:ext>
+            </a:extLst>
+          </p:cNvPr>
+          <p:cNvSpPr/>
+          <p:nvPr/>
+        </p:nvSpPr>
+        <p:spPr>
+          <a:xfrm>
+            <a:off x="6113258" y="1294224"/>
+            <a:ext cx="2609591" cy="8864188"/>
+          </a:xfrm>
+          <a:prstGeom prst="roundRect">
+            <a:avLst>
+              <a:gd name="adj" fmla="val 16667"/>
+            </a:avLst>
+          </a:prstGeom>
+          <a:solidFill>
+            <a:srgbClr val="D9EAD3"/>
+          </a:solidFill>
+          <a:ln w="28575" cap="flat" cmpd="sng">
+            <a:solidFill>
+              <a:srgbClr val="274E13"/>
+            </a:solidFill>
+            <a:prstDash val="solid"/>
+            <a:round/>
+            <a:headEnd type="none" w="sm" len="sm"/>
+            <a:tailEnd type="none" w="sm" len="sm"/>
+          </a:ln>
+        </p:spPr>
+        <p:txBody>
+          <a:bodyPr spcFirstLastPara="1" wrap="square" lIns="91425" tIns="91425" rIns="91425" bIns="91425" anchor="t" anchorCtr="0">
+            <a:noAutofit/>
+          </a:bodyPr>
+          <a:lstStyle/>
+          <a:p>
+            <a:pPr marL="0" lvl="0" indent="0" rtl="0">
+              <a:spcBef>
+                <a:spcPts val="0"/>
+              </a:spcBef>
+              <a:spcAft>
+                <a:spcPts val="0"/>
+              </a:spcAft>
+              <a:buNone/>
+            </a:pPr>
+            <a:r>
+              <a:rPr lang="en-GB" dirty="0">
+                <a:latin typeface="Consolas"/>
+                <a:ea typeface="Consolas"/>
+                <a:cs typeface="Consolas"/>
+                <a:sym typeface="Consolas"/>
+              </a:rPr>
+              <a:t>US1: Como </a:t>
+            </a:r>
+            <a:r>
+              <a:rPr lang="en-GB" dirty="0" err="1">
+                <a:latin typeface="Consolas"/>
+                <a:ea typeface="Consolas"/>
+                <a:cs typeface="Consolas"/>
+                <a:sym typeface="Consolas"/>
+              </a:rPr>
+              <a:t>membro</a:t>
+            </a:r>
+            <a:r>
+              <a:rPr lang="en-GB" dirty="0">
+                <a:latin typeface="Consolas"/>
+                <a:ea typeface="Consolas"/>
+                <a:cs typeface="Consolas"/>
+                <a:sym typeface="Consolas"/>
+              </a:rPr>
+              <a:t> da </a:t>
+            </a:r>
+            <a:r>
+              <a:rPr lang="en-GB" dirty="0" err="1">
+                <a:latin typeface="Consolas"/>
+                <a:ea typeface="Consolas"/>
+                <a:cs typeface="Consolas"/>
+                <a:sym typeface="Consolas"/>
+              </a:rPr>
+              <a:t>equipa</a:t>
+            </a:r>
+            <a:r>
+              <a:rPr lang="en-GB" dirty="0">
+                <a:latin typeface="Consolas"/>
+                <a:ea typeface="Consolas"/>
+                <a:cs typeface="Consolas"/>
+                <a:sym typeface="Consolas"/>
+              </a:rPr>
+              <a:t>, </a:t>
+            </a:r>
+            <a:r>
+              <a:rPr lang="en-GB" dirty="0" err="1">
+                <a:latin typeface="Consolas"/>
+                <a:ea typeface="Consolas"/>
+                <a:cs typeface="Consolas"/>
+                <a:sym typeface="Consolas"/>
+              </a:rPr>
+              <a:t>quero</a:t>
+            </a:r>
+            <a:r>
+              <a:rPr lang="en-GB" dirty="0">
+                <a:latin typeface="Consolas"/>
+                <a:ea typeface="Consolas"/>
+                <a:cs typeface="Consolas"/>
+                <a:sym typeface="Consolas"/>
+              </a:rPr>
+              <a:t> </a:t>
+            </a:r>
+            <a:r>
+              <a:rPr lang="en-GB" dirty="0" err="1">
+                <a:latin typeface="Consolas"/>
+                <a:ea typeface="Consolas"/>
+                <a:cs typeface="Consolas"/>
+                <a:sym typeface="Consolas"/>
+              </a:rPr>
+              <a:t>implementar</a:t>
+            </a:r>
+            <a:r>
+              <a:rPr lang="en-GB" dirty="0">
+                <a:latin typeface="Consolas"/>
+                <a:ea typeface="Consolas"/>
+                <a:cs typeface="Consolas"/>
+                <a:sym typeface="Consolas"/>
+              </a:rPr>
+              <a:t> um modo de </a:t>
+            </a:r>
+            <a:r>
+              <a:rPr lang="en-GB" dirty="0" err="1">
+                <a:latin typeface="Consolas"/>
+                <a:ea typeface="Consolas"/>
+                <a:cs typeface="Consolas"/>
+                <a:sym typeface="Consolas"/>
+              </a:rPr>
+              <a:t>jogo</a:t>
+            </a:r>
+            <a:r>
+              <a:rPr lang="en-GB" dirty="0">
+                <a:latin typeface="Consolas"/>
+                <a:ea typeface="Consolas"/>
+                <a:cs typeface="Consolas"/>
+                <a:sym typeface="Consolas"/>
+              </a:rPr>
+              <a:t> </a:t>
+            </a:r>
+            <a:r>
+              <a:rPr lang="en-GB" dirty="0" err="1">
+                <a:latin typeface="Consolas"/>
+                <a:ea typeface="Consolas"/>
+                <a:cs typeface="Consolas"/>
+                <a:sym typeface="Consolas"/>
+              </a:rPr>
+              <a:t>onde</a:t>
+            </a:r>
+            <a:r>
+              <a:rPr lang="en-GB" dirty="0">
+                <a:latin typeface="Consolas"/>
+                <a:ea typeface="Consolas"/>
+                <a:cs typeface="Consolas"/>
+                <a:sym typeface="Consolas"/>
+              </a:rPr>
+              <a:t> o </a:t>
+            </a:r>
+            <a:r>
+              <a:rPr lang="en-GB" dirty="0" err="1">
+                <a:latin typeface="Consolas"/>
+                <a:ea typeface="Consolas"/>
+                <a:cs typeface="Consolas"/>
+                <a:sym typeface="Consolas"/>
+              </a:rPr>
+              <a:t>mapa</a:t>
+            </a:r>
+            <a:r>
+              <a:rPr lang="en-GB" dirty="0">
+                <a:latin typeface="Consolas"/>
+                <a:ea typeface="Consolas"/>
+                <a:cs typeface="Consolas"/>
+                <a:sym typeface="Consolas"/>
+              </a:rPr>
+              <a:t> </a:t>
+            </a:r>
+            <a:r>
+              <a:rPr lang="en-GB" dirty="0" err="1">
+                <a:latin typeface="Consolas"/>
+                <a:ea typeface="Consolas"/>
+                <a:cs typeface="Consolas"/>
+                <a:sym typeface="Consolas"/>
+              </a:rPr>
+              <a:t>muda</a:t>
+            </a:r>
+            <a:r>
+              <a:rPr lang="en-GB" dirty="0">
+                <a:latin typeface="Consolas"/>
+                <a:ea typeface="Consolas"/>
+                <a:cs typeface="Consolas"/>
+                <a:sym typeface="Consolas"/>
+              </a:rPr>
+              <a:t> </a:t>
+            </a:r>
+            <a:r>
+              <a:rPr lang="en-GB" dirty="0" err="1">
+                <a:latin typeface="Consolas"/>
+                <a:ea typeface="Consolas"/>
+                <a:cs typeface="Consolas"/>
+                <a:sym typeface="Consolas"/>
+              </a:rPr>
+              <a:t>semanalmente</a:t>
+            </a:r>
+            <a:r>
+              <a:rPr lang="en-GB" dirty="0">
+                <a:latin typeface="Consolas"/>
+                <a:ea typeface="Consolas"/>
+                <a:cs typeface="Consolas"/>
+                <a:sym typeface="Consolas"/>
+              </a:rPr>
+              <a:t> e </a:t>
+            </a:r>
+            <a:r>
+              <a:rPr lang="en-GB" dirty="0" err="1">
+                <a:latin typeface="Consolas"/>
+                <a:ea typeface="Consolas"/>
+                <a:cs typeface="Consolas"/>
+                <a:sym typeface="Consolas"/>
+              </a:rPr>
+              <a:t>possui</a:t>
+            </a:r>
+            <a:r>
+              <a:rPr lang="en-GB" dirty="0">
+                <a:latin typeface="Consolas"/>
+                <a:ea typeface="Consolas"/>
+                <a:cs typeface="Consolas"/>
+                <a:sym typeface="Consolas"/>
+              </a:rPr>
+              <a:t> um ranking </a:t>
+            </a:r>
+            <a:r>
+              <a:rPr lang="en-GB" dirty="0" err="1">
+                <a:latin typeface="Consolas"/>
+                <a:ea typeface="Consolas"/>
+                <a:cs typeface="Consolas"/>
+                <a:sym typeface="Consolas"/>
+              </a:rPr>
+              <a:t>baseado</a:t>
+            </a:r>
+            <a:r>
+              <a:rPr lang="en-GB" dirty="0">
+                <a:latin typeface="Consolas"/>
+                <a:ea typeface="Consolas"/>
+                <a:cs typeface="Consolas"/>
+                <a:sym typeface="Consolas"/>
+              </a:rPr>
+              <a:t> </a:t>
+            </a:r>
+            <a:r>
+              <a:rPr lang="en-GB" dirty="0" err="1">
+                <a:latin typeface="Consolas"/>
+                <a:ea typeface="Consolas"/>
+                <a:cs typeface="Consolas"/>
+                <a:sym typeface="Consolas"/>
+              </a:rPr>
+              <a:t>na</a:t>
+            </a:r>
+            <a:r>
+              <a:rPr lang="en-GB" dirty="0">
+                <a:latin typeface="Consolas"/>
+                <a:ea typeface="Consolas"/>
+                <a:cs typeface="Consolas"/>
+                <a:sym typeface="Consolas"/>
+              </a:rPr>
+              <a:t> performance.</a:t>
+            </a:r>
+            <a:endParaRPr dirty="0">
+              <a:latin typeface="Consolas"/>
+              <a:ea typeface="Consolas"/>
+              <a:cs typeface="Consolas"/>
+              <a:sym typeface="Consolas"/>
+            </a:endParaRPr>
+          </a:p>
+        </p:txBody>
+      </p:sp>
+      <p:sp>
+        <p:nvSpPr>
+          <p:cNvPr id="20" name="Google Shape;92;p15">
+            <a:extLst>
+              <a:ext uri="{FF2B5EF4-FFF2-40B4-BE49-F238E27FC236}">
+                <a16:creationId xmlns:a16="http://schemas.microsoft.com/office/drawing/2014/main" id="{039AC44D-89BA-A4D7-E2B9-854A90D3B1F4}"/>
+              </a:ext>
+            </a:extLst>
+          </p:cNvPr>
+          <p:cNvSpPr/>
+          <p:nvPr/>
+        </p:nvSpPr>
+        <p:spPr>
+          <a:xfrm>
+            <a:off x="6113258" y="3203475"/>
+            <a:ext cx="2609587" cy="7609683"/>
+          </a:xfrm>
+          <a:prstGeom prst="roundRect">
+            <a:avLst>
+              <a:gd name="adj" fmla="val 16667"/>
+            </a:avLst>
+          </a:prstGeom>
+          <a:solidFill>
+            <a:srgbClr val="D9EAD3"/>
+          </a:solidFill>
+          <a:ln w="28575" cap="flat" cmpd="sng">
+            <a:solidFill>
+              <a:srgbClr val="274E13"/>
+            </a:solidFill>
+            <a:prstDash val="solid"/>
+            <a:round/>
+            <a:headEnd type="none" w="sm" len="sm"/>
+            <a:tailEnd type="none" w="sm" len="sm"/>
+          </a:ln>
+        </p:spPr>
+        <p:txBody>
+          <a:bodyPr spcFirstLastPara="1" wrap="square" lIns="91425" tIns="91425" rIns="91425" bIns="91425" anchor="t" anchorCtr="0">
+            <a:noAutofit/>
+          </a:bodyPr>
+          <a:lstStyle/>
+          <a:p>
+            <a:pPr lvl="0"/>
+            <a:r>
+              <a:rPr lang="en-GB" dirty="0">
+                <a:latin typeface="Consolas"/>
+                <a:ea typeface="Consolas"/>
+                <a:cs typeface="Consolas"/>
+                <a:sym typeface="Consolas"/>
+              </a:rPr>
+              <a:t>US2: Como </a:t>
+            </a:r>
+            <a:r>
+              <a:rPr lang="en-GB" dirty="0" err="1">
+                <a:latin typeface="Consolas"/>
+                <a:ea typeface="Consolas"/>
+                <a:cs typeface="Consolas"/>
+                <a:sym typeface="Consolas"/>
+              </a:rPr>
+              <a:t>membro</a:t>
+            </a:r>
+            <a:r>
+              <a:rPr lang="en-GB" dirty="0">
+                <a:latin typeface="Consolas"/>
+                <a:ea typeface="Consolas"/>
+                <a:cs typeface="Consolas"/>
+                <a:sym typeface="Consolas"/>
+              </a:rPr>
+              <a:t> da </a:t>
+            </a:r>
+            <a:r>
+              <a:rPr lang="en-GB" dirty="0" err="1">
+                <a:latin typeface="Consolas"/>
+                <a:ea typeface="Consolas"/>
+                <a:cs typeface="Consolas"/>
+                <a:sym typeface="Consolas"/>
+              </a:rPr>
+              <a:t>equipa</a:t>
+            </a:r>
+            <a:r>
+              <a:rPr lang="en-GB" dirty="0">
+                <a:latin typeface="Consolas"/>
+                <a:ea typeface="Consolas"/>
+                <a:cs typeface="Consolas"/>
+                <a:sym typeface="Consolas"/>
+              </a:rPr>
+              <a:t> </a:t>
+            </a:r>
+            <a:r>
+              <a:rPr lang="en-GB" dirty="0" err="1">
+                <a:latin typeface="Consolas"/>
+                <a:ea typeface="Consolas"/>
+                <a:cs typeface="Consolas"/>
+                <a:sym typeface="Consolas"/>
+              </a:rPr>
+              <a:t>quero</a:t>
+            </a:r>
+            <a:r>
+              <a:rPr lang="pt-PT" dirty="0">
+                <a:latin typeface="Consolas"/>
+                <a:ea typeface="Consolas"/>
+                <a:cs typeface="Consolas"/>
+                <a:sym typeface="Consolas"/>
+              </a:rPr>
+              <a:t> implementar a </a:t>
+            </a:r>
+            <a:r>
+              <a:rPr lang="pt-PT" dirty="0" err="1">
+                <a:latin typeface="Consolas"/>
+                <a:ea typeface="Consolas"/>
+                <a:cs typeface="Consolas"/>
+                <a:sym typeface="Consolas"/>
+              </a:rPr>
+              <a:t>Health</a:t>
+            </a:r>
+            <a:r>
+              <a:rPr lang="pt-PT" dirty="0">
+                <a:latin typeface="Consolas"/>
+                <a:ea typeface="Consolas"/>
+                <a:cs typeface="Consolas"/>
+                <a:sym typeface="Consolas"/>
+              </a:rPr>
+              <a:t> Bar de cada </a:t>
+            </a:r>
+            <a:r>
+              <a:rPr lang="pt-PT" dirty="0" err="1">
+                <a:latin typeface="Consolas"/>
+                <a:ea typeface="Consolas"/>
+                <a:cs typeface="Consolas"/>
+                <a:sym typeface="Consolas"/>
+              </a:rPr>
+              <a:t>wave</a:t>
+            </a:r>
+            <a:r>
+              <a:rPr lang="pt-PT" dirty="0">
+                <a:latin typeface="Consolas"/>
+                <a:ea typeface="Consolas"/>
+                <a:cs typeface="Consolas"/>
+                <a:sym typeface="Consolas"/>
+              </a:rPr>
+              <a:t> de inimigos.</a:t>
+            </a:r>
+            <a:endParaRPr dirty="0">
+              <a:latin typeface="Consolas"/>
+              <a:ea typeface="Consolas"/>
+              <a:cs typeface="Consolas"/>
+              <a:sym typeface="Consolas"/>
+            </a:endParaRPr>
+          </a:p>
+        </p:txBody>
+      </p:sp>
+      <p:sp>
+        <p:nvSpPr>
+          <p:cNvPr id="21" name="Google Shape;92;p15">
+            <a:extLst>
+              <a:ext uri="{FF2B5EF4-FFF2-40B4-BE49-F238E27FC236}">
+                <a16:creationId xmlns:a16="http://schemas.microsoft.com/office/drawing/2014/main" id="{38E0B706-5871-FBBB-1A01-B68FF5359838}"/>
+              </a:ext>
+            </a:extLst>
+          </p:cNvPr>
+          <p:cNvSpPr/>
+          <p:nvPr/>
+        </p:nvSpPr>
+        <p:spPr>
+          <a:xfrm>
+            <a:off x="6136546" y="4644094"/>
+            <a:ext cx="2609586" cy="6208084"/>
+          </a:xfrm>
+          <a:prstGeom prst="roundRect">
+            <a:avLst>
+              <a:gd name="adj" fmla="val 16667"/>
+            </a:avLst>
+          </a:prstGeom>
+          <a:solidFill>
+            <a:srgbClr val="D9EAD3"/>
+          </a:solidFill>
+          <a:ln w="28575" cap="flat" cmpd="sng">
+            <a:solidFill>
+              <a:srgbClr val="274E13"/>
+            </a:solidFill>
+            <a:prstDash val="solid"/>
+            <a:round/>
+            <a:headEnd type="none" w="sm" len="sm"/>
+            <a:tailEnd type="none" w="sm" len="sm"/>
+          </a:ln>
+        </p:spPr>
+        <p:txBody>
+          <a:bodyPr spcFirstLastPara="1" wrap="square" lIns="91425" tIns="91425" rIns="91425" bIns="91425" anchor="t" anchorCtr="0">
+            <a:noAutofit/>
+          </a:bodyPr>
+          <a:lstStyle/>
+          <a:p>
+            <a:pPr lvl="0"/>
+            <a:r>
+              <a:rPr lang="en-GB" dirty="0">
+                <a:latin typeface="Consolas"/>
+                <a:ea typeface="Consolas"/>
+                <a:cs typeface="Consolas"/>
+                <a:sym typeface="Consolas"/>
+              </a:rPr>
+              <a:t>US3: Como </a:t>
+            </a:r>
+            <a:r>
+              <a:rPr lang="en-GB" dirty="0" err="1">
+                <a:latin typeface="Consolas"/>
+                <a:ea typeface="Consolas"/>
+                <a:cs typeface="Consolas"/>
+                <a:sym typeface="Consolas"/>
+              </a:rPr>
+              <a:t>membro</a:t>
+            </a:r>
+            <a:r>
+              <a:rPr lang="en-GB" dirty="0">
+                <a:latin typeface="Consolas"/>
+                <a:ea typeface="Consolas"/>
+                <a:cs typeface="Consolas"/>
+                <a:sym typeface="Consolas"/>
+              </a:rPr>
+              <a:t> da </a:t>
+            </a:r>
+            <a:r>
+              <a:rPr lang="en-GB" dirty="0" err="1">
+                <a:latin typeface="Consolas"/>
+                <a:ea typeface="Consolas"/>
+                <a:cs typeface="Consolas"/>
+                <a:sym typeface="Consolas"/>
+              </a:rPr>
+              <a:t>equipa</a:t>
+            </a:r>
+            <a:r>
+              <a:rPr lang="en-GB" dirty="0">
+                <a:latin typeface="Consolas"/>
+                <a:ea typeface="Consolas"/>
+                <a:cs typeface="Consolas"/>
+                <a:sym typeface="Consolas"/>
+              </a:rPr>
+              <a:t> </a:t>
+            </a:r>
+            <a:r>
+              <a:rPr lang="en-GB" dirty="0" err="1">
+                <a:latin typeface="Consolas"/>
+                <a:ea typeface="Consolas"/>
+                <a:cs typeface="Consolas"/>
+                <a:sym typeface="Consolas"/>
+              </a:rPr>
+              <a:t>quero</a:t>
+            </a:r>
+            <a:r>
+              <a:rPr lang="pt-PT" dirty="0">
+                <a:latin typeface="Consolas"/>
+                <a:ea typeface="Consolas"/>
+                <a:cs typeface="Consolas"/>
+                <a:sym typeface="Consolas"/>
+              </a:rPr>
+              <a:t> implementar as diferentes condições climatéricas.</a:t>
+            </a:r>
+          </a:p>
+        </p:txBody>
+      </p:sp>
+      <p:sp>
+        <p:nvSpPr>
+          <p:cNvPr id="8" name="Google Shape;121;p16">
+            <a:extLst>
+              <a:ext uri="{FF2B5EF4-FFF2-40B4-BE49-F238E27FC236}">
+                <a16:creationId xmlns:a16="http://schemas.microsoft.com/office/drawing/2014/main" id="{6D7B61FE-FF7D-243C-505F-53C496B5D7E5}"/>
+              </a:ext>
+            </a:extLst>
+          </p:cNvPr>
+          <p:cNvSpPr/>
+          <p:nvPr/>
+        </p:nvSpPr>
+        <p:spPr>
+          <a:xfrm>
+            <a:off x="18725151" y="1021952"/>
+            <a:ext cx="2410800" cy="2657243"/>
+          </a:xfrm>
+          <a:prstGeom prst="roundRect">
+            <a:avLst>
+              <a:gd name="adj" fmla="val 16667"/>
+            </a:avLst>
+          </a:prstGeom>
+          <a:solidFill>
+            <a:srgbClr val="D0E0E3"/>
+          </a:solidFill>
+          <a:ln w="28575" cap="flat" cmpd="sng">
+            <a:solidFill>
+              <a:srgbClr val="134F5C"/>
+            </a:solidFill>
+            <a:prstDash val="solid"/>
+            <a:round/>
+            <a:headEnd type="none" w="sm" len="sm"/>
+            <a:tailEnd type="none" w="sm" len="sm"/>
+          </a:ln>
+        </p:spPr>
+        <p:txBody>
+          <a:bodyPr spcFirstLastPara="1" wrap="square" lIns="91425" tIns="91425" rIns="91425" bIns="91425" anchor="t" anchorCtr="0">
+            <a:noAutofit/>
+          </a:bodyPr>
+          <a:lstStyle/>
+          <a:p>
+            <a:r>
+              <a:rPr lang="en-GB" dirty="0">
+                <a:latin typeface="Consolas"/>
+                <a:ea typeface="Consolas"/>
+                <a:cs typeface="Consolas"/>
+                <a:sym typeface="Consolas"/>
+              </a:rPr>
+              <a:t>T1: </a:t>
+            </a:r>
+            <a:r>
+              <a:rPr lang="pt-PT" dirty="0">
+                <a:latin typeface="Consolas"/>
+                <a:ea typeface="Consolas"/>
+                <a:cs typeface="Consolas"/>
+                <a:sym typeface="Consolas"/>
+              </a:rPr>
+              <a:t>Fazer Interface de Rankings e “jogar Desafio Semanal”</a:t>
+            </a:r>
+            <a:br>
+              <a:rPr lang="en-GB" dirty="0">
+                <a:latin typeface="Consolas"/>
+                <a:ea typeface="Consolas"/>
+                <a:cs typeface="Consolas"/>
+                <a:sym typeface="Consolas"/>
+              </a:rPr>
+            </a:br>
+            <a:br>
+              <a:rPr lang="en-GB" dirty="0">
+                <a:latin typeface="Consolas"/>
+                <a:ea typeface="Consolas"/>
+                <a:cs typeface="Consolas"/>
+                <a:sym typeface="Consolas"/>
+              </a:rPr>
+            </a:br>
+            <a:endParaRPr lang="en-GB" dirty="0">
+              <a:latin typeface="Consolas"/>
+              <a:ea typeface="Consolas"/>
+              <a:cs typeface="Consolas"/>
+              <a:sym typeface="Consolas"/>
+            </a:endParaRPr>
+          </a:p>
+          <a:p>
+            <a:pPr marL="0" lvl="0" indent="0" algn="l" rtl="0">
+              <a:spcBef>
+                <a:spcPts val="0"/>
+              </a:spcBef>
+              <a:spcAft>
+                <a:spcPts val="0"/>
+              </a:spcAft>
+              <a:buNone/>
+            </a:pPr>
+            <a:endParaRPr dirty="0">
+              <a:latin typeface="Consolas"/>
+              <a:ea typeface="Consolas"/>
+              <a:cs typeface="Consolas"/>
+              <a:sym typeface="Consolas"/>
+            </a:endParaRPr>
+          </a:p>
+        </p:txBody>
+      </p:sp>
+      <p:sp>
+        <p:nvSpPr>
+          <p:cNvPr id="10" name="Google Shape;121;p16">
+            <a:extLst>
+              <a:ext uri="{FF2B5EF4-FFF2-40B4-BE49-F238E27FC236}">
+                <a16:creationId xmlns:a16="http://schemas.microsoft.com/office/drawing/2014/main" id="{708FE690-0101-BE6B-CCF2-D391717C05CA}"/>
+              </a:ext>
+            </a:extLst>
+          </p:cNvPr>
+          <p:cNvSpPr/>
+          <p:nvPr/>
+        </p:nvSpPr>
+        <p:spPr>
+          <a:xfrm>
+            <a:off x="12395940" y="4165308"/>
+            <a:ext cx="2410800" cy="749592"/>
+          </a:xfrm>
+          <a:prstGeom prst="roundRect">
+            <a:avLst>
+              <a:gd name="adj" fmla="val 16667"/>
+            </a:avLst>
+          </a:prstGeom>
+          <a:solidFill>
+            <a:srgbClr val="D0E0E3"/>
+          </a:solidFill>
+          <a:ln w="28575" cap="flat" cmpd="sng">
+            <a:solidFill>
+              <a:srgbClr val="134F5C"/>
+            </a:solidFill>
+            <a:prstDash val="solid"/>
+            <a:round/>
+            <a:headEnd type="none" w="sm" len="sm"/>
+            <a:tailEnd type="none" w="sm" len="sm"/>
+          </a:ln>
+        </p:spPr>
+        <p:txBody>
+          <a:bodyPr spcFirstLastPara="1" wrap="square" lIns="91425" tIns="91425" rIns="91425" bIns="91425" anchor="t" anchorCtr="0">
+            <a:noAutofit/>
+          </a:bodyPr>
+          <a:lstStyle/>
+          <a:p>
+            <a:r>
+              <a:rPr lang="pt-PT" dirty="0">
+                <a:latin typeface="Consolas"/>
+                <a:ea typeface="Consolas"/>
+                <a:cs typeface="Consolas"/>
+                <a:sym typeface="Consolas"/>
+              </a:rPr>
+              <a:t>T3: Implementar a parte do Terramoto.</a:t>
+            </a:r>
+          </a:p>
+          <a:p>
+            <a:r>
+              <a:rPr lang="en-GB" dirty="0">
+                <a:latin typeface="Consolas"/>
+                <a:ea typeface="Consolas"/>
+                <a:cs typeface="Consolas"/>
+                <a:sym typeface="Consolas"/>
+              </a:rPr>
+              <a:t> </a:t>
+            </a:r>
+            <a:br>
+              <a:rPr lang="en-GB" dirty="0">
+                <a:latin typeface="Consolas"/>
+                <a:ea typeface="Consolas"/>
+                <a:cs typeface="Consolas"/>
+                <a:sym typeface="Consolas"/>
+              </a:rPr>
+            </a:br>
+            <a:br>
+              <a:rPr lang="en-GB" dirty="0">
+                <a:latin typeface="Consolas"/>
+                <a:ea typeface="Consolas"/>
+                <a:cs typeface="Consolas"/>
+                <a:sym typeface="Consolas"/>
+              </a:rPr>
+            </a:br>
+            <a:endParaRPr lang="en-GB" dirty="0">
+              <a:latin typeface="Consolas"/>
+              <a:ea typeface="Consolas"/>
+              <a:cs typeface="Consolas"/>
+              <a:sym typeface="Consolas"/>
+            </a:endParaRPr>
+          </a:p>
+          <a:p>
+            <a:pPr marL="0" lvl="0" indent="0" algn="l" rtl="0">
+              <a:spcBef>
+                <a:spcPts val="0"/>
+              </a:spcBef>
+              <a:spcAft>
+                <a:spcPts val="0"/>
+              </a:spcAft>
+              <a:buNone/>
+            </a:pPr>
+            <a:endParaRPr dirty="0">
+              <a:latin typeface="Consolas"/>
+              <a:ea typeface="Consolas"/>
+              <a:cs typeface="Consolas"/>
+              <a:sym typeface="Consolas"/>
+            </a:endParaRPr>
+          </a:p>
+        </p:txBody>
+      </p:sp>
+      <p:sp>
+        <p:nvSpPr>
+          <p:cNvPr id="11" name="Google Shape;121;p16">
+            <a:extLst>
+              <a:ext uri="{FF2B5EF4-FFF2-40B4-BE49-F238E27FC236}">
+                <a16:creationId xmlns:a16="http://schemas.microsoft.com/office/drawing/2014/main" id="{FB81A080-CF90-FB94-50B9-82E6886A5A59}"/>
+              </a:ext>
+            </a:extLst>
+          </p:cNvPr>
+          <p:cNvSpPr/>
+          <p:nvPr/>
+        </p:nvSpPr>
+        <p:spPr>
+          <a:xfrm>
+            <a:off x="12395940" y="4784311"/>
+            <a:ext cx="2410800" cy="749592"/>
+          </a:xfrm>
+          <a:prstGeom prst="roundRect">
+            <a:avLst>
+              <a:gd name="adj" fmla="val 16667"/>
+            </a:avLst>
+          </a:prstGeom>
+          <a:solidFill>
+            <a:srgbClr val="D0E0E3"/>
+          </a:solidFill>
+          <a:ln w="28575" cap="flat" cmpd="sng">
+            <a:solidFill>
+              <a:srgbClr val="134F5C"/>
+            </a:solidFill>
+            <a:prstDash val="solid"/>
+            <a:round/>
+            <a:headEnd type="none" w="sm" len="sm"/>
+            <a:tailEnd type="none" w="sm" len="sm"/>
+          </a:ln>
+        </p:spPr>
+        <p:txBody>
+          <a:bodyPr spcFirstLastPara="1" wrap="square" lIns="91425" tIns="91425" rIns="91425" bIns="91425" anchor="t" anchorCtr="0">
+            <a:noAutofit/>
+          </a:bodyPr>
+          <a:lstStyle/>
+          <a:p>
+            <a:r>
+              <a:rPr lang="pt-PT" dirty="0">
+                <a:latin typeface="Consolas"/>
+                <a:ea typeface="Consolas"/>
+                <a:cs typeface="Consolas"/>
+                <a:sym typeface="Consolas"/>
+              </a:rPr>
+              <a:t>T3: Implementar a parte do Tsunami.</a:t>
+            </a:r>
+          </a:p>
+          <a:p>
+            <a:r>
+              <a:rPr lang="en-GB" dirty="0">
+                <a:latin typeface="Consolas"/>
+                <a:ea typeface="Consolas"/>
+                <a:cs typeface="Consolas"/>
+                <a:sym typeface="Consolas"/>
+              </a:rPr>
+              <a:t> </a:t>
+            </a:r>
+            <a:br>
+              <a:rPr lang="en-GB" dirty="0">
+                <a:latin typeface="Consolas"/>
+                <a:ea typeface="Consolas"/>
+                <a:cs typeface="Consolas"/>
+                <a:sym typeface="Consolas"/>
+              </a:rPr>
+            </a:br>
+            <a:br>
+              <a:rPr lang="en-GB" dirty="0">
+                <a:latin typeface="Consolas"/>
+                <a:ea typeface="Consolas"/>
+                <a:cs typeface="Consolas"/>
+                <a:sym typeface="Consolas"/>
+              </a:rPr>
+            </a:br>
+            <a:endParaRPr lang="en-GB" dirty="0">
+              <a:latin typeface="Consolas"/>
+              <a:ea typeface="Consolas"/>
+              <a:cs typeface="Consolas"/>
+              <a:sym typeface="Consolas"/>
+            </a:endParaRPr>
+          </a:p>
+          <a:p>
+            <a:pPr marL="0" lvl="0" indent="0" algn="l" rtl="0">
+              <a:spcBef>
+                <a:spcPts val="0"/>
+              </a:spcBef>
+              <a:spcAft>
+                <a:spcPts val="0"/>
+              </a:spcAft>
+              <a:buNone/>
+            </a:pPr>
+            <a:endParaRPr dirty="0">
+              <a:latin typeface="Consolas"/>
+              <a:ea typeface="Consolas"/>
+              <a:cs typeface="Consolas"/>
+              <a:sym typeface="Consolas"/>
+            </a:endParaRPr>
+          </a:p>
+        </p:txBody>
+      </p:sp>
+      <p:sp>
+        <p:nvSpPr>
+          <p:cNvPr id="22" name="Google Shape;121;p16">
+            <a:extLst>
+              <a:ext uri="{FF2B5EF4-FFF2-40B4-BE49-F238E27FC236}">
+                <a16:creationId xmlns:a16="http://schemas.microsoft.com/office/drawing/2014/main" id="{F8620EEB-DBF2-7CC7-E189-D55301A96F58}"/>
+              </a:ext>
+            </a:extLst>
+          </p:cNvPr>
+          <p:cNvSpPr/>
+          <p:nvPr/>
+        </p:nvSpPr>
+        <p:spPr>
+          <a:xfrm>
+            <a:off x="12423686" y="7368613"/>
+            <a:ext cx="2410800" cy="1215821"/>
+          </a:xfrm>
+          <a:prstGeom prst="roundRect">
+            <a:avLst>
+              <a:gd name="adj" fmla="val 16667"/>
+            </a:avLst>
+          </a:prstGeom>
+          <a:solidFill>
+            <a:srgbClr val="D0E0E3"/>
+          </a:solidFill>
+          <a:ln w="28575" cap="flat" cmpd="sng">
+            <a:solidFill>
+              <a:srgbClr val="134F5C"/>
+            </a:solidFill>
+            <a:prstDash val="solid"/>
+            <a:round/>
+            <a:headEnd type="none" w="sm" len="sm"/>
+            <a:tailEnd type="none" w="sm" len="sm"/>
+          </a:ln>
+        </p:spPr>
+        <p:txBody>
+          <a:bodyPr spcFirstLastPara="1" wrap="square" lIns="91425" tIns="91425" rIns="91425" bIns="91425" anchor="t" anchorCtr="0">
+            <a:noAutofit/>
+          </a:bodyPr>
+          <a:lstStyle/>
+          <a:p>
+            <a:r>
+              <a:rPr lang="pt-PT" dirty="0">
+                <a:latin typeface="Consolas"/>
+                <a:ea typeface="Consolas"/>
+                <a:cs typeface="Consolas"/>
+                <a:sym typeface="Consolas"/>
+              </a:rPr>
+              <a:t>T3: Implementar a parte do Meteorito. </a:t>
+            </a:r>
+          </a:p>
+          <a:p>
+            <a:r>
+              <a:rPr lang="en-GB" dirty="0">
+                <a:latin typeface="Consolas"/>
+                <a:ea typeface="Consolas"/>
+                <a:cs typeface="Consolas"/>
+                <a:sym typeface="Consolas"/>
+              </a:rPr>
+              <a:t> </a:t>
+            </a:r>
+            <a:br>
+              <a:rPr lang="en-GB" dirty="0">
+                <a:latin typeface="Consolas"/>
+                <a:ea typeface="Consolas"/>
+                <a:cs typeface="Consolas"/>
+                <a:sym typeface="Consolas"/>
+              </a:rPr>
+            </a:br>
+            <a:br>
+              <a:rPr lang="en-GB" dirty="0">
+                <a:latin typeface="Consolas"/>
+                <a:ea typeface="Consolas"/>
+                <a:cs typeface="Consolas"/>
+                <a:sym typeface="Consolas"/>
+              </a:rPr>
+            </a:br>
+            <a:endParaRPr lang="en-GB" dirty="0">
+              <a:latin typeface="Consolas"/>
+              <a:ea typeface="Consolas"/>
+              <a:cs typeface="Consolas"/>
+              <a:sym typeface="Consolas"/>
+            </a:endParaRPr>
+          </a:p>
+          <a:p>
+            <a:pPr marL="0" lvl="0" indent="0" algn="l" rtl="0">
+              <a:spcBef>
+                <a:spcPts val="0"/>
+              </a:spcBef>
+              <a:spcAft>
+                <a:spcPts val="0"/>
+              </a:spcAft>
+              <a:buNone/>
+            </a:pPr>
+            <a:endParaRPr lang="en-GB" dirty="0">
+              <a:latin typeface="Consolas"/>
+              <a:ea typeface="Consolas"/>
+              <a:cs typeface="Consolas"/>
+              <a:sym typeface="Consolas"/>
+            </a:endParaRPr>
+          </a:p>
+        </p:txBody>
+      </p:sp>
+      <p:sp>
+        <p:nvSpPr>
+          <p:cNvPr id="24" name="Google Shape;121;p16">
+            <a:extLst>
+              <a:ext uri="{FF2B5EF4-FFF2-40B4-BE49-F238E27FC236}">
+                <a16:creationId xmlns:a16="http://schemas.microsoft.com/office/drawing/2014/main" id="{DFA277F6-FAC1-F983-E958-3655E8AF52C5}"/>
+              </a:ext>
+            </a:extLst>
+          </p:cNvPr>
+          <p:cNvSpPr/>
+          <p:nvPr/>
+        </p:nvSpPr>
+        <p:spPr>
+          <a:xfrm>
+            <a:off x="12395940" y="932272"/>
+            <a:ext cx="2410800" cy="2657243"/>
+          </a:xfrm>
+          <a:prstGeom prst="roundRect">
+            <a:avLst>
+              <a:gd name="adj" fmla="val 16667"/>
+            </a:avLst>
+          </a:prstGeom>
+          <a:solidFill>
+            <a:srgbClr val="D0E0E3"/>
+          </a:solidFill>
+          <a:ln w="28575" cap="flat" cmpd="sng">
+            <a:solidFill>
+              <a:srgbClr val="134F5C"/>
+            </a:solidFill>
+            <a:prstDash val="solid"/>
+            <a:round/>
+            <a:headEnd type="none" w="sm" len="sm"/>
+            <a:tailEnd type="none" w="sm" len="sm"/>
+          </a:ln>
+        </p:spPr>
+        <p:txBody>
+          <a:bodyPr spcFirstLastPara="1" wrap="square" lIns="91425" tIns="91425" rIns="91425" bIns="91425" anchor="t" anchorCtr="0">
+            <a:noAutofit/>
+          </a:bodyPr>
+          <a:lstStyle/>
+          <a:p>
+            <a:r>
+              <a:rPr lang="en-GB" dirty="0">
+                <a:latin typeface="Consolas"/>
+                <a:ea typeface="Consolas"/>
+                <a:cs typeface="Consolas"/>
+                <a:sym typeface="Consolas"/>
+              </a:rPr>
+              <a:t>T1: </a:t>
+            </a:r>
+            <a:r>
+              <a:rPr lang="pt-PT" dirty="0">
+                <a:latin typeface="Consolas"/>
+                <a:ea typeface="Consolas"/>
+                <a:cs typeface="Consolas"/>
+                <a:sym typeface="Consolas"/>
+              </a:rPr>
+              <a:t>Implementar um gerador de mapa semanal.</a:t>
+            </a:r>
+            <a:br>
+              <a:rPr lang="en-GB" dirty="0">
+                <a:latin typeface="Consolas"/>
+                <a:ea typeface="Consolas"/>
+                <a:cs typeface="Consolas"/>
+                <a:sym typeface="Consolas"/>
+              </a:rPr>
+            </a:br>
+            <a:br>
+              <a:rPr lang="en-GB" dirty="0">
+                <a:latin typeface="Consolas"/>
+                <a:ea typeface="Consolas"/>
+                <a:cs typeface="Consolas"/>
+                <a:sym typeface="Consolas"/>
+              </a:rPr>
+            </a:br>
+            <a:endParaRPr lang="en-GB" dirty="0">
+              <a:latin typeface="Consolas"/>
+              <a:ea typeface="Consolas"/>
+              <a:cs typeface="Consolas"/>
+              <a:sym typeface="Consolas"/>
+            </a:endParaRPr>
+          </a:p>
+          <a:p>
+            <a:pPr marL="0" lvl="0" indent="0" algn="l" rtl="0">
+              <a:spcBef>
+                <a:spcPts val="0"/>
+              </a:spcBef>
+              <a:spcAft>
+                <a:spcPts val="0"/>
+              </a:spcAft>
+              <a:buNone/>
+            </a:pPr>
+            <a:endParaRPr dirty="0">
+              <a:latin typeface="Consolas"/>
+              <a:ea typeface="Consolas"/>
+              <a:cs typeface="Consolas"/>
+              <a:sym typeface="Consolas"/>
+            </a:endParaRPr>
+          </a:p>
+        </p:txBody>
+      </p:sp>
+      <p:sp>
+        <p:nvSpPr>
+          <p:cNvPr id="23" name="Google Shape;121;p16">
+            <a:extLst>
+              <a:ext uri="{FF2B5EF4-FFF2-40B4-BE49-F238E27FC236}">
+                <a16:creationId xmlns:a16="http://schemas.microsoft.com/office/drawing/2014/main" id="{87533D02-062A-4DEB-31C2-2FCBBD1A55C5}"/>
+              </a:ext>
+            </a:extLst>
+          </p:cNvPr>
+          <p:cNvSpPr/>
+          <p:nvPr/>
+        </p:nvSpPr>
+        <p:spPr>
+          <a:xfrm>
+            <a:off x="15532407" y="5825394"/>
+            <a:ext cx="2410800" cy="1215821"/>
+          </a:xfrm>
+          <a:prstGeom prst="roundRect">
+            <a:avLst>
+              <a:gd name="adj" fmla="val 16667"/>
+            </a:avLst>
+          </a:prstGeom>
+          <a:solidFill>
+            <a:srgbClr val="D0E0E3"/>
+          </a:solidFill>
+          <a:ln w="28575" cap="flat" cmpd="sng">
+            <a:solidFill>
+              <a:srgbClr val="134F5C"/>
+            </a:solidFill>
+            <a:prstDash val="solid"/>
+            <a:round/>
+            <a:headEnd type="none" w="sm" len="sm"/>
+            <a:tailEnd type="none" w="sm" len="sm"/>
+          </a:ln>
+        </p:spPr>
+        <p:txBody>
+          <a:bodyPr spcFirstLastPara="1" wrap="square" lIns="91425" tIns="91425" rIns="91425" bIns="91425" anchor="t" anchorCtr="0">
+            <a:noAutofit/>
+          </a:bodyPr>
+          <a:lstStyle/>
+          <a:p>
+            <a:r>
+              <a:rPr lang="pt-PT" dirty="0">
+                <a:latin typeface="Consolas"/>
+                <a:ea typeface="Consolas"/>
+                <a:cs typeface="Consolas"/>
+                <a:sym typeface="Consolas"/>
+              </a:rPr>
+              <a:t>T2: Implementar a </a:t>
+            </a:r>
+            <a:r>
+              <a:rPr lang="pt-PT" dirty="0" err="1">
+                <a:latin typeface="Consolas"/>
+                <a:ea typeface="Consolas"/>
+                <a:cs typeface="Consolas"/>
+                <a:sym typeface="Consolas"/>
+              </a:rPr>
+              <a:t>Health</a:t>
+            </a:r>
+            <a:r>
+              <a:rPr lang="pt-PT" dirty="0">
+                <a:latin typeface="Consolas"/>
+                <a:ea typeface="Consolas"/>
+                <a:cs typeface="Consolas"/>
+                <a:sym typeface="Consolas"/>
+              </a:rPr>
+              <a:t> Bar de cada </a:t>
+            </a:r>
+            <a:r>
+              <a:rPr lang="pt-PT" dirty="0" err="1">
+                <a:latin typeface="Consolas"/>
+                <a:ea typeface="Consolas"/>
+                <a:cs typeface="Consolas"/>
+                <a:sym typeface="Consolas"/>
+              </a:rPr>
+              <a:t>wave</a:t>
+            </a:r>
+            <a:r>
+              <a:rPr lang="pt-PT" dirty="0">
+                <a:latin typeface="Consolas"/>
+                <a:ea typeface="Consolas"/>
+                <a:cs typeface="Consolas"/>
+                <a:sym typeface="Consolas"/>
+              </a:rPr>
+              <a:t> de inimigos.</a:t>
+            </a:r>
+          </a:p>
+          <a:p>
+            <a:r>
+              <a:rPr lang="en-GB" dirty="0">
+                <a:latin typeface="Consolas"/>
+                <a:ea typeface="Consolas"/>
+                <a:cs typeface="Consolas"/>
+                <a:sym typeface="Consolas"/>
+              </a:rPr>
+              <a:t> </a:t>
+            </a:r>
+            <a:br>
+              <a:rPr lang="en-GB" dirty="0">
+                <a:latin typeface="Consolas"/>
+                <a:ea typeface="Consolas"/>
+                <a:cs typeface="Consolas"/>
+                <a:sym typeface="Consolas"/>
+              </a:rPr>
+            </a:br>
+            <a:br>
+              <a:rPr lang="en-GB" dirty="0">
+                <a:latin typeface="Consolas"/>
+                <a:ea typeface="Consolas"/>
+                <a:cs typeface="Consolas"/>
+                <a:sym typeface="Consolas"/>
+              </a:rPr>
+            </a:br>
+            <a:endParaRPr lang="en-GB" dirty="0">
+              <a:latin typeface="Consolas"/>
+              <a:ea typeface="Consolas"/>
+              <a:cs typeface="Consolas"/>
+              <a:sym typeface="Consolas"/>
+            </a:endParaRPr>
+          </a:p>
+          <a:p>
+            <a:pPr marL="0" lvl="0" indent="0" algn="l" rtl="0">
+              <a:spcBef>
+                <a:spcPts val="0"/>
+              </a:spcBef>
+              <a:spcAft>
+                <a:spcPts val="0"/>
+              </a:spcAft>
+              <a:buNone/>
+            </a:pPr>
+            <a:endParaRPr dirty="0">
+              <a:latin typeface="Consolas"/>
+              <a:ea typeface="Consolas"/>
+              <a:cs typeface="Consolas"/>
+              <a:sym typeface="Consolas"/>
+            </a:endParaRPr>
+          </a:p>
+        </p:txBody>
+      </p:sp>
+      <p:sp>
+        <p:nvSpPr>
+          <p:cNvPr id="25" name="Google Shape;121;p16">
+            <a:extLst>
+              <a:ext uri="{FF2B5EF4-FFF2-40B4-BE49-F238E27FC236}">
+                <a16:creationId xmlns:a16="http://schemas.microsoft.com/office/drawing/2014/main" id="{B34C950C-E7E1-AD55-EA22-8FC5D1D0E711}"/>
+              </a:ext>
+            </a:extLst>
+          </p:cNvPr>
+          <p:cNvSpPr/>
+          <p:nvPr/>
+        </p:nvSpPr>
+        <p:spPr>
+          <a:xfrm>
+            <a:off x="15532407" y="8942591"/>
+            <a:ext cx="2410800" cy="1215821"/>
+          </a:xfrm>
+          <a:prstGeom prst="roundRect">
+            <a:avLst>
+              <a:gd name="adj" fmla="val 16667"/>
+            </a:avLst>
+          </a:prstGeom>
+          <a:solidFill>
+            <a:srgbClr val="D0E0E3"/>
+          </a:solidFill>
+          <a:ln w="28575" cap="flat" cmpd="sng">
+            <a:solidFill>
+              <a:srgbClr val="134F5C"/>
+            </a:solidFill>
+            <a:prstDash val="solid"/>
+            <a:round/>
+            <a:headEnd type="none" w="sm" len="sm"/>
+            <a:tailEnd type="none" w="sm" len="sm"/>
+          </a:ln>
+        </p:spPr>
+        <p:txBody>
+          <a:bodyPr spcFirstLastPara="1" wrap="square" lIns="91425" tIns="91425" rIns="91425" bIns="91425" anchor="t" anchorCtr="0">
+            <a:noAutofit/>
+          </a:bodyPr>
+          <a:lstStyle/>
+          <a:p>
+            <a:r>
+              <a:rPr lang="pt-PT" dirty="0">
+                <a:latin typeface="Consolas"/>
+                <a:ea typeface="Consolas"/>
+                <a:cs typeface="Consolas"/>
+                <a:sym typeface="Consolas"/>
+              </a:rPr>
+              <a:t>T2: Implementar a </a:t>
+            </a:r>
+            <a:r>
+              <a:rPr lang="pt-PT" dirty="0" err="1">
+                <a:latin typeface="Consolas"/>
+                <a:ea typeface="Consolas"/>
+                <a:cs typeface="Consolas"/>
+                <a:sym typeface="Consolas"/>
+              </a:rPr>
+              <a:t>Health</a:t>
+            </a:r>
+            <a:r>
+              <a:rPr lang="pt-PT" dirty="0">
+                <a:latin typeface="Consolas"/>
+                <a:ea typeface="Consolas"/>
+                <a:cs typeface="Consolas"/>
+                <a:sym typeface="Consolas"/>
+              </a:rPr>
+              <a:t> Bar de cada </a:t>
+            </a:r>
+            <a:r>
+              <a:rPr lang="pt-PT" dirty="0" err="1">
+                <a:latin typeface="Consolas"/>
+                <a:ea typeface="Consolas"/>
+                <a:cs typeface="Consolas"/>
+                <a:sym typeface="Consolas"/>
+              </a:rPr>
+              <a:t>wave</a:t>
+            </a:r>
+            <a:r>
+              <a:rPr lang="pt-PT" dirty="0">
+                <a:latin typeface="Consolas"/>
+                <a:ea typeface="Consolas"/>
+                <a:cs typeface="Consolas"/>
+                <a:sym typeface="Consolas"/>
+              </a:rPr>
+              <a:t> de inimigos.</a:t>
+            </a:r>
+          </a:p>
+          <a:p>
+            <a:r>
+              <a:rPr lang="en-GB" dirty="0">
+                <a:latin typeface="Consolas"/>
+                <a:ea typeface="Consolas"/>
+                <a:cs typeface="Consolas"/>
+                <a:sym typeface="Consolas"/>
+              </a:rPr>
+              <a:t> </a:t>
+            </a:r>
+            <a:br>
+              <a:rPr lang="en-GB" dirty="0">
+                <a:latin typeface="Consolas"/>
+                <a:ea typeface="Consolas"/>
+                <a:cs typeface="Consolas"/>
+                <a:sym typeface="Consolas"/>
+              </a:rPr>
+            </a:br>
+            <a:br>
+              <a:rPr lang="en-GB" dirty="0">
+                <a:latin typeface="Consolas"/>
+                <a:ea typeface="Consolas"/>
+                <a:cs typeface="Consolas"/>
+                <a:sym typeface="Consolas"/>
+              </a:rPr>
+            </a:br>
+            <a:endParaRPr lang="en-GB" dirty="0">
+              <a:latin typeface="Consolas"/>
+              <a:ea typeface="Consolas"/>
+              <a:cs typeface="Consolas"/>
+              <a:sym typeface="Consolas"/>
+            </a:endParaRPr>
+          </a:p>
+          <a:p>
+            <a:pPr marL="0" lvl="0" indent="0" algn="l" rtl="0">
+              <a:spcBef>
+                <a:spcPts val="0"/>
+              </a:spcBef>
+              <a:spcAft>
+                <a:spcPts val="0"/>
+              </a:spcAft>
+              <a:buNone/>
+            </a:pPr>
+            <a:endParaRPr dirty="0">
+              <a:latin typeface="Consolas"/>
+              <a:ea typeface="Consolas"/>
+              <a:cs typeface="Consolas"/>
+              <a:sym typeface="Consolas"/>
+            </a:endParaRPr>
+          </a:p>
+        </p:txBody>
+      </p:sp>
+    </p:spTree>
+    <p:extLst>
+      <p:ext uri="{BB962C8B-B14F-4D97-AF65-F5344CB8AC3E}">
+        <p14:creationId xmlns:p14="http://schemas.microsoft.com/office/powerpoint/2010/main" val="3611577896"/>
+      </p:ext>
+    </p:extLst>
+  </p:cSld>
+  <p:clrMapOvr>
+    <a:masterClrMapping/>
+  </p:clrMapOvr>
+</p:sld>
+</file>
+
 <file path=ppt/slides/slide3.xml><?xml version="1.0" encoding="utf-8"?>
 <p:sld xmlns:a="http://schemas.openxmlformats.org/drawingml/2006/main" xmlns:r="http://schemas.openxmlformats.org/officeDocument/2006/relationships" xmlns:p="http://schemas.openxmlformats.org/presentationml/2006/main">
   <p:cSld>

</xml_diff>